<commit_message>
Update chapter 05 - MEA - Makers a new approach to Electronic Applications
</commit_message>
<xml_diff>
--- a/04 - JavaScript/slides.pptx
+++ b/04 - JavaScript/slides.pptx
@@ -2,58 +2,58 @@
 <file path=ppt/presentation.xml><?xml version="1.0" encoding="utf-8"?>
 <p:presentation xmlns:a="http://schemas.openxmlformats.org/drawingml/2006/main" xmlns:r="http://schemas.openxmlformats.org/officeDocument/2006/relationships" xmlns:p="http://schemas.openxmlformats.org/presentationml/2006/main" strictFirstAndLastChars="0" embedTrueTypeFonts="1" saveSubsetFonts="1" autoCompressPictures="0">
   <p:sldMasterIdLst>
-    <p:sldMasterId id="2147483659" r:id="rId1"/>
+    <p:sldMasterId id="2147483659" r:id="rId4"/>
   </p:sldMasterIdLst>
   <p:notesMasterIdLst>
-    <p:notesMasterId r:id="rId31"/>
+    <p:notesMasterId r:id="rId34"/>
   </p:notesMasterIdLst>
   <p:sldIdLst>
-    <p:sldId id="256" r:id="rId2"/>
-    <p:sldId id="257" r:id="rId3"/>
-    <p:sldId id="258" r:id="rId4"/>
-    <p:sldId id="276" r:id="rId5"/>
-    <p:sldId id="259" r:id="rId6"/>
-    <p:sldId id="260" r:id="rId7"/>
-    <p:sldId id="261" r:id="rId8"/>
-    <p:sldId id="262" r:id="rId9"/>
-    <p:sldId id="263" r:id="rId10"/>
-    <p:sldId id="264" r:id="rId11"/>
-    <p:sldId id="280" r:id="rId12"/>
-    <p:sldId id="281" r:id="rId13"/>
-    <p:sldId id="265" r:id="rId14"/>
-    <p:sldId id="282" r:id="rId15"/>
-    <p:sldId id="266" r:id="rId16"/>
-    <p:sldId id="267" r:id="rId17"/>
-    <p:sldId id="275" r:id="rId18"/>
-    <p:sldId id="283" r:id="rId19"/>
-    <p:sldId id="268" r:id="rId20"/>
-    <p:sldId id="269" r:id="rId21"/>
-    <p:sldId id="271" r:id="rId22"/>
-    <p:sldId id="272" r:id="rId23"/>
-    <p:sldId id="273" r:id="rId24"/>
-    <p:sldId id="277" r:id="rId25"/>
-    <p:sldId id="284" r:id="rId26"/>
-    <p:sldId id="285" r:id="rId27"/>
-    <p:sldId id="278" r:id="rId28"/>
-    <p:sldId id="286" r:id="rId29"/>
-    <p:sldId id="279" r:id="rId30"/>
+    <p:sldId id="256" r:id="rId5"/>
+    <p:sldId id="257" r:id="rId6"/>
+    <p:sldId id="258" r:id="rId7"/>
+    <p:sldId id="276" r:id="rId8"/>
+    <p:sldId id="259" r:id="rId9"/>
+    <p:sldId id="260" r:id="rId10"/>
+    <p:sldId id="261" r:id="rId11"/>
+    <p:sldId id="262" r:id="rId12"/>
+    <p:sldId id="263" r:id="rId13"/>
+    <p:sldId id="264" r:id="rId14"/>
+    <p:sldId id="280" r:id="rId15"/>
+    <p:sldId id="281" r:id="rId16"/>
+    <p:sldId id="265" r:id="rId17"/>
+    <p:sldId id="282" r:id="rId18"/>
+    <p:sldId id="266" r:id="rId19"/>
+    <p:sldId id="267" r:id="rId20"/>
+    <p:sldId id="275" r:id="rId21"/>
+    <p:sldId id="283" r:id="rId22"/>
+    <p:sldId id="268" r:id="rId23"/>
+    <p:sldId id="269" r:id="rId24"/>
+    <p:sldId id="271" r:id="rId25"/>
+    <p:sldId id="272" r:id="rId26"/>
+    <p:sldId id="273" r:id="rId27"/>
+    <p:sldId id="277" r:id="rId28"/>
+    <p:sldId id="284" r:id="rId29"/>
+    <p:sldId id="285" r:id="rId30"/>
+    <p:sldId id="278" r:id="rId31"/>
+    <p:sldId id="286" r:id="rId32"/>
+    <p:sldId id="279" r:id="rId33"/>
   </p:sldIdLst>
   <p:sldSz cx="9144000" cy="6858000" type="screen4x3"/>
   <p:notesSz cx="6858000" cy="9144000"/>
   <p:embeddedFontLst>
     <p:embeddedFont>
       <p:font typeface="Economica" panose="02000506040000020004" pitchFamily="2" charset="77"/>
-      <p:regular r:id="rId32"/>
-      <p:bold r:id="rId33"/>
-      <p:italic r:id="rId34"/>
-      <p:boldItalic r:id="rId35"/>
+      <p:regular r:id="rId35"/>
+      <p:bold r:id="rId36"/>
+      <p:italic r:id="rId37"/>
+      <p:boldItalic r:id="rId38"/>
     </p:embeddedFont>
     <p:embeddedFont>
       <p:font typeface="Open Sans" panose="020B0606030504020204" pitchFamily="34" charset="0"/>
-      <p:regular r:id="rId36"/>
-      <p:bold r:id="rId37"/>
-      <p:italic r:id="rId38"/>
-      <p:boldItalic r:id="rId39"/>
+      <p:regular r:id="rId39"/>
+      <p:bold r:id="rId40"/>
+      <p:italic r:id="rId41"/>
+      <p:boldItalic r:id="rId42"/>
     </p:embeddedFont>
   </p:embeddedFontLst>
   <p:defaultTextStyle>
@@ -296,7 +296,7 @@
 <file path=ppt/revisionInfo.xml><?xml version="1.0" encoding="utf-8"?>
 <p1510:revInfo xmlns:a="http://schemas.openxmlformats.org/drawingml/2006/main" xmlns:r="http://schemas.openxmlformats.org/officeDocument/2006/relationships" xmlns:p1510="http://schemas.microsoft.com/office/powerpoint/2015/10/main">
   <p1510:revLst>
-    <p1510:client id="{A7A4F2B9-5ABC-2443-A920-7D4C1CF4E6C8}" v="2" dt="2023-03-16T14:20:41.577"/>
+    <p1510:client id="{6721FC2B-0410-CC4B-876D-7D10CC589F85}" v="3" dt="2026-04-15T05:54:29.597"/>
   </p1510:revLst>
 </p1510:revInfo>
 </file>
@@ -304,318 +304,50 @@
 <file path=ppt/changesInfos/changesInfo1.xml><?xml version="1.0" encoding="utf-8"?>
 <pc:chgInfo xmlns:a="http://schemas.openxmlformats.org/drawingml/2006/main" xmlns:r="http://schemas.openxmlformats.org/officeDocument/2006/relationships" xmlns:ac="http://schemas.microsoft.com/office/drawing/2013/main/command" xmlns:pc="http://schemas.microsoft.com/office/powerpoint/2013/main/command">
   <pc:docChgLst>
-    <pc:chgData name="Riccardo Berta" userId="c8694f89-bba4-4576-b0a8-456619ca5a8c" providerId="ADAL" clId="{A7A4F2B9-5ABC-2443-A920-7D4C1CF4E6C8}"/>
-    <pc:docChg chg="modSld sldOrd">
-      <pc:chgData name="Riccardo Berta" userId="c8694f89-bba4-4576-b0a8-456619ca5a8c" providerId="ADAL" clId="{A7A4F2B9-5ABC-2443-A920-7D4C1CF4E6C8}" dt="2023-03-22T11:37:46.474" v="10" actId="20578"/>
+    <pc:chgData name="Riccardo Berta" userId="c8694f89-bba4-4576-b0a8-456619ca5a8c" providerId="ADAL" clId="{FDDBFC5A-5EA9-5330-BEB8-433D7E3B4C4E}"/>
+    <pc:docChg chg="custSel addSld delSld modSld">
+      <pc:chgData name="Riccardo Berta" userId="c8694f89-bba4-4576-b0a8-456619ca5a8c" providerId="ADAL" clId="{FDDBFC5A-5EA9-5330-BEB8-433D7E3B4C4E}" dt="2026-04-15T13:37:26.050" v="92" actId="2696"/>
       <pc:docMkLst>
         <pc:docMk/>
       </pc:docMkLst>
       <pc:sldChg chg="modSp mod">
-        <pc:chgData name="Riccardo Berta" userId="c8694f89-bba4-4576-b0a8-456619ca5a8c" providerId="ADAL" clId="{A7A4F2B9-5ABC-2443-A920-7D4C1CF4E6C8}" dt="2023-03-16T13:49:54.749" v="0" actId="1076"/>
+        <pc:chgData name="Riccardo Berta" userId="c8694f89-bba4-4576-b0a8-456619ca5a8c" providerId="ADAL" clId="{FDDBFC5A-5EA9-5330-BEB8-433D7E3B4C4E}" dt="2026-04-10T05:30:10.280" v="3" actId="20577"/>
         <pc:sldMkLst>
           <pc:docMk/>
-          <pc:sldMk cId="0" sldId="257"/>
-        </pc:sldMkLst>
-        <pc:picChg chg="mod">
-          <ac:chgData name="Riccardo Berta" userId="c8694f89-bba4-4576-b0a8-456619ca5a8c" providerId="ADAL" clId="{A7A4F2B9-5ABC-2443-A920-7D4C1CF4E6C8}" dt="2023-03-16T13:49:54.749" v="0" actId="1076"/>
-          <ac:picMkLst>
-            <pc:docMk/>
-            <pc:sldMk cId="0" sldId="257"/>
-            <ac:picMk id="87" creationId="{00000000-0000-0000-0000-000000000000}"/>
-          </ac:picMkLst>
-        </pc:picChg>
-      </pc:sldChg>
-      <pc:sldChg chg="modSp">
-        <pc:chgData name="Riccardo Berta" userId="c8694f89-bba4-4576-b0a8-456619ca5a8c" providerId="ADAL" clId="{A7A4F2B9-5ABC-2443-A920-7D4C1CF4E6C8}" dt="2023-03-16T14:20:38.129" v="1" actId="20578"/>
-        <pc:sldMkLst>
-          <pc:docMk/>
-          <pc:sldMk cId="0" sldId="262"/>
+          <pc:sldMk cId="0" sldId="263"/>
         </pc:sldMkLst>
         <pc:spChg chg="mod">
-          <ac:chgData name="Riccardo Berta" userId="c8694f89-bba4-4576-b0a8-456619ca5a8c" providerId="ADAL" clId="{A7A4F2B9-5ABC-2443-A920-7D4C1CF4E6C8}" dt="2023-03-16T14:20:38.129" v="1" actId="20578"/>
+          <ac:chgData name="Riccardo Berta" userId="c8694f89-bba4-4576-b0a8-456619ca5a8c" providerId="ADAL" clId="{FDDBFC5A-5EA9-5330-BEB8-433D7E3B4C4E}" dt="2026-04-10T05:30:10.280" v="3" actId="20577"/>
           <ac:spMkLst>
             <pc:docMk/>
-            <pc:sldMk cId="0" sldId="262"/>
-            <ac:spMk id="122" creationId="{00000000-0000-0000-0000-000000000000}"/>
+            <pc:sldMk cId="0" sldId="263"/>
+            <ac:spMk id="128" creationId="{00000000-0000-0000-0000-000000000000}"/>
           </ac:spMkLst>
         </pc:spChg>
       </pc:sldChg>
       <pc:sldChg chg="modSp mod">
-        <pc:chgData name="Riccardo Berta" userId="c8694f89-bba4-4576-b0a8-456619ca5a8c" providerId="ADAL" clId="{A7A4F2B9-5ABC-2443-A920-7D4C1CF4E6C8}" dt="2023-03-22T11:34:54.689" v="9" actId="20577"/>
+        <pc:chgData name="Riccardo Berta" userId="c8694f89-bba4-4576-b0a8-456619ca5a8c" providerId="ADAL" clId="{FDDBFC5A-5EA9-5330-BEB8-433D7E3B4C4E}" dt="2026-04-15T12:38:09.332" v="88" actId="20577"/>
         <pc:sldMkLst>
           <pc:docMk/>
-          <pc:sldMk cId="0" sldId="270"/>
+          <pc:sldMk cId="0" sldId="265"/>
         </pc:sldMkLst>
         <pc:spChg chg="mod">
-          <ac:chgData name="Riccardo Berta" userId="c8694f89-bba4-4576-b0a8-456619ca5a8c" providerId="ADAL" clId="{A7A4F2B9-5ABC-2443-A920-7D4C1CF4E6C8}" dt="2023-03-22T11:34:54.689" v="9" actId="20577"/>
+          <ac:chgData name="Riccardo Berta" userId="c8694f89-bba4-4576-b0a8-456619ca5a8c" providerId="ADAL" clId="{FDDBFC5A-5EA9-5330-BEB8-433D7E3B4C4E}" dt="2026-04-15T12:38:09.332" v="88" actId="20577"/>
           <ac:spMkLst>
             <pc:docMk/>
-            <pc:sldMk cId="0" sldId="270"/>
-            <ac:spMk id="179" creationId="{00000000-0000-0000-0000-000000000000}"/>
+            <pc:sldMk cId="0" sldId="265"/>
+            <ac:spMk id="142" creationId="{00000000-0000-0000-0000-000000000000}"/>
           </ac:spMkLst>
         </pc:spChg>
       </pc:sldChg>
-      <pc:sldChg chg="ord">
-        <pc:chgData name="Riccardo Berta" userId="c8694f89-bba4-4576-b0a8-456619ca5a8c" providerId="ADAL" clId="{A7A4F2B9-5ABC-2443-A920-7D4C1CF4E6C8}" dt="2023-03-22T11:37:46.474" v="10" actId="20578"/>
-        <pc:sldMkLst>
-          <pc:docMk/>
-          <pc:sldMk cId="0" sldId="274"/>
-        </pc:sldMkLst>
-      </pc:sldChg>
-      <pc:sldChg chg="ord">
-        <pc:chgData name="Riccardo Berta" userId="c8694f89-bba4-4576-b0a8-456619ca5a8c" providerId="ADAL" clId="{A7A4F2B9-5ABC-2443-A920-7D4C1CF4E6C8}" dt="2023-03-22T11:30:07.725" v="3" actId="20578"/>
-        <pc:sldMkLst>
-          <pc:docMk/>
-          <pc:sldMk cId="0" sldId="277"/>
-        </pc:sldMkLst>
-      </pc:sldChg>
-    </pc:docChg>
-  </pc:docChgLst>
-  <pc:docChgLst>
-    <pc:chgData name="Riccardo Berta" userId="c8694f89-bba4-4576-b0a8-456619ca5a8c" providerId="ADAL" clId="{D42FCCBE-6F56-A641-874C-E03919B67028}"/>
-    <pc:docChg chg="undo custSel modSld">
-      <pc:chgData name="Riccardo Berta" userId="c8694f89-bba4-4576-b0a8-456619ca5a8c" providerId="ADAL" clId="{D42FCCBE-6F56-A641-874C-E03919B67028}" dt="2022-03-04T07:14:55.209" v="5" actId="1076"/>
-      <pc:docMkLst>
-        <pc:docMk/>
-      </pc:docMkLst>
-      <pc:sldChg chg="modSp">
-        <pc:chgData name="Riccardo Berta" userId="c8694f89-bba4-4576-b0a8-456619ca5a8c" providerId="ADAL" clId="{D42FCCBE-6F56-A641-874C-E03919B67028}" dt="2022-03-04T07:14:55.209" v="5" actId="1076"/>
-        <pc:sldMkLst>
-          <pc:docMk/>
-          <pc:sldMk cId="0" sldId="258"/>
-        </pc:sldMkLst>
-        <pc:spChg chg="mod">
-          <ac:chgData name="Riccardo Berta" userId="c8694f89-bba4-4576-b0a8-456619ca5a8c" providerId="ADAL" clId="{D42FCCBE-6F56-A641-874C-E03919B67028}" dt="2022-03-04T07:14:55.209" v="5" actId="1076"/>
-          <ac:spMkLst>
-            <pc:docMk/>
-            <pc:sldMk cId="0" sldId="258"/>
-            <ac:spMk id="93" creationId="{00000000-0000-0000-0000-000000000000}"/>
-          </ac:spMkLst>
-        </pc:spChg>
-      </pc:sldChg>
-    </pc:docChg>
-  </pc:docChgLst>
-  <pc:docChgLst>
-    <pc:chgData name="Riccardo Berta" userId="c8694f89-bba4-4576-b0a8-456619ca5a8c" providerId="ADAL" clId="{06DF791A-ABEB-DB44-A5FA-301FD99EBD63}"/>
-    <pc:docChg chg="undo custSel modSld">
-      <pc:chgData name="Riccardo Berta" userId="c8694f89-bba4-4576-b0a8-456619ca5a8c" providerId="ADAL" clId="{06DF791A-ABEB-DB44-A5FA-301FD99EBD63}" dt="2022-03-09T09:42:37.745" v="94" actId="20577"/>
-      <pc:docMkLst>
-        <pc:docMk/>
-      </pc:docMkLst>
-      <pc:sldChg chg="modSp mod">
-        <pc:chgData name="Riccardo Berta" userId="c8694f89-bba4-4576-b0a8-456619ca5a8c" providerId="ADAL" clId="{06DF791A-ABEB-DB44-A5FA-301FD99EBD63}" dt="2022-03-04T12:00:03.447" v="4"/>
-        <pc:sldMkLst>
-          <pc:docMk/>
-          <pc:sldMk cId="0" sldId="257"/>
-        </pc:sldMkLst>
-        <pc:picChg chg="mod">
-          <ac:chgData name="Riccardo Berta" userId="c8694f89-bba4-4576-b0a8-456619ca5a8c" providerId="ADAL" clId="{06DF791A-ABEB-DB44-A5FA-301FD99EBD63}" dt="2022-03-04T11:56:11.498" v="1"/>
-          <ac:picMkLst>
-            <pc:docMk/>
-            <pc:sldMk cId="0" sldId="257"/>
-            <ac:picMk id="85" creationId="{00000000-0000-0000-0000-000000000000}"/>
-          </ac:picMkLst>
-        </pc:picChg>
-        <pc:picChg chg="mod">
-          <ac:chgData name="Riccardo Berta" userId="c8694f89-bba4-4576-b0a8-456619ca5a8c" providerId="ADAL" clId="{06DF791A-ABEB-DB44-A5FA-301FD99EBD63}" dt="2022-03-04T11:58:25.867" v="3"/>
-          <ac:picMkLst>
-            <pc:docMk/>
-            <pc:sldMk cId="0" sldId="257"/>
-            <ac:picMk id="86" creationId="{00000000-0000-0000-0000-000000000000}"/>
-          </ac:picMkLst>
-        </pc:picChg>
-        <pc:picChg chg="mod">
-          <ac:chgData name="Riccardo Berta" userId="c8694f89-bba4-4576-b0a8-456619ca5a8c" providerId="ADAL" clId="{06DF791A-ABEB-DB44-A5FA-301FD99EBD63}" dt="2022-03-04T12:00:03.447" v="4"/>
-          <ac:picMkLst>
-            <pc:docMk/>
-            <pc:sldMk cId="0" sldId="257"/>
-            <ac:picMk id="87" creationId="{00000000-0000-0000-0000-000000000000}"/>
-          </ac:picMkLst>
-        </pc:picChg>
-      </pc:sldChg>
-      <pc:sldChg chg="modSp mod">
-        <pc:chgData name="Riccardo Berta" userId="c8694f89-bba4-4576-b0a8-456619ca5a8c" providerId="ADAL" clId="{06DF791A-ABEB-DB44-A5FA-301FD99EBD63}" dt="2022-03-04T12:00:51.005" v="7"/>
-        <pc:sldMkLst>
-          <pc:docMk/>
-          <pc:sldMk cId="0" sldId="258"/>
-        </pc:sldMkLst>
-        <pc:picChg chg="mod">
-          <ac:chgData name="Riccardo Berta" userId="c8694f89-bba4-4576-b0a8-456619ca5a8c" providerId="ADAL" clId="{06DF791A-ABEB-DB44-A5FA-301FD99EBD63}" dt="2022-03-04T12:00:31.191" v="5"/>
-          <ac:picMkLst>
-            <pc:docMk/>
-            <pc:sldMk cId="0" sldId="258"/>
-            <ac:picMk id="94" creationId="{00000000-0000-0000-0000-000000000000}"/>
-          </ac:picMkLst>
-        </pc:picChg>
-        <pc:picChg chg="mod">
-          <ac:chgData name="Riccardo Berta" userId="c8694f89-bba4-4576-b0a8-456619ca5a8c" providerId="ADAL" clId="{06DF791A-ABEB-DB44-A5FA-301FD99EBD63}" dt="2022-03-04T12:00:51.005" v="7"/>
-          <ac:picMkLst>
-            <pc:docMk/>
-            <pc:sldMk cId="0" sldId="258"/>
-            <ac:picMk id="95" creationId="{00000000-0000-0000-0000-000000000000}"/>
-          </ac:picMkLst>
-        </pc:picChg>
-      </pc:sldChg>
-      <pc:sldChg chg="modSp">
-        <pc:chgData name="Riccardo Berta" userId="c8694f89-bba4-4576-b0a8-456619ca5a8c" providerId="ADAL" clId="{06DF791A-ABEB-DB44-A5FA-301FD99EBD63}" dt="2022-03-04T12:01:07.267" v="8"/>
-        <pc:sldMkLst>
-          <pc:docMk/>
-          <pc:sldMk cId="0" sldId="259"/>
-        </pc:sldMkLst>
-        <pc:picChg chg="mod">
-          <ac:chgData name="Riccardo Berta" userId="c8694f89-bba4-4576-b0a8-456619ca5a8c" providerId="ADAL" clId="{06DF791A-ABEB-DB44-A5FA-301FD99EBD63}" dt="2022-03-04T12:01:07.267" v="8"/>
-          <ac:picMkLst>
-            <pc:docMk/>
-            <pc:sldMk cId="0" sldId="259"/>
-            <ac:picMk id="102" creationId="{00000000-0000-0000-0000-000000000000}"/>
-          </ac:picMkLst>
-        </pc:picChg>
-      </pc:sldChg>
-      <pc:sldChg chg="modSp">
-        <pc:chgData name="Riccardo Berta" userId="c8694f89-bba4-4576-b0a8-456619ca5a8c" providerId="ADAL" clId="{06DF791A-ABEB-DB44-A5FA-301FD99EBD63}" dt="2022-03-04T12:01:23.487" v="9"/>
-        <pc:sldMkLst>
-          <pc:docMk/>
-          <pc:sldMk cId="0" sldId="260"/>
-        </pc:sldMkLst>
-        <pc:picChg chg="mod">
-          <ac:chgData name="Riccardo Berta" userId="c8694f89-bba4-4576-b0a8-456619ca5a8c" providerId="ADAL" clId="{06DF791A-ABEB-DB44-A5FA-301FD99EBD63}" dt="2022-03-04T12:01:23.487" v="9"/>
-          <ac:picMkLst>
-            <pc:docMk/>
-            <pc:sldMk cId="0" sldId="260"/>
-            <ac:picMk id="109" creationId="{00000000-0000-0000-0000-000000000000}"/>
-          </ac:picMkLst>
-        </pc:picChg>
-      </pc:sldChg>
-      <pc:sldChg chg="modSp">
-        <pc:chgData name="Riccardo Berta" userId="c8694f89-bba4-4576-b0a8-456619ca5a8c" providerId="ADAL" clId="{06DF791A-ABEB-DB44-A5FA-301FD99EBD63}" dt="2022-03-04T12:01:44.166" v="10"/>
-        <pc:sldMkLst>
-          <pc:docMk/>
-          <pc:sldMk cId="0" sldId="261"/>
-        </pc:sldMkLst>
-        <pc:picChg chg="mod">
-          <ac:chgData name="Riccardo Berta" userId="c8694f89-bba4-4576-b0a8-456619ca5a8c" providerId="ADAL" clId="{06DF791A-ABEB-DB44-A5FA-301FD99EBD63}" dt="2022-03-04T12:01:44.166" v="10"/>
-          <ac:picMkLst>
-            <pc:docMk/>
-            <pc:sldMk cId="0" sldId="261"/>
-            <ac:picMk id="116" creationId="{00000000-0000-0000-0000-000000000000}"/>
-          </ac:picMkLst>
-        </pc:picChg>
-      </pc:sldChg>
-      <pc:sldChg chg="modSp mod">
-        <pc:chgData name="Riccardo Berta" userId="c8694f89-bba4-4576-b0a8-456619ca5a8c" providerId="ADAL" clId="{06DF791A-ABEB-DB44-A5FA-301FD99EBD63}" dt="2022-03-04T14:50:48.586" v="34" actId="20577"/>
-        <pc:sldMkLst>
-          <pc:docMk/>
-          <pc:sldMk cId="0" sldId="262"/>
-        </pc:sldMkLst>
-        <pc:spChg chg="mod">
-          <ac:chgData name="Riccardo Berta" userId="c8694f89-bba4-4576-b0a8-456619ca5a8c" providerId="ADAL" clId="{06DF791A-ABEB-DB44-A5FA-301FD99EBD63}" dt="2022-03-04T14:50:48.586" v="34" actId="20577"/>
-          <ac:spMkLst>
-            <pc:docMk/>
-            <pc:sldMk cId="0" sldId="262"/>
-            <ac:spMk id="122" creationId="{00000000-0000-0000-0000-000000000000}"/>
-          </ac:spMkLst>
-        </pc:spChg>
-      </pc:sldChg>
-      <pc:sldChg chg="modSp">
-        <pc:chgData name="Riccardo Berta" userId="c8694f89-bba4-4576-b0a8-456619ca5a8c" providerId="ADAL" clId="{06DF791A-ABEB-DB44-A5FA-301FD99EBD63}" dt="2022-03-04T12:02:14.097" v="11"/>
-        <pc:sldMkLst>
-          <pc:docMk/>
-          <pc:sldMk cId="0" sldId="263"/>
-        </pc:sldMkLst>
-        <pc:picChg chg="mod">
-          <ac:chgData name="Riccardo Berta" userId="c8694f89-bba4-4576-b0a8-456619ca5a8c" providerId="ADAL" clId="{06DF791A-ABEB-DB44-A5FA-301FD99EBD63}" dt="2022-03-04T12:02:14.097" v="11"/>
-          <ac:picMkLst>
-            <pc:docMk/>
-            <pc:sldMk cId="0" sldId="263"/>
-            <ac:picMk id="129" creationId="{00000000-0000-0000-0000-000000000000}"/>
-          </ac:picMkLst>
-        </pc:picChg>
-      </pc:sldChg>
-      <pc:sldChg chg="modSp">
-        <pc:chgData name="Riccardo Berta" userId="c8694f89-bba4-4576-b0a8-456619ca5a8c" providerId="ADAL" clId="{06DF791A-ABEB-DB44-A5FA-301FD99EBD63}" dt="2022-03-04T12:02:37.449" v="12"/>
-        <pc:sldMkLst>
-          <pc:docMk/>
-          <pc:sldMk cId="0" sldId="264"/>
-        </pc:sldMkLst>
-        <pc:picChg chg="mod">
-          <ac:chgData name="Riccardo Berta" userId="c8694f89-bba4-4576-b0a8-456619ca5a8c" providerId="ADAL" clId="{06DF791A-ABEB-DB44-A5FA-301FD99EBD63}" dt="2022-03-04T12:02:37.449" v="12"/>
-          <ac:picMkLst>
-            <pc:docMk/>
-            <pc:sldMk cId="0" sldId="264"/>
-            <ac:picMk id="136" creationId="{00000000-0000-0000-0000-000000000000}"/>
-          </ac:picMkLst>
-        </pc:picChg>
-      </pc:sldChg>
-      <pc:sldChg chg="modSp mod">
-        <pc:chgData name="Riccardo Berta" userId="c8694f89-bba4-4576-b0a8-456619ca5a8c" providerId="ADAL" clId="{06DF791A-ABEB-DB44-A5FA-301FD99EBD63}" dt="2022-03-04T15:20:09.961" v="60" actId="20577"/>
-        <pc:sldMkLst>
-          <pc:docMk/>
-          <pc:sldMk cId="0" sldId="266"/>
-        </pc:sldMkLst>
-        <pc:spChg chg="mod">
-          <ac:chgData name="Riccardo Berta" userId="c8694f89-bba4-4576-b0a8-456619ca5a8c" providerId="ADAL" clId="{06DF791A-ABEB-DB44-A5FA-301FD99EBD63}" dt="2022-03-04T15:20:09.961" v="60" actId="20577"/>
-          <ac:spMkLst>
-            <pc:docMk/>
-            <pc:sldMk cId="0" sldId="266"/>
-            <ac:spMk id="148" creationId="{00000000-0000-0000-0000-000000000000}"/>
-          </ac:spMkLst>
-        </pc:spChg>
-        <pc:picChg chg="mod">
-          <ac:chgData name="Riccardo Berta" userId="c8694f89-bba4-4576-b0a8-456619ca5a8c" providerId="ADAL" clId="{06DF791A-ABEB-DB44-A5FA-301FD99EBD63}" dt="2022-03-04T12:03:00.211" v="13"/>
-          <ac:picMkLst>
-            <pc:docMk/>
-            <pc:sldMk cId="0" sldId="266"/>
-            <ac:picMk id="149" creationId="{00000000-0000-0000-0000-000000000000}"/>
-          </ac:picMkLst>
-        </pc:picChg>
-      </pc:sldChg>
-      <pc:sldChg chg="modSp mod">
-        <pc:chgData name="Riccardo Berta" userId="c8694f89-bba4-4576-b0a8-456619ca5a8c" providerId="ADAL" clId="{06DF791A-ABEB-DB44-A5FA-301FD99EBD63}" dt="2022-03-04T15:31:16.427" v="64" actId="20577"/>
-        <pc:sldMkLst>
-          <pc:docMk/>
-          <pc:sldMk cId="0" sldId="267"/>
-        </pc:sldMkLst>
-        <pc:spChg chg="mod">
-          <ac:chgData name="Riccardo Berta" userId="c8694f89-bba4-4576-b0a8-456619ca5a8c" providerId="ADAL" clId="{06DF791A-ABEB-DB44-A5FA-301FD99EBD63}" dt="2022-03-04T15:31:16.427" v="64" actId="20577"/>
-          <ac:spMkLst>
-            <pc:docMk/>
-            <pc:sldMk cId="0" sldId="267"/>
-            <ac:spMk id="155" creationId="{00000000-0000-0000-0000-000000000000}"/>
-          </ac:spMkLst>
-        </pc:spChg>
-        <pc:picChg chg="mod">
-          <ac:chgData name="Riccardo Berta" userId="c8694f89-bba4-4576-b0a8-456619ca5a8c" providerId="ADAL" clId="{06DF791A-ABEB-DB44-A5FA-301FD99EBD63}" dt="2022-03-04T12:03:26.333" v="14"/>
-          <ac:picMkLst>
-            <pc:docMk/>
-            <pc:sldMk cId="0" sldId="267"/>
-            <ac:picMk id="156" creationId="{00000000-0000-0000-0000-000000000000}"/>
-          </ac:picMkLst>
-        </pc:picChg>
-      </pc:sldChg>
-      <pc:sldChg chg="modSp mod">
-        <pc:chgData name="Riccardo Berta" userId="c8694f89-bba4-4576-b0a8-456619ca5a8c" providerId="ADAL" clId="{06DF791A-ABEB-DB44-A5FA-301FD99EBD63}" dt="2022-03-04T15:32:54.976" v="65" actId="15"/>
+      <pc:sldChg chg="delSp mod">
+        <pc:chgData name="Riccardo Berta" userId="c8694f89-bba4-4576-b0a8-456619ca5a8c" providerId="ADAL" clId="{FDDBFC5A-5EA9-5330-BEB8-433D7E3B4C4E}" dt="2026-04-15T05:44:29.034" v="14" actId="478"/>
         <pc:sldMkLst>
           <pc:docMk/>
           <pc:sldMk cId="0" sldId="268"/>
         </pc:sldMkLst>
-        <pc:spChg chg="mod">
-          <ac:chgData name="Riccardo Berta" userId="c8694f89-bba4-4576-b0a8-456619ca5a8c" providerId="ADAL" clId="{06DF791A-ABEB-DB44-A5FA-301FD99EBD63}" dt="2022-03-04T15:32:54.976" v="65" actId="15"/>
-          <ac:spMkLst>
-            <pc:docMk/>
-            <pc:sldMk cId="0" sldId="268"/>
-            <ac:spMk id="162" creationId="{00000000-0000-0000-0000-000000000000}"/>
-          </ac:spMkLst>
-        </pc:spChg>
-        <pc:picChg chg="mod">
-          <ac:chgData name="Riccardo Berta" userId="c8694f89-bba4-4576-b0a8-456619ca5a8c" providerId="ADAL" clId="{06DF791A-ABEB-DB44-A5FA-301FD99EBD63}" dt="2022-03-04T12:03:43.055" v="15"/>
-          <ac:picMkLst>
-            <pc:docMk/>
-            <pc:sldMk cId="0" sldId="268"/>
-            <ac:picMk id="163" creationId="{00000000-0000-0000-0000-000000000000}"/>
-          </ac:picMkLst>
-        </pc:picChg>
-        <pc:picChg chg="mod">
-          <ac:chgData name="Riccardo Berta" userId="c8694f89-bba4-4576-b0a8-456619ca5a8c" providerId="ADAL" clId="{06DF791A-ABEB-DB44-A5FA-301FD99EBD63}" dt="2022-03-04T12:03:58.966" v="16"/>
+        <pc:picChg chg="del">
+          <ac:chgData name="Riccardo Berta" userId="c8694f89-bba4-4576-b0a8-456619ca5a8c" providerId="ADAL" clId="{FDDBFC5A-5EA9-5330-BEB8-433D7E3B4C4E}" dt="2026-04-15T05:44:29.034" v="14" actId="478"/>
           <ac:picMkLst>
             <pc:docMk/>
             <pc:sldMk cId="0" sldId="268"/>
@@ -623,38 +355,22 @@
           </ac:picMkLst>
         </pc:picChg>
       </pc:sldChg>
-      <pc:sldChg chg="modSp mod">
-        <pc:chgData name="Riccardo Berta" userId="c8694f89-bba4-4576-b0a8-456619ca5a8c" providerId="ADAL" clId="{06DF791A-ABEB-DB44-A5FA-301FD99EBD63}" dt="2022-03-09T08:53:35.740" v="83" actId="20577"/>
+      <pc:sldChg chg="delSp modSp mod">
+        <pc:chgData name="Riccardo Berta" userId="c8694f89-bba4-4576-b0a8-456619ca5a8c" providerId="ADAL" clId="{FDDBFC5A-5EA9-5330-BEB8-433D7E3B4C4E}" dt="2026-04-15T05:48:54.187" v="31" actId="20577"/>
         <pc:sldMkLst>
           <pc:docMk/>
           <pc:sldMk cId="0" sldId="269"/>
         </pc:sldMkLst>
         <pc:spChg chg="mod">
-          <ac:chgData name="Riccardo Berta" userId="c8694f89-bba4-4576-b0a8-456619ca5a8c" providerId="ADAL" clId="{06DF791A-ABEB-DB44-A5FA-301FD99EBD63}" dt="2022-03-09T08:53:35.740" v="83" actId="20577"/>
+          <ac:chgData name="Riccardo Berta" userId="c8694f89-bba4-4576-b0a8-456619ca5a8c" providerId="ADAL" clId="{FDDBFC5A-5EA9-5330-BEB8-433D7E3B4C4E}" dt="2026-04-15T05:48:54.187" v="31" actId="20577"/>
           <ac:spMkLst>
             <pc:docMk/>
             <pc:sldMk cId="0" sldId="269"/>
             <ac:spMk id="170" creationId="{00000000-0000-0000-0000-000000000000}"/>
           </ac:spMkLst>
         </pc:spChg>
-        <pc:picChg chg="mod">
-          <ac:chgData name="Riccardo Berta" userId="c8694f89-bba4-4576-b0a8-456619ca5a8c" providerId="ADAL" clId="{06DF791A-ABEB-DB44-A5FA-301FD99EBD63}" dt="2022-03-04T12:04:18.357" v="17"/>
-          <ac:picMkLst>
-            <pc:docMk/>
-            <pc:sldMk cId="0" sldId="269"/>
-            <ac:picMk id="171" creationId="{00000000-0000-0000-0000-000000000000}"/>
-          </ac:picMkLst>
-        </pc:picChg>
-        <pc:picChg chg="mod">
-          <ac:chgData name="Riccardo Berta" userId="c8694f89-bba4-4576-b0a8-456619ca5a8c" providerId="ADAL" clId="{06DF791A-ABEB-DB44-A5FA-301FD99EBD63}" dt="2022-03-04T12:05:02.517" v="24" actId="1076"/>
-          <ac:picMkLst>
-            <pc:docMk/>
-            <pc:sldMk cId="0" sldId="269"/>
-            <ac:picMk id="172" creationId="{00000000-0000-0000-0000-000000000000}"/>
-          </ac:picMkLst>
-        </pc:picChg>
-        <pc:picChg chg="mod">
-          <ac:chgData name="Riccardo Berta" userId="c8694f89-bba4-4576-b0a8-456619ca5a8c" providerId="ADAL" clId="{06DF791A-ABEB-DB44-A5FA-301FD99EBD63}" dt="2022-03-04T12:04:59.725" v="23"/>
+        <pc:picChg chg="del">
+          <ac:chgData name="Riccardo Berta" userId="c8694f89-bba4-4576-b0a8-456619ca5a8c" providerId="ADAL" clId="{FDDBFC5A-5EA9-5330-BEB8-433D7E3B4C4E}" dt="2026-04-15T05:45:02.473" v="15" actId="478"/>
           <ac:picMkLst>
             <pc:docMk/>
             <pc:sldMk cId="0" sldId="269"/>
@@ -662,174 +378,111 @@
           </ac:picMkLst>
         </pc:picChg>
       </pc:sldChg>
-      <pc:sldChg chg="modSp">
-        <pc:chgData name="Riccardo Berta" userId="c8694f89-bba4-4576-b0a8-456619ca5a8c" providerId="ADAL" clId="{06DF791A-ABEB-DB44-A5FA-301FD99EBD63}" dt="2022-03-04T12:05:23.333" v="25"/>
-        <pc:sldMkLst>
-          <pc:docMk/>
-          <pc:sldMk cId="0" sldId="270"/>
-        </pc:sldMkLst>
-        <pc:picChg chg="mod">
-          <ac:chgData name="Riccardo Berta" userId="c8694f89-bba4-4576-b0a8-456619ca5a8c" providerId="ADAL" clId="{06DF791A-ABEB-DB44-A5FA-301FD99EBD63}" dt="2022-03-04T12:05:23.333" v="25"/>
-          <ac:picMkLst>
-            <pc:docMk/>
-            <pc:sldMk cId="0" sldId="270"/>
-            <ac:picMk id="181" creationId="{00000000-0000-0000-0000-000000000000}"/>
-          </ac:picMkLst>
-        </pc:picChg>
-      </pc:sldChg>
-      <pc:sldChg chg="modSp mod">
-        <pc:chgData name="Riccardo Berta" userId="c8694f89-bba4-4576-b0a8-456619ca5a8c" providerId="ADAL" clId="{06DF791A-ABEB-DB44-A5FA-301FD99EBD63}" dt="2022-03-09T09:01:55.073" v="84" actId="20578"/>
-        <pc:sldMkLst>
-          <pc:docMk/>
-          <pc:sldMk cId="0" sldId="271"/>
-        </pc:sldMkLst>
-        <pc:spChg chg="mod">
-          <ac:chgData name="Riccardo Berta" userId="c8694f89-bba4-4576-b0a8-456619ca5a8c" providerId="ADAL" clId="{06DF791A-ABEB-DB44-A5FA-301FD99EBD63}" dt="2022-03-09T09:01:55.073" v="84" actId="20578"/>
-          <ac:spMkLst>
-            <pc:docMk/>
-            <pc:sldMk cId="0" sldId="271"/>
-            <ac:spMk id="187" creationId="{00000000-0000-0000-0000-000000000000}"/>
-          </ac:spMkLst>
-        </pc:spChg>
-        <pc:picChg chg="mod">
-          <ac:chgData name="Riccardo Berta" userId="c8694f89-bba4-4576-b0a8-456619ca5a8c" providerId="ADAL" clId="{06DF791A-ABEB-DB44-A5FA-301FD99EBD63}" dt="2022-03-04T12:05:43.939" v="26"/>
-          <ac:picMkLst>
-            <pc:docMk/>
-            <pc:sldMk cId="0" sldId="271"/>
-            <ac:picMk id="188" creationId="{00000000-0000-0000-0000-000000000000}"/>
-          </ac:picMkLst>
-        </pc:picChg>
-      </pc:sldChg>
-      <pc:sldChg chg="modSp mod">
-        <pc:chgData name="Riccardo Berta" userId="c8694f89-bba4-4576-b0a8-456619ca5a8c" providerId="ADAL" clId="{06DF791A-ABEB-DB44-A5FA-301FD99EBD63}" dt="2022-03-09T09:07:02.329" v="88" actId="20577"/>
-        <pc:sldMkLst>
-          <pc:docMk/>
-          <pc:sldMk cId="0" sldId="272"/>
-        </pc:sldMkLst>
-        <pc:spChg chg="mod">
-          <ac:chgData name="Riccardo Berta" userId="c8694f89-bba4-4576-b0a8-456619ca5a8c" providerId="ADAL" clId="{06DF791A-ABEB-DB44-A5FA-301FD99EBD63}" dt="2022-03-09T09:07:02.329" v="88" actId="20577"/>
-          <ac:spMkLst>
-            <pc:docMk/>
-            <pc:sldMk cId="0" sldId="272"/>
-            <ac:spMk id="194" creationId="{00000000-0000-0000-0000-000000000000}"/>
-          </ac:spMkLst>
-        </pc:spChg>
-      </pc:sldChg>
-      <pc:sldChg chg="modSp">
-        <pc:chgData name="Riccardo Berta" userId="c8694f89-bba4-4576-b0a8-456619ca5a8c" providerId="ADAL" clId="{06DF791A-ABEB-DB44-A5FA-301FD99EBD63}" dt="2022-03-04T12:06:04.974" v="27"/>
+      <pc:sldChg chg="addSp modSp mod">
+        <pc:chgData name="Riccardo Berta" userId="c8694f89-bba4-4576-b0a8-456619ca5a8c" providerId="ADAL" clId="{FDDBFC5A-5EA9-5330-BEB8-433D7E3B4C4E}" dt="2026-04-15T05:55:41.864" v="82" actId="20577"/>
         <pc:sldMkLst>
           <pc:docMk/>
           <pc:sldMk cId="0" sldId="273"/>
         </pc:sldMkLst>
-        <pc:picChg chg="mod">
-          <ac:chgData name="Riccardo Berta" userId="c8694f89-bba4-4576-b0a8-456619ca5a8c" providerId="ADAL" clId="{06DF791A-ABEB-DB44-A5FA-301FD99EBD63}" dt="2022-03-04T12:06:04.974" v="27"/>
-          <ac:picMkLst>
+        <pc:spChg chg="add mod">
+          <ac:chgData name="Riccardo Berta" userId="c8694f89-bba4-4576-b0a8-456619ca5a8c" providerId="ADAL" clId="{FDDBFC5A-5EA9-5330-BEB8-433D7E3B4C4E}" dt="2026-04-15T05:55:41.864" v="82" actId="20577"/>
+          <ac:spMkLst>
             <pc:docMk/>
             <pc:sldMk cId="0" sldId="273"/>
-            <ac:picMk id="201" creationId="{00000000-0000-0000-0000-000000000000}"/>
-          </ac:picMkLst>
-        </pc:picChg>
-      </pc:sldChg>
-      <pc:sldChg chg="addSp modSp mod modNotes">
-        <pc:chgData name="Riccardo Berta" userId="c8694f89-bba4-4576-b0a8-456619ca5a8c" providerId="ADAL" clId="{06DF791A-ABEB-DB44-A5FA-301FD99EBD63}" dt="2022-03-09T09:42:37.745" v="94" actId="20577"/>
-        <pc:sldMkLst>
-          <pc:docMk/>
-          <pc:sldMk cId="0" sldId="275"/>
-        </pc:sldMkLst>
+            <ac:spMk id="3" creationId="{ED1F4048-CBE4-17A9-ECDF-2A16E63ECE27}"/>
+          </ac:spMkLst>
+        </pc:spChg>
         <pc:spChg chg="mod">
-          <ac:chgData name="Riccardo Berta" userId="c8694f89-bba4-4576-b0a8-456619ca5a8c" providerId="ADAL" clId="{06DF791A-ABEB-DB44-A5FA-301FD99EBD63}" dt="2022-03-09T09:42:37.745" v="94" actId="20577"/>
+          <ac:chgData name="Riccardo Berta" userId="c8694f89-bba4-4576-b0a8-456619ca5a8c" providerId="ADAL" clId="{FDDBFC5A-5EA9-5330-BEB8-433D7E3B4C4E}" dt="2026-04-15T05:54:28.166" v="33"/>
           <ac:spMkLst>
             <pc:docMk/>
-            <pc:sldMk cId="0" sldId="275"/>
-            <ac:spMk id="213" creationId="{00000000-0000-0000-0000-000000000000}"/>
+            <pc:sldMk cId="0" sldId="273"/>
+            <ac:spMk id="200" creationId="{00000000-0000-0000-0000-000000000000}"/>
           </ac:spMkLst>
         </pc:spChg>
-        <pc:picChg chg="add mod">
-          <ac:chgData name="Riccardo Berta" userId="c8694f89-bba4-4576-b0a8-456619ca5a8c" providerId="ADAL" clId="{06DF791A-ABEB-DB44-A5FA-301FD99EBD63}" dt="2022-03-09T09:42:36.752" v="93" actId="14100"/>
-          <ac:picMkLst>
-            <pc:docMk/>
-            <pc:sldMk cId="0" sldId="275"/>
-            <ac:picMk id="3" creationId="{B5113C0C-9368-1A40-9C7A-3518DA9FFE96}"/>
-          </ac:picMkLst>
-        </pc:picChg>
-        <pc:picChg chg="mod">
-          <ac:chgData name="Riccardo Berta" userId="c8694f89-bba4-4576-b0a8-456619ca5a8c" providerId="ADAL" clId="{06DF791A-ABEB-DB44-A5FA-301FD99EBD63}" dt="2022-03-04T12:06:25.288" v="28"/>
-          <ac:picMkLst>
-            <pc:docMk/>
-            <pc:sldMk cId="0" sldId="275"/>
-            <ac:picMk id="214" creationId="{00000000-0000-0000-0000-000000000000}"/>
-          </ac:picMkLst>
-        </pc:picChg>
       </pc:sldChg>
-      <pc:sldChg chg="modSp">
-        <pc:chgData name="Riccardo Berta" userId="c8694f89-bba4-4576-b0a8-456619ca5a8c" providerId="ADAL" clId="{06DF791A-ABEB-DB44-A5FA-301FD99EBD63}" dt="2022-03-04T12:06:40.618" v="29"/>
+      <pc:sldChg chg="modSp mod">
+        <pc:chgData name="Riccardo Berta" userId="c8694f89-bba4-4576-b0a8-456619ca5a8c" providerId="ADAL" clId="{FDDBFC5A-5EA9-5330-BEB8-433D7E3B4C4E}" dt="2026-04-10T05:26:47.007" v="0" actId="20577"/>
         <pc:sldMkLst>
           <pc:docMk/>
           <pc:sldMk cId="0" sldId="276"/>
         </pc:sldMkLst>
-        <pc:picChg chg="mod">
-          <ac:chgData name="Riccardo Berta" userId="c8694f89-bba4-4576-b0a8-456619ca5a8c" providerId="ADAL" clId="{06DF791A-ABEB-DB44-A5FA-301FD99EBD63}" dt="2022-03-04T12:06:40.618" v="29"/>
-          <ac:picMkLst>
+        <pc:spChg chg="mod">
+          <ac:chgData name="Riccardo Berta" userId="c8694f89-bba4-4576-b0a8-456619ca5a8c" providerId="ADAL" clId="{FDDBFC5A-5EA9-5330-BEB8-433D7E3B4C4E}" dt="2026-04-10T05:26:47.007" v="0" actId="20577"/>
+          <ac:spMkLst>
             <pc:docMk/>
             <pc:sldMk cId="0" sldId="276"/>
-            <ac:picMk id="221" creationId="{00000000-0000-0000-0000-000000000000}"/>
-          </ac:picMkLst>
-        </pc:picChg>
+            <ac:spMk id="220" creationId="{00000000-0000-0000-0000-000000000000}"/>
+          </ac:spMkLst>
+        </pc:spChg>
       </pc:sldChg>
-      <pc:sldChg chg="modSp">
-        <pc:chgData name="Riccardo Berta" userId="c8694f89-bba4-4576-b0a8-456619ca5a8c" providerId="ADAL" clId="{06DF791A-ABEB-DB44-A5FA-301FD99EBD63}" dt="2022-03-04T12:07:00.413" v="30"/>
+      <pc:sldChg chg="modSp mod">
+        <pc:chgData name="Riccardo Berta" userId="c8694f89-bba4-4576-b0a8-456619ca5a8c" providerId="ADAL" clId="{FDDBFC5A-5EA9-5330-BEB8-433D7E3B4C4E}" dt="2026-04-10T05:37:51.050" v="4" actId="20577"/>
         <pc:sldMkLst>
           <pc:docMk/>
-          <pc:sldMk cId="0" sldId="277"/>
+          <pc:sldMk cId="179800585" sldId="281"/>
         </pc:sldMkLst>
-        <pc:picChg chg="mod">
-          <ac:chgData name="Riccardo Berta" userId="c8694f89-bba4-4576-b0a8-456619ca5a8c" providerId="ADAL" clId="{06DF791A-ABEB-DB44-A5FA-301FD99EBD63}" dt="2022-03-04T12:07:00.413" v="30"/>
-          <ac:picMkLst>
+        <pc:spChg chg="mod">
+          <ac:chgData name="Riccardo Berta" userId="c8694f89-bba4-4576-b0a8-456619ca5a8c" providerId="ADAL" clId="{FDDBFC5A-5EA9-5330-BEB8-433D7E3B4C4E}" dt="2026-04-10T05:37:51.050" v="4" actId="20577"/>
+          <ac:spMkLst>
             <pc:docMk/>
-            <pc:sldMk cId="0" sldId="277"/>
-            <ac:picMk id="228" creationId="{00000000-0000-0000-0000-000000000000}"/>
-          </ac:picMkLst>
-        </pc:picChg>
+            <pc:sldMk cId="179800585" sldId="281"/>
+            <ac:spMk id="135" creationId="{2248243C-A928-5BF5-4EE1-E4A3F24EF0D9}"/>
+          </ac:spMkLst>
+        </pc:spChg>
       </pc:sldChg>
-    </pc:docChg>
-  </pc:docChgLst>
-  <pc:docChgLst>
-    <pc:chgData name="Riccardo Berta" userId="c8694f89-bba4-4576-b0a8-456619ca5a8c" providerId="ADAL" clId="{894CBCD6-FC5D-E644-9183-7AA72B9AD2F7}"/>
-    <pc:docChg chg="modSld">
-      <pc:chgData name="Riccardo Berta" userId="c8694f89-bba4-4576-b0a8-456619ca5a8c" providerId="ADAL" clId="{894CBCD6-FC5D-E644-9183-7AA72B9AD2F7}" dt="2023-02-23T12:36:55.896" v="3" actId="1076"/>
-      <pc:docMkLst>
-        <pc:docMk/>
-      </pc:docMkLst>
       <pc:sldChg chg="modSp mod">
-        <pc:chgData name="Riccardo Berta" userId="c8694f89-bba4-4576-b0a8-456619ca5a8c" providerId="ADAL" clId="{894CBCD6-FC5D-E644-9183-7AA72B9AD2F7}" dt="2023-02-23T12:36:55.896" v="3" actId="1076"/>
+        <pc:chgData name="Riccardo Berta" userId="c8694f89-bba4-4576-b0a8-456619ca5a8c" providerId="ADAL" clId="{FDDBFC5A-5EA9-5330-BEB8-433D7E3B4C4E}" dt="2026-04-15T05:58:46.562" v="83" actId="20577"/>
         <pc:sldMkLst>
           <pc:docMk/>
-          <pc:sldMk cId="0" sldId="257"/>
+          <pc:sldMk cId="264790446" sldId="285"/>
         </pc:sldMkLst>
-        <pc:picChg chg="mod">
-          <ac:chgData name="Riccardo Berta" userId="c8694f89-bba4-4576-b0a8-456619ca5a8c" providerId="ADAL" clId="{894CBCD6-FC5D-E644-9183-7AA72B9AD2F7}" dt="2023-02-23T12:29:52.141" v="0"/>
-          <ac:picMkLst>
+        <pc:spChg chg="mod">
+          <ac:chgData name="Riccardo Berta" userId="c8694f89-bba4-4576-b0a8-456619ca5a8c" providerId="ADAL" clId="{FDDBFC5A-5EA9-5330-BEB8-433D7E3B4C4E}" dt="2026-04-15T05:58:46.562" v="83" actId="20577"/>
+          <ac:spMkLst>
             <pc:docMk/>
-            <pc:sldMk cId="0" sldId="257"/>
-            <ac:picMk id="85" creationId="{00000000-0000-0000-0000-000000000000}"/>
-          </ac:picMkLst>
-        </pc:picChg>
-        <pc:picChg chg="mod">
-          <ac:chgData name="Riccardo Berta" userId="c8694f89-bba4-4576-b0a8-456619ca5a8c" providerId="ADAL" clId="{894CBCD6-FC5D-E644-9183-7AA72B9AD2F7}" dt="2023-02-23T12:34:55.916" v="1"/>
-          <ac:picMkLst>
+            <pc:sldMk cId="264790446" sldId="285"/>
+            <ac:spMk id="227" creationId="{7F003B01-656F-1311-C537-549760D2ED2C}"/>
+          </ac:spMkLst>
+        </pc:spChg>
+      </pc:sldChg>
+      <pc:sldChg chg="modSp mod">
+        <pc:chgData name="Riccardo Berta" userId="c8694f89-bba4-4576-b0a8-456619ca5a8c" providerId="ADAL" clId="{FDDBFC5A-5EA9-5330-BEB8-433D7E3B4C4E}" dt="2026-04-15T05:59:53.389" v="86" actId="20577"/>
+        <pc:sldMkLst>
+          <pc:docMk/>
+          <pc:sldMk cId="755255463" sldId="286"/>
+        </pc:sldMkLst>
+        <pc:spChg chg="mod">
+          <ac:chgData name="Riccardo Berta" userId="c8694f89-bba4-4576-b0a8-456619ca5a8c" providerId="ADAL" clId="{FDDBFC5A-5EA9-5330-BEB8-433D7E3B4C4E}" dt="2026-04-15T05:59:53.389" v="86" actId="20577"/>
+          <ac:spMkLst>
             <pc:docMk/>
-            <pc:sldMk cId="0" sldId="257"/>
-            <ac:picMk id="86" creationId="{00000000-0000-0000-0000-000000000000}"/>
-          </ac:picMkLst>
-        </pc:picChg>
-        <pc:picChg chg="mod">
-          <ac:chgData name="Riccardo Berta" userId="c8694f89-bba4-4576-b0a8-456619ca5a8c" providerId="ADAL" clId="{894CBCD6-FC5D-E644-9183-7AA72B9AD2F7}" dt="2023-02-23T12:36:55.896" v="3" actId="1076"/>
-          <ac:picMkLst>
+            <pc:sldMk cId="755255463" sldId="286"/>
+            <ac:spMk id="234" creationId="{EE072F69-7826-CB32-3EC0-E460C181291D}"/>
+          </ac:spMkLst>
+        </pc:spChg>
+      </pc:sldChg>
+      <pc:sldChg chg="delSp new del mod">
+        <pc:chgData name="Riccardo Berta" userId="c8694f89-bba4-4576-b0a8-456619ca5a8c" providerId="ADAL" clId="{FDDBFC5A-5EA9-5330-BEB8-433D7E3B4C4E}" dt="2026-04-15T13:37:26.050" v="92" actId="2696"/>
+        <pc:sldMkLst>
+          <pc:docMk/>
+          <pc:sldMk cId="1990312382" sldId="287"/>
+        </pc:sldMkLst>
+        <pc:spChg chg="del">
+          <ac:chgData name="Riccardo Berta" userId="c8694f89-bba4-4576-b0a8-456619ca5a8c" providerId="ADAL" clId="{FDDBFC5A-5EA9-5330-BEB8-433D7E3B4C4E}" dt="2026-04-15T13:33:11.132" v="90" actId="478"/>
+          <ac:spMkLst>
             <pc:docMk/>
-            <pc:sldMk cId="0" sldId="257"/>
-            <ac:picMk id="87" creationId="{00000000-0000-0000-0000-000000000000}"/>
-          </ac:picMkLst>
-        </pc:picChg>
+            <pc:sldMk cId="1990312382" sldId="287"/>
+            <ac:spMk id="2" creationId="{2B183603-8701-5D3C-091B-630495F992C5}"/>
+          </ac:spMkLst>
+        </pc:spChg>
+        <pc:spChg chg="del">
+          <ac:chgData name="Riccardo Berta" userId="c8694f89-bba4-4576-b0a8-456619ca5a8c" providerId="ADAL" clId="{FDDBFC5A-5EA9-5330-BEB8-433D7E3B4C4E}" dt="2026-04-15T13:33:12.824" v="91" actId="478"/>
+          <ac:spMkLst>
+            <pc:docMk/>
+            <pc:sldMk cId="1990312382" sldId="287"/>
+            <ac:spMk id="3" creationId="{8D7195DD-950E-9DDC-C576-B2D5B591FE3A}"/>
+          </ac:spMkLst>
+        </pc:spChg>
       </pc:sldChg>
     </pc:docChg>
   </pc:docChgLst>
@@ -4513,6 +4166,13 @@
             <a:tailEnd type="none" w="sm" len="sm"/>
           </a:ln>
         </p:spPr>
+        <p:txBody>
+          <a:bodyPr/>
+          <a:lstStyle/>
+          <a:p>
+            <a:endParaRPr lang="en-GB"/>
+          </a:p>
+        </p:txBody>
       </p:sp>
       <p:sp>
         <p:nvSpPr>
@@ -4556,6 +4216,13 @@
             <a:tailEnd type="none" w="sm" len="sm"/>
           </a:ln>
         </p:spPr>
+        <p:txBody>
+          <a:bodyPr/>
+          <a:lstStyle/>
+          <a:p>
+            <a:endParaRPr lang="en-GB"/>
+          </a:p>
+        </p:txBody>
       </p:sp>
       <p:sp>
         <p:nvSpPr>
@@ -4969,7 +4636,7 @@
             </a:pPr>
             <a:fld id="{00000000-1234-1234-1234-123412341234}" type="slidenum">
               <a:rPr lang="en-GB"/>
-              <a:t>‹#›</a:t>
+              <a:t>‹N›</a:t>
             </a:fld>
             <a:endParaRPr/>
           </a:p>
@@ -4984,473 +4651,6 @@
 </file>
 
 <file path=ppt/slideLayouts/slideLayout10.xml><?xml version="1.0" encoding="utf-8"?>
-<p:sldLayout xmlns:a="http://schemas.openxmlformats.org/drawingml/2006/main" xmlns:r="http://schemas.openxmlformats.org/officeDocument/2006/relationships" xmlns:p="http://schemas.openxmlformats.org/presentationml/2006/main" matchingName="Big number">
-  <p:cSld name="BIG_NUMBER">
-    <p:spTree>
-      <p:nvGrpSpPr>
-        <p:cNvPr id="1" name="Shape 51"/>
-        <p:cNvGrpSpPr/>
-        <p:nvPr/>
-      </p:nvGrpSpPr>
-      <p:grpSpPr>
-        <a:xfrm>
-          <a:off x="0" y="0"/>
-          <a:ext cx="0" cy="0"/>
-          <a:chOff x="0" y="0"/>
-          <a:chExt cx="0" cy="0"/>
-        </a:xfrm>
-      </p:grpSpPr>
-      <p:sp>
-        <p:nvSpPr>
-          <p:cNvPr id="52" name="Google Shape;52;p11"/>
-          <p:cNvSpPr/>
-          <p:nvPr/>
-        </p:nvSpPr>
-        <p:spPr>
-          <a:xfrm>
-            <a:off x="0" y="6727600"/>
-            <a:ext cx="9144000" cy="130500"/>
-          </a:xfrm>
-          <a:prstGeom prst="rect">
-            <a:avLst/>
-          </a:prstGeom>
-          <a:solidFill>
-            <a:schemeClr val="lt2"/>
-          </a:solidFill>
-          <a:ln>
-            <a:noFill/>
-          </a:ln>
-        </p:spPr>
-        <p:txBody>
-          <a:bodyPr spcFirstLastPara="1" wrap="square" lIns="91425" tIns="91425" rIns="91425" bIns="91425" anchor="ctr" anchorCtr="0">
-            <a:noAutofit/>
-          </a:bodyPr>
-          <a:lstStyle/>
-          <a:p>
-            <a:pPr marL="0" lvl="0" indent="0" algn="l" rtl="0">
-              <a:spcBef>
-                <a:spcPts val="0"/>
-              </a:spcBef>
-              <a:spcAft>
-                <a:spcPts val="0"/>
-              </a:spcAft>
-              <a:buNone/>
-            </a:pPr>
-            <a:endParaRPr/>
-          </a:p>
-        </p:txBody>
-      </p:sp>
-      <p:sp>
-        <p:nvSpPr>
-          <p:cNvPr id="53" name="Google Shape;53;p11"/>
-          <p:cNvSpPr txBox="1">
-            <a:spLocks noGrp="1"/>
-          </p:cNvSpPr>
-          <p:nvPr>
-            <p:ph type="title" hasCustomPrompt="1"/>
-          </p:nvPr>
-        </p:nvSpPr>
-        <p:spPr>
-          <a:xfrm>
-            <a:off x="311700" y="1276167"/>
-            <a:ext cx="8520600" cy="2838300"/>
-          </a:xfrm>
-          <a:prstGeom prst="rect">
-            <a:avLst/>
-          </a:prstGeom>
-        </p:spPr>
-        <p:txBody>
-          <a:bodyPr spcFirstLastPara="1" wrap="square" lIns="91425" tIns="91425" rIns="91425" bIns="91425" anchor="ctr" anchorCtr="0">
-            <a:noAutofit/>
-          </a:bodyPr>
-          <a:lstStyle>
-            <a:lvl1pPr lvl="0" algn="ctr">
-              <a:spcBef>
-                <a:spcPts val="0"/>
-              </a:spcBef>
-              <a:spcAft>
-                <a:spcPts val="0"/>
-              </a:spcAft>
-              <a:buClr>
-                <a:schemeClr val="lt2"/>
-              </a:buClr>
-              <a:buSzPts val="16000"/>
-              <a:buNone/>
-              <a:defRPr sz="16000">
-                <a:solidFill>
-                  <a:schemeClr val="lt2"/>
-                </a:solidFill>
-              </a:defRPr>
-            </a:lvl1pPr>
-            <a:lvl2pPr lvl="1" algn="ctr">
-              <a:spcBef>
-                <a:spcPts val="0"/>
-              </a:spcBef>
-              <a:spcAft>
-                <a:spcPts val="0"/>
-              </a:spcAft>
-              <a:buClr>
-                <a:schemeClr val="lt2"/>
-              </a:buClr>
-              <a:buSzPts val="16000"/>
-              <a:buNone/>
-              <a:defRPr sz="16000">
-                <a:solidFill>
-                  <a:schemeClr val="lt2"/>
-                </a:solidFill>
-              </a:defRPr>
-            </a:lvl2pPr>
-            <a:lvl3pPr lvl="2" algn="ctr">
-              <a:spcBef>
-                <a:spcPts val="0"/>
-              </a:spcBef>
-              <a:spcAft>
-                <a:spcPts val="0"/>
-              </a:spcAft>
-              <a:buClr>
-                <a:schemeClr val="lt2"/>
-              </a:buClr>
-              <a:buSzPts val="16000"/>
-              <a:buNone/>
-              <a:defRPr sz="16000">
-                <a:solidFill>
-                  <a:schemeClr val="lt2"/>
-                </a:solidFill>
-              </a:defRPr>
-            </a:lvl3pPr>
-            <a:lvl4pPr lvl="3" algn="ctr">
-              <a:spcBef>
-                <a:spcPts val="0"/>
-              </a:spcBef>
-              <a:spcAft>
-                <a:spcPts val="0"/>
-              </a:spcAft>
-              <a:buClr>
-                <a:schemeClr val="lt2"/>
-              </a:buClr>
-              <a:buSzPts val="16000"/>
-              <a:buNone/>
-              <a:defRPr sz="16000">
-                <a:solidFill>
-                  <a:schemeClr val="lt2"/>
-                </a:solidFill>
-              </a:defRPr>
-            </a:lvl4pPr>
-            <a:lvl5pPr lvl="4" algn="ctr">
-              <a:spcBef>
-                <a:spcPts val="0"/>
-              </a:spcBef>
-              <a:spcAft>
-                <a:spcPts val="0"/>
-              </a:spcAft>
-              <a:buClr>
-                <a:schemeClr val="lt2"/>
-              </a:buClr>
-              <a:buSzPts val="16000"/>
-              <a:buNone/>
-              <a:defRPr sz="16000">
-                <a:solidFill>
-                  <a:schemeClr val="lt2"/>
-                </a:solidFill>
-              </a:defRPr>
-            </a:lvl5pPr>
-            <a:lvl6pPr lvl="5" algn="ctr">
-              <a:spcBef>
-                <a:spcPts val="0"/>
-              </a:spcBef>
-              <a:spcAft>
-                <a:spcPts val="0"/>
-              </a:spcAft>
-              <a:buClr>
-                <a:schemeClr val="lt2"/>
-              </a:buClr>
-              <a:buSzPts val="16000"/>
-              <a:buNone/>
-              <a:defRPr sz="16000">
-                <a:solidFill>
-                  <a:schemeClr val="lt2"/>
-                </a:solidFill>
-              </a:defRPr>
-            </a:lvl6pPr>
-            <a:lvl7pPr lvl="6" algn="ctr">
-              <a:spcBef>
-                <a:spcPts val="0"/>
-              </a:spcBef>
-              <a:spcAft>
-                <a:spcPts val="0"/>
-              </a:spcAft>
-              <a:buClr>
-                <a:schemeClr val="lt2"/>
-              </a:buClr>
-              <a:buSzPts val="16000"/>
-              <a:buNone/>
-              <a:defRPr sz="16000">
-                <a:solidFill>
-                  <a:schemeClr val="lt2"/>
-                </a:solidFill>
-              </a:defRPr>
-            </a:lvl7pPr>
-            <a:lvl8pPr lvl="7" algn="ctr">
-              <a:spcBef>
-                <a:spcPts val="0"/>
-              </a:spcBef>
-              <a:spcAft>
-                <a:spcPts val="0"/>
-              </a:spcAft>
-              <a:buClr>
-                <a:schemeClr val="lt2"/>
-              </a:buClr>
-              <a:buSzPts val="16000"/>
-              <a:buNone/>
-              <a:defRPr sz="16000">
-                <a:solidFill>
-                  <a:schemeClr val="lt2"/>
-                </a:solidFill>
-              </a:defRPr>
-            </a:lvl8pPr>
-            <a:lvl9pPr lvl="8" algn="ctr">
-              <a:spcBef>
-                <a:spcPts val="0"/>
-              </a:spcBef>
-              <a:spcAft>
-                <a:spcPts val="0"/>
-              </a:spcAft>
-              <a:buClr>
-                <a:schemeClr val="lt2"/>
-              </a:buClr>
-              <a:buSzPts val="16000"/>
-              <a:buNone/>
-              <a:defRPr sz="16000">
-                <a:solidFill>
-                  <a:schemeClr val="lt2"/>
-                </a:solidFill>
-              </a:defRPr>
-            </a:lvl9pPr>
-          </a:lstStyle>
-          <a:p>
-            <a:r>
-              <a:t>xx%</a:t>
-            </a:r>
-          </a:p>
-        </p:txBody>
-      </p:sp>
-      <p:sp>
-        <p:nvSpPr>
-          <p:cNvPr id="54" name="Google Shape;54;p11"/>
-          <p:cNvSpPr txBox="1">
-            <a:spLocks noGrp="1"/>
-          </p:cNvSpPr>
-          <p:nvPr>
-            <p:ph type="body" idx="1"/>
-          </p:nvPr>
-        </p:nvSpPr>
-        <p:spPr>
-          <a:xfrm>
-            <a:off x="311700" y="4216000"/>
-            <a:ext cx="8520600" cy="1428900"/>
-          </a:xfrm>
-          <a:prstGeom prst="rect">
-            <a:avLst/>
-          </a:prstGeom>
-        </p:spPr>
-        <p:txBody>
-          <a:bodyPr spcFirstLastPara="1" wrap="square" lIns="91425" tIns="91425" rIns="91425" bIns="91425" anchor="t" anchorCtr="0">
-            <a:noAutofit/>
-          </a:bodyPr>
-          <a:lstStyle>
-            <a:lvl1pPr marL="457200" lvl="0" indent="-342900" algn="ctr">
-              <a:spcBef>
-                <a:spcPts val="0"/>
-              </a:spcBef>
-              <a:spcAft>
-                <a:spcPts val="0"/>
-              </a:spcAft>
-              <a:buSzPts val="1800"/>
-              <a:buChar char="●"/>
-              <a:defRPr/>
-            </a:lvl1pPr>
-            <a:lvl2pPr marL="914400" lvl="1" indent="-317500" algn="ctr">
-              <a:spcBef>
-                <a:spcPts val="1600"/>
-              </a:spcBef>
-              <a:spcAft>
-                <a:spcPts val="0"/>
-              </a:spcAft>
-              <a:buSzPts val="1400"/>
-              <a:buChar char="○"/>
-              <a:defRPr/>
-            </a:lvl2pPr>
-            <a:lvl3pPr marL="1371600" lvl="2" indent="-317500" algn="ctr">
-              <a:spcBef>
-                <a:spcPts val="1600"/>
-              </a:spcBef>
-              <a:spcAft>
-                <a:spcPts val="0"/>
-              </a:spcAft>
-              <a:buSzPts val="1400"/>
-              <a:buChar char="■"/>
-              <a:defRPr/>
-            </a:lvl3pPr>
-            <a:lvl4pPr marL="1828800" lvl="3" indent="-317500" algn="ctr">
-              <a:spcBef>
-                <a:spcPts val="1600"/>
-              </a:spcBef>
-              <a:spcAft>
-                <a:spcPts val="0"/>
-              </a:spcAft>
-              <a:buSzPts val="1400"/>
-              <a:buChar char="●"/>
-              <a:defRPr/>
-            </a:lvl4pPr>
-            <a:lvl5pPr marL="2286000" lvl="4" indent="-317500" algn="ctr">
-              <a:spcBef>
-                <a:spcPts val="1600"/>
-              </a:spcBef>
-              <a:spcAft>
-                <a:spcPts val="0"/>
-              </a:spcAft>
-              <a:buSzPts val="1400"/>
-              <a:buChar char="○"/>
-              <a:defRPr/>
-            </a:lvl5pPr>
-            <a:lvl6pPr marL="2743200" lvl="5" indent="-317500" algn="ctr">
-              <a:spcBef>
-                <a:spcPts val="1600"/>
-              </a:spcBef>
-              <a:spcAft>
-                <a:spcPts val="0"/>
-              </a:spcAft>
-              <a:buSzPts val="1400"/>
-              <a:buChar char="■"/>
-              <a:defRPr/>
-            </a:lvl6pPr>
-            <a:lvl7pPr marL="3200400" lvl="6" indent="-317500" algn="ctr">
-              <a:spcBef>
-                <a:spcPts val="1600"/>
-              </a:spcBef>
-              <a:spcAft>
-                <a:spcPts val="0"/>
-              </a:spcAft>
-              <a:buSzPts val="1400"/>
-              <a:buChar char="●"/>
-              <a:defRPr/>
-            </a:lvl7pPr>
-            <a:lvl8pPr marL="3657600" lvl="7" indent="-317500" algn="ctr">
-              <a:spcBef>
-                <a:spcPts val="1600"/>
-              </a:spcBef>
-              <a:spcAft>
-                <a:spcPts val="0"/>
-              </a:spcAft>
-              <a:buSzPts val="1400"/>
-              <a:buChar char="○"/>
-              <a:defRPr/>
-            </a:lvl8pPr>
-            <a:lvl9pPr marL="4114800" lvl="8" indent="-317500" algn="ctr">
-              <a:spcBef>
-                <a:spcPts val="1600"/>
-              </a:spcBef>
-              <a:spcAft>
-                <a:spcPts val="1600"/>
-              </a:spcAft>
-              <a:buSzPts val="1400"/>
-              <a:buChar char="■"/>
-              <a:defRPr/>
-            </a:lvl9pPr>
-          </a:lstStyle>
-          <a:p>
-            <a:endParaRPr/>
-          </a:p>
-        </p:txBody>
-      </p:sp>
-      <p:sp>
-        <p:nvSpPr>
-          <p:cNvPr id="55" name="Google Shape;55;p11"/>
-          <p:cNvSpPr txBox="1">
-            <a:spLocks noGrp="1"/>
-          </p:cNvSpPr>
-          <p:nvPr>
-            <p:ph type="sldNum" idx="12"/>
-          </p:nvPr>
-        </p:nvSpPr>
-        <p:spPr>
-          <a:xfrm>
-            <a:off x="8472458" y="6217622"/>
-            <a:ext cx="548700" cy="524700"/>
-          </a:xfrm>
-          <a:prstGeom prst="rect">
-            <a:avLst/>
-          </a:prstGeom>
-        </p:spPr>
-        <p:txBody>
-          <a:bodyPr spcFirstLastPara="1" wrap="square" lIns="91425" tIns="91425" rIns="91425" bIns="91425" anchor="ctr" anchorCtr="0">
-            <a:noAutofit/>
-          </a:bodyPr>
-          <a:lstStyle>
-            <a:lvl1pPr lvl="0">
-              <a:buNone/>
-              <a:defRPr/>
-            </a:lvl1pPr>
-            <a:lvl2pPr lvl="1">
-              <a:buNone/>
-              <a:defRPr/>
-            </a:lvl2pPr>
-            <a:lvl3pPr lvl="2">
-              <a:buNone/>
-              <a:defRPr/>
-            </a:lvl3pPr>
-            <a:lvl4pPr lvl="3">
-              <a:buNone/>
-              <a:defRPr/>
-            </a:lvl4pPr>
-            <a:lvl5pPr lvl="4">
-              <a:buNone/>
-              <a:defRPr/>
-            </a:lvl5pPr>
-            <a:lvl6pPr lvl="5">
-              <a:buNone/>
-              <a:defRPr/>
-            </a:lvl6pPr>
-            <a:lvl7pPr lvl="6">
-              <a:buNone/>
-              <a:defRPr/>
-            </a:lvl7pPr>
-            <a:lvl8pPr lvl="7">
-              <a:buNone/>
-              <a:defRPr/>
-            </a:lvl8pPr>
-            <a:lvl9pPr lvl="8">
-              <a:buNone/>
-              <a:defRPr/>
-            </a:lvl9pPr>
-          </a:lstStyle>
-          <a:p>
-            <a:pPr marL="0" lvl="0" indent="0" algn="r" rtl="0">
-              <a:spcBef>
-                <a:spcPts val="0"/>
-              </a:spcBef>
-              <a:spcAft>
-                <a:spcPts val="0"/>
-              </a:spcAft>
-              <a:buNone/>
-            </a:pPr>
-            <a:fld id="{00000000-1234-1234-1234-123412341234}" type="slidenum">
-              <a:rPr lang="en-GB"/>
-              <a:t>‹#›</a:t>
-            </a:fld>
-            <a:endParaRPr/>
-          </a:p>
-        </p:txBody>
-      </p:sp>
-    </p:spTree>
-  </p:cSld>
-  <p:clrMapOvr>
-    <a:masterClrMapping/>
-  </p:clrMapOvr>
-</p:sldLayout>
-</file>
-
-<file path=ppt/slideLayouts/slideLayout11.xml><?xml version="1.0" encoding="utf-8"?>
 <p:sldLayout xmlns:a="http://schemas.openxmlformats.org/drawingml/2006/main" xmlns:r="http://schemas.openxmlformats.org/officeDocument/2006/relationships" xmlns:p="http://schemas.openxmlformats.org/presentationml/2006/main" matchingName="Blank" type="blank">
   <p:cSld name="BLANK">
     <p:spTree>
@@ -5540,7 +4740,7 @@
             </a:pPr>
             <a:fld id="{00000000-1234-1234-1234-123412341234}" type="slidenum">
               <a:rPr lang="en-GB"/>
-              <a:t>‹#›</a:t>
+              <a:t>‹N›</a:t>
             </a:fld>
             <a:endParaRPr/>
           </a:p>
@@ -5555,325 +4755,6 @@
 </file>
 
 <file path=ppt/slideLayouts/slideLayout2.xml><?xml version="1.0" encoding="utf-8"?>
-<p:sldLayout xmlns:a="http://schemas.openxmlformats.org/drawingml/2006/main" xmlns:r="http://schemas.openxmlformats.org/officeDocument/2006/relationships" xmlns:p="http://schemas.openxmlformats.org/presentationml/2006/main" matchingName="Section header" type="secHead">
-  <p:cSld name="SECTION_HEADER">
-    <p:spTree>
-      <p:nvGrpSpPr>
-        <p:cNvPr id="1" name="Shape 15"/>
-        <p:cNvGrpSpPr/>
-        <p:nvPr/>
-      </p:nvGrpSpPr>
-      <p:grpSpPr>
-        <a:xfrm>
-          <a:off x="0" y="0"/>
-          <a:ext cx="0" cy="0"/>
-          <a:chOff x="0" y="0"/>
-          <a:chExt cx="0" cy="0"/>
-        </a:xfrm>
-      </p:grpSpPr>
-      <p:sp>
-        <p:nvSpPr>
-          <p:cNvPr id="16" name="Google Shape;16;p3"/>
-          <p:cNvSpPr/>
-          <p:nvPr/>
-        </p:nvSpPr>
-        <p:spPr>
-          <a:xfrm flipH="1">
-            <a:off x="7595938" y="613633"/>
-            <a:ext cx="1081625" cy="1499896"/>
-          </a:xfrm>
-          <a:custGeom>
-            <a:avLst/>
-            <a:gdLst/>
-            <a:ahLst/>
-            <a:cxnLst/>
-            <a:rect l="l" t="t" r="r" b="b"/>
-            <a:pathLst>
-              <a:path w="43265" h="44998" extrusionOk="0">
-                <a:moveTo>
-                  <a:pt x="0" y="44998"/>
-                </a:moveTo>
-                <a:lnTo>
-                  <a:pt x="0" y="0"/>
-                </a:lnTo>
-                <a:lnTo>
-                  <a:pt x="43265" y="0"/>
-                </a:lnTo>
-              </a:path>
-            </a:pathLst>
-          </a:custGeom>
-          <a:noFill/>
-          <a:ln w="28575" cap="flat" cmpd="sng">
-            <a:solidFill>
-              <a:schemeClr val="lt2"/>
-            </a:solidFill>
-            <a:prstDash val="solid"/>
-            <a:miter lim="8000"/>
-            <a:headEnd type="none" w="sm" len="sm"/>
-            <a:tailEnd type="none" w="sm" len="sm"/>
-          </a:ln>
-        </p:spPr>
-      </p:sp>
-      <p:sp>
-        <p:nvSpPr>
-          <p:cNvPr id="17" name="Google Shape;17;p3"/>
-          <p:cNvSpPr/>
-          <p:nvPr/>
-        </p:nvSpPr>
-        <p:spPr>
-          <a:xfrm rot="10800000" flipH="1">
-            <a:off x="466425" y="4744471"/>
-            <a:ext cx="1081625" cy="1499896"/>
-          </a:xfrm>
-          <a:custGeom>
-            <a:avLst/>
-            <a:gdLst/>
-            <a:ahLst/>
-            <a:cxnLst/>
-            <a:rect l="l" t="t" r="r" b="b"/>
-            <a:pathLst>
-              <a:path w="43265" h="44998" extrusionOk="0">
-                <a:moveTo>
-                  <a:pt x="0" y="44998"/>
-                </a:moveTo>
-                <a:lnTo>
-                  <a:pt x="0" y="0"/>
-                </a:lnTo>
-                <a:lnTo>
-                  <a:pt x="43265" y="0"/>
-                </a:lnTo>
-              </a:path>
-            </a:pathLst>
-          </a:custGeom>
-          <a:noFill/>
-          <a:ln w="28575" cap="flat" cmpd="sng">
-            <a:solidFill>
-              <a:schemeClr val="lt2"/>
-            </a:solidFill>
-            <a:prstDash val="solid"/>
-            <a:miter lim="8000"/>
-            <a:headEnd type="none" w="sm" len="sm"/>
-            <a:tailEnd type="none" w="sm" len="sm"/>
-          </a:ln>
-        </p:spPr>
-      </p:sp>
-      <p:sp>
-        <p:nvSpPr>
-          <p:cNvPr id="18" name="Google Shape;18;p3"/>
-          <p:cNvSpPr txBox="1">
-            <a:spLocks noGrp="1"/>
-          </p:cNvSpPr>
-          <p:nvPr>
-            <p:ph type="title"/>
-          </p:nvPr>
-        </p:nvSpPr>
-        <p:spPr>
-          <a:xfrm>
-            <a:off x="773700" y="2408600"/>
-            <a:ext cx="7596600" cy="2040900"/>
-          </a:xfrm>
-          <a:prstGeom prst="rect">
-            <a:avLst/>
-          </a:prstGeom>
-        </p:spPr>
-        <p:txBody>
-          <a:bodyPr spcFirstLastPara="1" wrap="square" lIns="91425" tIns="91425" rIns="91425" bIns="91425" anchor="ctr" anchorCtr="0">
-            <a:noAutofit/>
-          </a:bodyPr>
-          <a:lstStyle>
-            <a:lvl1pPr lvl="0" algn="ctr">
-              <a:spcBef>
-                <a:spcPts val="0"/>
-              </a:spcBef>
-              <a:spcAft>
-                <a:spcPts val="0"/>
-              </a:spcAft>
-              <a:buSzPts val="4200"/>
-              <a:buNone/>
-              <a:defRPr/>
-            </a:lvl1pPr>
-            <a:lvl2pPr lvl="1" algn="ctr">
-              <a:spcBef>
-                <a:spcPts val="0"/>
-              </a:spcBef>
-              <a:spcAft>
-                <a:spcPts val="0"/>
-              </a:spcAft>
-              <a:buSzPts val="4200"/>
-              <a:buNone/>
-              <a:defRPr/>
-            </a:lvl2pPr>
-            <a:lvl3pPr lvl="2" algn="ctr">
-              <a:spcBef>
-                <a:spcPts val="0"/>
-              </a:spcBef>
-              <a:spcAft>
-                <a:spcPts val="0"/>
-              </a:spcAft>
-              <a:buSzPts val="4200"/>
-              <a:buNone/>
-              <a:defRPr/>
-            </a:lvl3pPr>
-            <a:lvl4pPr lvl="3" algn="ctr">
-              <a:spcBef>
-                <a:spcPts val="0"/>
-              </a:spcBef>
-              <a:spcAft>
-                <a:spcPts val="0"/>
-              </a:spcAft>
-              <a:buSzPts val="4200"/>
-              <a:buNone/>
-              <a:defRPr/>
-            </a:lvl4pPr>
-            <a:lvl5pPr lvl="4" algn="ctr">
-              <a:spcBef>
-                <a:spcPts val="0"/>
-              </a:spcBef>
-              <a:spcAft>
-                <a:spcPts val="0"/>
-              </a:spcAft>
-              <a:buSzPts val="4200"/>
-              <a:buNone/>
-              <a:defRPr/>
-            </a:lvl5pPr>
-            <a:lvl6pPr lvl="5" algn="ctr">
-              <a:spcBef>
-                <a:spcPts val="0"/>
-              </a:spcBef>
-              <a:spcAft>
-                <a:spcPts val="0"/>
-              </a:spcAft>
-              <a:buSzPts val="4200"/>
-              <a:buNone/>
-              <a:defRPr/>
-            </a:lvl6pPr>
-            <a:lvl7pPr lvl="6" algn="ctr">
-              <a:spcBef>
-                <a:spcPts val="0"/>
-              </a:spcBef>
-              <a:spcAft>
-                <a:spcPts val="0"/>
-              </a:spcAft>
-              <a:buSzPts val="4200"/>
-              <a:buNone/>
-              <a:defRPr/>
-            </a:lvl7pPr>
-            <a:lvl8pPr lvl="7" algn="ctr">
-              <a:spcBef>
-                <a:spcPts val="0"/>
-              </a:spcBef>
-              <a:spcAft>
-                <a:spcPts val="0"/>
-              </a:spcAft>
-              <a:buSzPts val="4200"/>
-              <a:buNone/>
-              <a:defRPr/>
-            </a:lvl8pPr>
-            <a:lvl9pPr lvl="8" algn="ctr">
-              <a:spcBef>
-                <a:spcPts val="0"/>
-              </a:spcBef>
-              <a:spcAft>
-                <a:spcPts val="0"/>
-              </a:spcAft>
-              <a:buSzPts val="4200"/>
-              <a:buNone/>
-              <a:defRPr/>
-            </a:lvl9pPr>
-          </a:lstStyle>
-          <a:p>
-            <a:endParaRPr/>
-          </a:p>
-        </p:txBody>
-      </p:sp>
-      <p:sp>
-        <p:nvSpPr>
-          <p:cNvPr id="19" name="Google Shape;19;p3"/>
-          <p:cNvSpPr txBox="1">
-            <a:spLocks noGrp="1"/>
-          </p:cNvSpPr>
-          <p:nvPr>
-            <p:ph type="sldNum" idx="12"/>
-          </p:nvPr>
-        </p:nvSpPr>
-        <p:spPr>
-          <a:xfrm>
-            <a:off x="8472458" y="6217622"/>
-            <a:ext cx="548700" cy="524700"/>
-          </a:xfrm>
-          <a:prstGeom prst="rect">
-            <a:avLst/>
-          </a:prstGeom>
-        </p:spPr>
-        <p:txBody>
-          <a:bodyPr spcFirstLastPara="1" wrap="square" lIns="91425" tIns="91425" rIns="91425" bIns="91425" anchor="ctr" anchorCtr="0">
-            <a:noAutofit/>
-          </a:bodyPr>
-          <a:lstStyle>
-            <a:lvl1pPr lvl="0">
-              <a:buNone/>
-              <a:defRPr/>
-            </a:lvl1pPr>
-            <a:lvl2pPr lvl="1">
-              <a:buNone/>
-              <a:defRPr/>
-            </a:lvl2pPr>
-            <a:lvl3pPr lvl="2">
-              <a:buNone/>
-              <a:defRPr/>
-            </a:lvl3pPr>
-            <a:lvl4pPr lvl="3">
-              <a:buNone/>
-              <a:defRPr/>
-            </a:lvl4pPr>
-            <a:lvl5pPr lvl="4">
-              <a:buNone/>
-              <a:defRPr/>
-            </a:lvl5pPr>
-            <a:lvl6pPr lvl="5">
-              <a:buNone/>
-              <a:defRPr/>
-            </a:lvl6pPr>
-            <a:lvl7pPr lvl="6">
-              <a:buNone/>
-              <a:defRPr/>
-            </a:lvl7pPr>
-            <a:lvl8pPr lvl="7">
-              <a:buNone/>
-              <a:defRPr/>
-            </a:lvl8pPr>
-            <a:lvl9pPr lvl="8">
-              <a:buNone/>
-              <a:defRPr/>
-            </a:lvl9pPr>
-          </a:lstStyle>
-          <a:p>
-            <a:pPr marL="0" lvl="0" indent="0" algn="r" rtl="0">
-              <a:spcBef>
-                <a:spcPts val="0"/>
-              </a:spcBef>
-              <a:spcAft>
-                <a:spcPts val="0"/>
-              </a:spcAft>
-              <a:buNone/>
-            </a:pPr>
-            <a:fld id="{00000000-1234-1234-1234-123412341234}" type="slidenum">
-              <a:rPr lang="en-GB"/>
-              <a:t>‹#›</a:t>
-            </a:fld>
-            <a:endParaRPr/>
-          </a:p>
-        </p:txBody>
-      </p:sp>
-    </p:spTree>
-  </p:cSld>
-  <p:clrMapOvr>
-    <a:masterClrMapping/>
-  </p:clrMapOvr>
-</p:sldLayout>
-</file>
-
-<file path=ppt/slideLayouts/slideLayout3.xml><?xml version="1.0" encoding="utf-8"?>
 <p:sldLayout xmlns:a="http://schemas.openxmlformats.org/drawingml/2006/main" xmlns:r="http://schemas.openxmlformats.org/officeDocument/2006/relationships" xmlns:p="http://schemas.openxmlformats.org/presentationml/2006/main" matchingName="RicTheme" type="tx">
   <p:cSld name="TITLE_AND_BODY">
     <p:spTree>
@@ -6261,7 +5142,7 @@
             </a:pPr>
             <a:fld id="{00000000-1234-1234-1234-123412341234}" type="slidenum">
               <a:rPr lang="en-GB"/>
-              <a:t>‹#›</a:t>
+              <a:t>‹N›</a:t>
             </a:fld>
             <a:endParaRPr/>
           </a:p>
@@ -6275,7 +5156,7 @@
 </p:sldLayout>
 </file>
 
-<file path=ppt/slideLayouts/slideLayout4.xml><?xml version="1.0" encoding="utf-8"?>
+<file path=ppt/slideLayouts/slideLayout3.xml><?xml version="1.0" encoding="utf-8"?>
 <p:sldLayout xmlns:a="http://schemas.openxmlformats.org/drawingml/2006/main" xmlns:r="http://schemas.openxmlformats.org/officeDocument/2006/relationships" xmlns:p="http://schemas.openxmlformats.org/presentationml/2006/main" matchingName="Title and two columns" type="twoColTx">
   <p:cSld name="TITLE_AND_TWO_COLUMNS">
     <p:spTree>
@@ -6752,7 +5633,7 @@
             </a:pPr>
             <a:fld id="{00000000-1234-1234-1234-123412341234}" type="slidenum">
               <a:rPr lang="en-GB"/>
-              <a:t>‹#›</a:t>
+              <a:t>‹N›</a:t>
             </a:fld>
             <a:endParaRPr/>
           </a:p>
@@ -6766,7 +5647,7 @@
 </p:sldLayout>
 </file>
 
-<file path=ppt/slideLayouts/slideLayout5.xml><?xml version="1.0" encoding="utf-8"?>
+<file path=ppt/slideLayouts/slideLayout4.xml><?xml version="1.0" encoding="utf-8"?>
 <p:sldLayout xmlns:a="http://schemas.openxmlformats.org/drawingml/2006/main" xmlns:r="http://schemas.openxmlformats.org/officeDocument/2006/relationships" xmlns:p="http://schemas.openxmlformats.org/presentationml/2006/main" matchingName="Title only" type="titleOnly">
   <p:cSld name="TITLE_ONLY">
     <p:spTree>
@@ -6985,7 +5866,7 @@
             </a:pPr>
             <a:fld id="{00000000-1234-1234-1234-123412341234}" type="slidenum">
               <a:rPr lang="en-GB"/>
-              <a:t>‹#›</a:t>
+              <a:t>‹N›</a:t>
             </a:fld>
             <a:endParaRPr/>
           </a:p>
@@ -6999,7 +5880,7 @@
 </p:sldLayout>
 </file>
 
-<file path=ppt/slideLayouts/slideLayout6.xml><?xml version="1.0" encoding="utf-8"?>
+<file path=ppt/slideLayouts/slideLayout5.xml><?xml version="1.0" encoding="utf-8"?>
 <p:sldLayout xmlns:a="http://schemas.openxmlformats.org/drawingml/2006/main" xmlns:r="http://schemas.openxmlformats.org/officeDocument/2006/relationships" xmlns:p="http://schemas.openxmlformats.org/presentationml/2006/main" matchingName="One column text">
   <p:cSld name="ONE_COLUMN_TEXT">
     <p:spTree>
@@ -7347,7 +6228,7 @@
             </a:pPr>
             <a:fld id="{00000000-1234-1234-1234-123412341234}" type="slidenum">
               <a:rPr lang="en-GB"/>
-              <a:t>‹#›</a:t>
+              <a:t>‹N›</a:t>
             </a:fld>
             <a:endParaRPr/>
           </a:p>
@@ -7361,7 +6242,7 @@
 </p:sldLayout>
 </file>
 
-<file path=ppt/slideLayouts/slideLayout7.xml><?xml version="1.0" encoding="utf-8"?>
+<file path=ppt/slideLayouts/slideLayout6.xml><?xml version="1.0" encoding="utf-8"?>
 <p:sldLayout xmlns:a="http://schemas.openxmlformats.org/drawingml/2006/main" xmlns:r="http://schemas.openxmlformats.org/officeDocument/2006/relationships" xmlns:p="http://schemas.openxmlformats.org/presentationml/2006/main" matchingName="Main point">
   <p:cSld name="MAIN_POINT">
     <p:spTree>
@@ -7620,7 +6501,7 @@
             </a:pPr>
             <a:fld id="{00000000-1234-1234-1234-123412341234}" type="slidenum">
               <a:rPr lang="en-GB"/>
-              <a:t>‹#›</a:t>
+              <a:t>‹N›</a:t>
             </a:fld>
             <a:endParaRPr/>
           </a:p>
@@ -7634,7 +6515,7 @@
 </p:sldLayout>
 </file>
 
-<file path=ppt/slideLayouts/slideLayout8.xml><?xml version="1.0" encoding="utf-8"?>
+<file path=ppt/slideLayouts/slideLayout7.xml><?xml version="1.0" encoding="utf-8"?>
 <p:sldLayout xmlns:a="http://schemas.openxmlformats.org/drawingml/2006/main" xmlns:r="http://schemas.openxmlformats.org/officeDocument/2006/relationships" xmlns:p="http://schemas.openxmlformats.org/presentationml/2006/main" matchingName="Section title and description">
   <p:cSld name="SECTION_TITLE_AND_DESCRIPTION">
     <p:spTree>
@@ -8420,7 +7301,7 @@
             </a:pPr>
             <a:fld id="{00000000-1234-1234-1234-123412341234}" type="slidenum">
               <a:rPr lang="en-GB"/>
-              <a:t>‹#›</a:t>
+              <a:t>‹N›</a:t>
             </a:fld>
             <a:endParaRPr/>
           </a:p>
@@ -8434,7 +7315,7 @@
 </p:sldLayout>
 </file>
 
-<file path=ppt/slideLayouts/slideLayout9.xml><?xml version="1.0" encoding="utf-8"?>
+<file path=ppt/slideLayouts/slideLayout8.xml><?xml version="1.0" encoding="utf-8"?>
 <p:sldLayout xmlns:a="http://schemas.openxmlformats.org/drawingml/2006/main" xmlns:r="http://schemas.openxmlformats.org/officeDocument/2006/relationships" xmlns:p="http://schemas.openxmlformats.org/presentationml/2006/main" matchingName="Caption">
   <p:cSld name="CAPTION_ONLY">
     <p:spTree>
@@ -8574,7 +7455,474 @@
             </a:pPr>
             <a:fld id="{00000000-1234-1234-1234-123412341234}" type="slidenum">
               <a:rPr lang="en-GB"/>
-              <a:t>‹#›</a:t>
+              <a:t>‹N›</a:t>
+            </a:fld>
+            <a:endParaRPr/>
+          </a:p>
+        </p:txBody>
+      </p:sp>
+    </p:spTree>
+  </p:cSld>
+  <p:clrMapOvr>
+    <a:masterClrMapping/>
+  </p:clrMapOvr>
+</p:sldLayout>
+</file>
+
+<file path=ppt/slideLayouts/slideLayout9.xml><?xml version="1.0" encoding="utf-8"?>
+<p:sldLayout xmlns:a="http://schemas.openxmlformats.org/drawingml/2006/main" xmlns:r="http://schemas.openxmlformats.org/officeDocument/2006/relationships" xmlns:p="http://schemas.openxmlformats.org/presentationml/2006/main" matchingName="Big number">
+  <p:cSld name="BIG_NUMBER">
+    <p:spTree>
+      <p:nvGrpSpPr>
+        <p:cNvPr id="1" name="Shape 51"/>
+        <p:cNvGrpSpPr/>
+        <p:nvPr/>
+      </p:nvGrpSpPr>
+      <p:grpSpPr>
+        <a:xfrm>
+          <a:off x="0" y="0"/>
+          <a:ext cx="0" cy="0"/>
+          <a:chOff x="0" y="0"/>
+          <a:chExt cx="0" cy="0"/>
+        </a:xfrm>
+      </p:grpSpPr>
+      <p:sp>
+        <p:nvSpPr>
+          <p:cNvPr id="52" name="Google Shape;52;p11"/>
+          <p:cNvSpPr/>
+          <p:nvPr/>
+        </p:nvSpPr>
+        <p:spPr>
+          <a:xfrm>
+            <a:off x="0" y="6727600"/>
+            <a:ext cx="9144000" cy="130500"/>
+          </a:xfrm>
+          <a:prstGeom prst="rect">
+            <a:avLst/>
+          </a:prstGeom>
+          <a:solidFill>
+            <a:schemeClr val="lt2"/>
+          </a:solidFill>
+          <a:ln>
+            <a:noFill/>
+          </a:ln>
+        </p:spPr>
+        <p:txBody>
+          <a:bodyPr spcFirstLastPara="1" wrap="square" lIns="91425" tIns="91425" rIns="91425" bIns="91425" anchor="ctr" anchorCtr="0">
+            <a:noAutofit/>
+          </a:bodyPr>
+          <a:lstStyle/>
+          <a:p>
+            <a:pPr marL="0" lvl="0" indent="0" algn="l" rtl="0">
+              <a:spcBef>
+                <a:spcPts val="0"/>
+              </a:spcBef>
+              <a:spcAft>
+                <a:spcPts val="0"/>
+              </a:spcAft>
+              <a:buNone/>
+            </a:pPr>
+            <a:endParaRPr/>
+          </a:p>
+        </p:txBody>
+      </p:sp>
+      <p:sp>
+        <p:nvSpPr>
+          <p:cNvPr id="53" name="Google Shape;53;p11"/>
+          <p:cNvSpPr txBox="1">
+            <a:spLocks noGrp="1"/>
+          </p:cNvSpPr>
+          <p:nvPr>
+            <p:ph type="title" hasCustomPrompt="1"/>
+          </p:nvPr>
+        </p:nvSpPr>
+        <p:spPr>
+          <a:xfrm>
+            <a:off x="311700" y="1276167"/>
+            <a:ext cx="8520600" cy="2838300"/>
+          </a:xfrm>
+          <a:prstGeom prst="rect">
+            <a:avLst/>
+          </a:prstGeom>
+        </p:spPr>
+        <p:txBody>
+          <a:bodyPr spcFirstLastPara="1" wrap="square" lIns="91425" tIns="91425" rIns="91425" bIns="91425" anchor="ctr" anchorCtr="0">
+            <a:noAutofit/>
+          </a:bodyPr>
+          <a:lstStyle>
+            <a:lvl1pPr lvl="0" algn="ctr">
+              <a:spcBef>
+                <a:spcPts val="0"/>
+              </a:spcBef>
+              <a:spcAft>
+                <a:spcPts val="0"/>
+              </a:spcAft>
+              <a:buClr>
+                <a:schemeClr val="lt2"/>
+              </a:buClr>
+              <a:buSzPts val="16000"/>
+              <a:buNone/>
+              <a:defRPr sz="16000">
+                <a:solidFill>
+                  <a:schemeClr val="lt2"/>
+                </a:solidFill>
+              </a:defRPr>
+            </a:lvl1pPr>
+            <a:lvl2pPr lvl="1" algn="ctr">
+              <a:spcBef>
+                <a:spcPts val="0"/>
+              </a:spcBef>
+              <a:spcAft>
+                <a:spcPts val="0"/>
+              </a:spcAft>
+              <a:buClr>
+                <a:schemeClr val="lt2"/>
+              </a:buClr>
+              <a:buSzPts val="16000"/>
+              <a:buNone/>
+              <a:defRPr sz="16000">
+                <a:solidFill>
+                  <a:schemeClr val="lt2"/>
+                </a:solidFill>
+              </a:defRPr>
+            </a:lvl2pPr>
+            <a:lvl3pPr lvl="2" algn="ctr">
+              <a:spcBef>
+                <a:spcPts val="0"/>
+              </a:spcBef>
+              <a:spcAft>
+                <a:spcPts val="0"/>
+              </a:spcAft>
+              <a:buClr>
+                <a:schemeClr val="lt2"/>
+              </a:buClr>
+              <a:buSzPts val="16000"/>
+              <a:buNone/>
+              <a:defRPr sz="16000">
+                <a:solidFill>
+                  <a:schemeClr val="lt2"/>
+                </a:solidFill>
+              </a:defRPr>
+            </a:lvl3pPr>
+            <a:lvl4pPr lvl="3" algn="ctr">
+              <a:spcBef>
+                <a:spcPts val="0"/>
+              </a:spcBef>
+              <a:spcAft>
+                <a:spcPts val="0"/>
+              </a:spcAft>
+              <a:buClr>
+                <a:schemeClr val="lt2"/>
+              </a:buClr>
+              <a:buSzPts val="16000"/>
+              <a:buNone/>
+              <a:defRPr sz="16000">
+                <a:solidFill>
+                  <a:schemeClr val="lt2"/>
+                </a:solidFill>
+              </a:defRPr>
+            </a:lvl4pPr>
+            <a:lvl5pPr lvl="4" algn="ctr">
+              <a:spcBef>
+                <a:spcPts val="0"/>
+              </a:spcBef>
+              <a:spcAft>
+                <a:spcPts val="0"/>
+              </a:spcAft>
+              <a:buClr>
+                <a:schemeClr val="lt2"/>
+              </a:buClr>
+              <a:buSzPts val="16000"/>
+              <a:buNone/>
+              <a:defRPr sz="16000">
+                <a:solidFill>
+                  <a:schemeClr val="lt2"/>
+                </a:solidFill>
+              </a:defRPr>
+            </a:lvl5pPr>
+            <a:lvl6pPr lvl="5" algn="ctr">
+              <a:spcBef>
+                <a:spcPts val="0"/>
+              </a:spcBef>
+              <a:spcAft>
+                <a:spcPts val="0"/>
+              </a:spcAft>
+              <a:buClr>
+                <a:schemeClr val="lt2"/>
+              </a:buClr>
+              <a:buSzPts val="16000"/>
+              <a:buNone/>
+              <a:defRPr sz="16000">
+                <a:solidFill>
+                  <a:schemeClr val="lt2"/>
+                </a:solidFill>
+              </a:defRPr>
+            </a:lvl6pPr>
+            <a:lvl7pPr lvl="6" algn="ctr">
+              <a:spcBef>
+                <a:spcPts val="0"/>
+              </a:spcBef>
+              <a:spcAft>
+                <a:spcPts val="0"/>
+              </a:spcAft>
+              <a:buClr>
+                <a:schemeClr val="lt2"/>
+              </a:buClr>
+              <a:buSzPts val="16000"/>
+              <a:buNone/>
+              <a:defRPr sz="16000">
+                <a:solidFill>
+                  <a:schemeClr val="lt2"/>
+                </a:solidFill>
+              </a:defRPr>
+            </a:lvl7pPr>
+            <a:lvl8pPr lvl="7" algn="ctr">
+              <a:spcBef>
+                <a:spcPts val="0"/>
+              </a:spcBef>
+              <a:spcAft>
+                <a:spcPts val="0"/>
+              </a:spcAft>
+              <a:buClr>
+                <a:schemeClr val="lt2"/>
+              </a:buClr>
+              <a:buSzPts val="16000"/>
+              <a:buNone/>
+              <a:defRPr sz="16000">
+                <a:solidFill>
+                  <a:schemeClr val="lt2"/>
+                </a:solidFill>
+              </a:defRPr>
+            </a:lvl8pPr>
+            <a:lvl9pPr lvl="8" algn="ctr">
+              <a:spcBef>
+                <a:spcPts val="0"/>
+              </a:spcBef>
+              <a:spcAft>
+                <a:spcPts val="0"/>
+              </a:spcAft>
+              <a:buClr>
+                <a:schemeClr val="lt2"/>
+              </a:buClr>
+              <a:buSzPts val="16000"/>
+              <a:buNone/>
+              <a:defRPr sz="16000">
+                <a:solidFill>
+                  <a:schemeClr val="lt2"/>
+                </a:solidFill>
+              </a:defRPr>
+            </a:lvl9pPr>
+          </a:lstStyle>
+          <a:p>
+            <a:r>
+              <a:t>xx%</a:t>
+            </a:r>
+          </a:p>
+        </p:txBody>
+      </p:sp>
+      <p:sp>
+        <p:nvSpPr>
+          <p:cNvPr id="54" name="Google Shape;54;p11"/>
+          <p:cNvSpPr txBox="1">
+            <a:spLocks noGrp="1"/>
+          </p:cNvSpPr>
+          <p:nvPr>
+            <p:ph type="body" idx="1"/>
+          </p:nvPr>
+        </p:nvSpPr>
+        <p:spPr>
+          <a:xfrm>
+            <a:off x="311700" y="4216000"/>
+            <a:ext cx="8520600" cy="1428900"/>
+          </a:xfrm>
+          <a:prstGeom prst="rect">
+            <a:avLst/>
+          </a:prstGeom>
+        </p:spPr>
+        <p:txBody>
+          <a:bodyPr spcFirstLastPara="1" wrap="square" lIns="91425" tIns="91425" rIns="91425" bIns="91425" anchor="t" anchorCtr="0">
+            <a:noAutofit/>
+          </a:bodyPr>
+          <a:lstStyle>
+            <a:lvl1pPr marL="457200" lvl="0" indent="-342900" algn="ctr">
+              <a:spcBef>
+                <a:spcPts val="0"/>
+              </a:spcBef>
+              <a:spcAft>
+                <a:spcPts val="0"/>
+              </a:spcAft>
+              <a:buSzPts val="1800"/>
+              <a:buChar char="●"/>
+              <a:defRPr/>
+            </a:lvl1pPr>
+            <a:lvl2pPr marL="914400" lvl="1" indent="-317500" algn="ctr">
+              <a:spcBef>
+                <a:spcPts val="1600"/>
+              </a:spcBef>
+              <a:spcAft>
+                <a:spcPts val="0"/>
+              </a:spcAft>
+              <a:buSzPts val="1400"/>
+              <a:buChar char="○"/>
+              <a:defRPr/>
+            </a:lvl2pPr>
+            <a:lvl3pPr marL="1371600" lvl="2" indent="-317500" algn="ctr">
+              <a:spcBef>
+                <a:spcPts val="1600"/>
+              </a:spcBef>
+              <a:spcAft>
+                <a:spcPts val="0"/>
+              </a:spcAft>
+              <a:buSzPts val="1400"/>
+              <a:buChar char="■"/>
+              <a:defRPr/>
+            </a:lvl3pPr>
+            <a:lvl4pPr marL="1828800" lvl="3" indent="-317500" algn="ctr">
+              <a:spcBef>
+                <a:spcPts val="1600"/>
+              </a:spcBef>
+              <a:spcAft>
+                <a:spcPts val="0"/>
+              </a:spcAft>
+              <a:buSzPts val="1400"/>
+              <a:buChar char="●"/>
+              <a:defRPr/>
+            </a:lvl4pPr>
+            <a:lvl5pPr marL="2286000" lvl="4" indent="-317500" algn="ctr">
+              <a:spcBef>
+                <a:spcPts val="1600"/>
+              </a:spcBef>
+              <a:spcAft>
+                <a:spcPts val="0"/>
+              </a:spcAft>
+              <a:buSzPts val="1400"/>
+              <a:buChar char="○"/>
+              <a:defRPr/>
+            </a:lvl5pPr>
+            <a:lvl6pPr marL="2743200" lvl="5" indent="-317500" algn="ctr">
+              <a:spcBef>
+                <a:spcPts val="1600"/>
+              </a:spcBef>
+              <a:spcAft>
+                <a:spcPts val="0"/>
+              </a:spcAft>
+              <a:buSzPts val="1400"/>
+              <a:buChar char="■"/>
+              <a:defRPr/>
+            </a:lvl6pPr>
+            <a:lvl7pPr marL="3200400" lvl="6" indent="-317500" algn="ctr">
+              <a:spcBef>
+                <a:spcPts val="1600"/>
+              </a:spcBef>
+              <a:spcAft>
+                <a:spcPts val="0"/>
+              </a:spcAft>
+              <a:buSzPts val="1400"/>
+              <a:buChar char="●"/>
+              <a:defRPr/>
+            </a:lvl7pPr>
+            <a:lvl8pPr marL="3657600" lvl="7" indent="-317500" algn="ctr">
+              <a:spcBef>
+                <a:spcPts val="1600"/>
+              </a:spcBef>
+              <a:spcAft>
+                <a:spcPts val="0"/>
+              </a:spcAft>
+              <a:buSzPts val="1400"/>
+              <a:buChar char="○"/>
+              <a:defRPr/>
+            </a:lvl8pPr>
+            <a:lvl9pPr marL="4114800" lvl="8" indent="-317500" algn="ctr">
+              <a:spcBef>
+                <a:spcPts val="1600"/>
+              </a:spcBef>
+              <a:spcAft>
+                <a:spcPts val="1600"/>
+              </a:spcAft>
+              <a:buSzPts val="1400"/>
+              <a:buChar char="■"/>
+              <a:defRPr/>
+            </a:lvl9pPr>
+          </a:lstStyle>
+          <a:p>
+            <a:endParaRPr/>
+          </a:p>
+        </p:txBody>
+      </p:sp>
+      <p:sp>
+        <p:nvSpPr>
+          <p:cNvPr id="55" name="Google Shape;55;p11"/>
+          <p:cNvSpPr txBox="1">
+            <a:spLocks noGrp="1"/>
+          </p:cNvSpPr>
+          <p:nvPr>
+            <p:ph type="sldNum" idx="12"/>
+          </p:nvPr>
+        </p:nvSpPr>
+        <p:spPr>
+          <a:xfrm>
+            <a:off x="8472458" y="6217622"/>
+            <a:ext cx="548700" cy="524700"/>
+          </a:xfrm>
+          <a:prstGeom prst="rect">
+            <a:avLst/>
+          </a:prstGeom>
+        </p:spPr>
+        <p:txBody>
+          <a:bodyPr spcFirstLastPara="1" wrap="square" lIns="91425" tIns="91425" rIns="91425" bIns="91425" anchor="ctr" anchorCtr="0">
+            <a:noAutofit/>
+          </a:bodyPr>
+          <a:lstStyle>
+            <a:lvl1pPr lvl="0">
+              <a:buNone/>
+              <a:defRPr/>
+            </a:lvl1pPr>
+            <a:lvl2pPr lvl="1">
+              <a:buNone/>
+              <a:defRPr/>
+            </a:lvl2pPr>
+            <a:lvl3pPr lvl="2">
+              <a:buNone/>
+              <a:defRPr/>
+            </a:lvl3pPr>
+            <a:lvl4pPr lvl="3">
+              <a:buNone/>
+              <a:defRPr/>
+            </a:lvl4pPr>
+            <a:lvl5pPr lvl="4">
+              <a:buNone/>
+              <a:defRPr/>
+            </a:lvl5pPr>
+            <a:lvl6pPr lvl="5">
+              <a:buNone/>
+              <a:defRPr/>
+            </a:lvl6pPr>
+            <a:lvl7pPr lvl="6">
+              <a:buNone/>
+              <a:defRPr/>
+            </a:lvl7pPr>
+            <a:lvl8pPr lvl="7">
+              <a:buNone/>
+              <a:defRPr/>
+            </a:lvl8pPr>
+            <a:lvl9pPr lvl="8">
+              <a:buNone/>
+              <a:defRPr/>
+            </a:lvl9pPr>
+          </a:lstStyle>
+          <a:p>
+            <a:pPr marL="0" lvl="0" indent="0" algn="r" rtl="0">
+              <a:spcBef>
+                <a:spcPts val="0"/>
+              </a:spcBef>
+              <a:spcAft>
+                <a:spcPts val="0"/>
+              </a:spcAft>
+              <a:buNone/>
+            </a:pPr>
+            <a:fld id="{00000000-1234-1234-1234-123412341234}" type="slidenum">
+              <a:rPr lang="en-GB"/>
+              <a:t>‹N›</a:t>
             </a:fld>
             <a:endParaRPr/>
           </a:p>
@@ -9271,7 +8619,7 @@
             </a:pPr>
             <a:fld id="{00000000-1234-1234-1234-123412341234}" type="slidenum">
               <a:rPr lang="en-GB"/>
-              <a:t>‹#›</a:t>
+              <a:t>‹N›</a:t>
             </a:fld>
             <a:endParaRPr/>
           </a:p>
@@ -9282,16 +8630,15 @@
   <p:clrMap bg1="lt1" tx1="dk1" bg2="dk2" tx2="lt2" accent1="accent1" accent2="accent2" accent3="accent3" accent4="accent4" accent5="accent5" accent6="accent6" hlink="hlink" folHlink="folHlink"/>
   <p:sldLayoutIdLst>
     <p:sldLayoutId id="2147483648" r:id="rId1"/>
-    <p:sldLayoutId id="2147483649" r:id="rId2"/>
-    <p:sldLayoutId id="2147483650" r:id="rId3"/>
-    <p:sldLayoutId id="2147483651" r:id="rId4"/>
-    <p:sldLayoutId id="2147483652" r:id="rId5"/>
-    <p:sldLayoutId id="2147483653" r:id="rId6"/>
-    <p:sldLayoutId id="2147483654" r:id="rId7"/>
-    <p:sldLayoutId id="2147483655" r:id="rId8"/>
-    <p:sldLayoutId id="2147483656" r:id="rId9"/>
-    <p:sldLayoutId id="2147483657" r:id="rId10"/>
-    <p:sldLayoutId id="2147483658" r:id="rId11"/>
+    <p:sldLayoutId id="2147483650" r:id="rId2"/>
+    <p:sldLayoutId id="2147483651" r:id="rId3"/>
+    <p:sldLayoutId id="2147483652" r:id="rId4"/>
+    <p:sldLayoutId id="2147483653" r:id="rId5"/>
+    <p:sldLayoutId id="2147483654" r:id="rId6"/>
+    <p:sldLayoutId id="2147483655" r:id="rId7"/>
+    <p:sldLayoutId id="2147483656" r:id="rId8"/>
+    <p:sldLayoutId id="2147483657" r:id="rId9"/>
+    <p:sldLayoutId id="2147483658" r:id="rId10"/>
   </p:sldLayoutIdLst>
   <p:hf sldNum="0" hdr="0" ftr="0" dt="0"/>
   <p:txStyles>
@@ -11823,8 +11170,13 @@
             </a:pPr>
             <a:r>
               <a:rPr lang="en-GB" dirty="0"/>
-              <a:t>Each module can have its own set of variables, functions, and objects, which are scoped to that module and not accessible globally unless explicitly exported. </a:t>
-            </a:r>
+              <a:t>Each module can have its own set of variables, functions, and objects, which are scoped to that module and not accessible globally unless </a:t>
+            </a:r>
+            <a:r>
+              <a:rPr lang="en-GB"/>
+              <a:t>explicitly exported </a:t>
+            </a:r>
+            <a:endParaRPr lang="en-GB" dirty="0"/>
           </a:p>
           <a:p>
             <a:pPr marL="457200" marR="0" lvl="0" indent="-336550" algn="l" rtl="0">
@@ -13735,16 +13087,6 @@
               </a:rPr>
             </a:br>
             <a:r>
-              <a:rPr lang="en-GB" sz="1200" b="0" dirty="0">
-                <a:solidFill>
-                  <a:srgbClr val="3B3B3B"/>
-                </a:solidFill>
-                <a:effectLst/>
-                <a:latin typeface="Menlo" panose="020B0609030804020204" pitchFamily="49" charset="0"/>
-              </a:rPr>
-              <a:t>	</a:t>
-            </a:r>
-            <a:r>
               <a:rPr lang="en-GB" sz="1200" b="0" dirty="0" err="1">
                 <a:solidFill>
                   <a:srgbClr val="0000FF"/>
@@ -14377,7 +13719,7 @@
                 <a:effectLst/>
                 <a:latin typeface="Menlo" panose="020B0609030804020204" pitchFamily="49" charset="0"/>
               </a:rPr>
-              <a:t>		return</a:t>
+              <a:t>	return</a:t>
             </a:r>
             <a:r>
               <a:rPr lang="en-GB" sz="1200" b="0" dirty="0">
@@ -24602,36 +23944,6 @@
           </a:p>
         </p:txBody>
       </p:sp>
-      <p:pic>
-        <p:nvPicPr>
-          <p:cNvPr id="164" name="Google Shape;164;p25">
-            <a:hlinkClick r:id="rId3"/>
-          </p:cNvPr>
-          <p:cNvPicPr preferRelativeResize="0"/>
-          <p:nvPr/>
-        </p:nvPicPr>
-        <p:blipFill>
-          <a:blip r:embed="rId4">
-            <a:alphaModFix/>
-          </a:blip>
-          <a:stretch>
-            <a:fillRect/>
-          </a:stretch>
-        </p:blipFill>
-        <p:spPr>
-          <a:xfrm>
-            <a:off x="8653459" y="5700891"/>
-            <a:ext cx="296550" cy="256250"/>
-          </a:xfrm>
-          <a:prstGeom prst="rect">
-            <a:avLst/>
-          </a:prstGeom>
-          <a:noFill/>
-          <a:ln>
-            <a:noFill/>
-          </a:ln>
-        </p:spPr>
-      </p:pic>
     </p:spTree>
   </p:cSld>
   <p:clrMapOvr>
@@ -25537,7 +24849,7 @@
                 <a:effectLst/>
                 <a:latin typeface="Menlo" panose="020B0609030804020204" pitchFamily="49" charset="0"/>
               </a:rPr>
-              <a:t>greet</a:t>
+              <a:t>greet: function</a:t>
             </a:r>
             <a:r>
               <a:rPr lang="en-GB" sz="1050" b="0" dirty="0">
@@ -25836,7 +25148,7 @@
             </a:r>
             <a:r>
               <a:rPr lang="en-GB" dirty="0"/>
-              <a:t> keyword, to create multiple instances with shared properties and methods:</a:t>
+              <a:t> keyword, to create multiple instances with shared properties and methods</a:t>
             </a:r>
           </a:p>
           <a:p>
@@ -26136,319 +25448,6 @@
                   <a:srgbClr val="0000FF"/>
                 </a:solidFill>
                 <a:effectLst/>
-                <a:latin typeface="Menlo" panose="020B0609030804020204" pitchFamily="49" charset="0"/>
-              </a:rPr>
-              <a:t>		  </a:t>
-            </a:r>
-            <a:r>
-              <a:rPr lang="en-GB" sz="1000" b="0" dirty="0" err="1">
-                <a:solidFill>
-                  <a:srgbClr val="0000FF"/>
-                </a:solidFill>
-                <a:effectLst/>
-                <a:latin typeface="Menlo" panose="020B0609030804020204" pitchFamily="49" charset="0"/>
-              </a:rPr>
-              <a:t>this</a:t>
-            </a:r>
-            <a:r>
-              <a:rPr lang="en-GB" sz="1000" b="0" dirty="0" err="1">
-                <a:solidFill>
-                  <a:srgbClr val="3B3B3B"/>
-                </a:solidFill>
-                <a:effectLst/>
-                <a:latin typeface="Menlo" panose="020B0609030804020204" pitchFamily="49" charset="0"/>
-              </a:rPr>
-              <a:t>.</a:t>
-            </a:r>
-            <a:r>
-              <a:rPr lang="en-GB" sz="1000" b="0" dirty="0" err="1">
-                <a:solidFill>
-                  <a:srgbClr val="795E26"/>
-                </a:solidFill>
-                <a:effectLst/>
-                <a:latin typeface="Menlo" panose="020B0609030804020204" pitchFamily="49" charset="0"/>
-              </a:rPr>
-              <a:t>greet</a:t>
-            </a:r>
-            <a:r>
-              <a:rPr lang="en-GB" sz="1000" b="0" dirty="0">
-                <a:solidFill>
-                  <a:srgbClr val="3B3B3B"/>
-                </a:solidFill>
-                <a:effectLst/>
-                <a:latin typeface="Menlo" panose="020B0609030804020204" pitchFamily="49" charset="0"/>
-              </a:rPr>
-              <a:t> </a:t>
-            </a:r>
-            <a:r>
-              <a:rPr lang="en-GB" sz="1000" b="0" dirty="0">
-                <a:solidFill>
-                  <a:srgbClr val="000000"/>
-                </a:solidFill>
-                <a:effectLst/>
-                <a:latin typeface="Menlo" panose="020B0609030804020204" pitchFamily="49" charset="0"/>
-              </a:rPr>
-              <a:t>=</a:t>
-            </a:r>
-            <a:r>
-              <a:rPr lang="en-GB" sz="1000" b="0" dirty="0">
-                <a:solidFill>
-                  <a:srgbClr val="3B3B3B"/>
-                </a:solidFill>
-                <a:effectLst/>
-                <a:latin typeface="Menlo" panose="020B0609030804020204" pitchFamily="49" charset="0"/>
-              </a:rPr>
-              <a:t> </a:t>
-            </a:r>
-            <a:r>
-              <a:rPr lang="en-GB" sz="1000" b="0" dirty="0">
-                <a:solidFill>
-                  <a:srgbClr val="0000FF"/>
-                </a:solidFill>
-                <a:effectLst/>
-                <a:latin typeface="Menlo" panose="020B0609030804020204" pitchFamily="49" charset="0"/>
-              </a:rPr>
-              <a:t>function</a:t>
-            </a:r>
-            <a:r>
-              <a:rPr lang="en-GB" sz="1000" b="0" dirty="0">
-                <a:solidFill>
-                  <a:srgbClr val="3B3B3B"/>
-                </a:solidFill>
-                <a:effectLst/>
-                <a:latin typeface="Menlo" panose="020B0609030804020204" pitchFamily="49" charset="0"/>
-              </a:rPr>
-              <a:t>() {</a:t>
-            </a:r>
-          </a:p>
-          <a:p>
-            <a:pPr>
-              <a:lnSpc>
-                <a:spcPts val="1350"/>
-              </a:lnSpc>
-              <a:buNone/>
-            </a:pPr>
-            <a:r>
-              <a:rPr lang="en-GB" sz="1000" b="0" dirty="0">
-                <a:solidFill>
-                  <a:srgbClr val="001080"/>
-                </a:solidFill>
-                <a:effectLst/>
-                <a:latin typeface="Menlo" panose="020B0609030804020204" pitchFamily="49" charset="0"/>
-              </a:rPr>
-              <a:t>		    </a:t>
-            </a:r>
-            <a:r>
-              <a:rPr lang="en-GB" sz="1000" b="0" dirty="0" err="1">
-                <a:solidFill>
-                  <a:srgbClr val="001080"/>
-                </a:solidFill>
-                <a:effectLst/>
-                <a:latin typeface="Menlo" panose="020B0609030804020204" pitchFamily="49" charset="0"/>
-              </a:rPr>
-              <a:t>console</a:t>
-            </a:r>
-            <a:r>
-              <a:rPr lang="en-GB" sz="1000" b="0" dirty="0" err="1">
-                <a:solidFill>
-                  <a:srgbClr val="3B3B3B"/>
-                </a:solidFill>
-                <a:effectLst/>
-                <a:latin typeface="Menlo" panose="020B0609030804020204" pitchFamily="49" charset="0"/>
-              </a:rPr>
-              <a:t>.</a:t>
-            </a:r>
-            <a:r>
-              <a:rPr lang="en-GB" sz="1000" b="0" dirty="0" err="1">
-                <a:solidFill>
-                  <a:srgbClr val="795E26"/>
-                </a:solidFill>
-                <a:effectLst/>
-                <a:latin typeface="Menlo" panose="020B0609030804020204" pitchFamily="49" charset="0"/>
-              </a:rPr>
-              <a:t>log</a:t>
-            </a:r>
-            <a:r>
-              <a:rPr lang="en-GB" sz="1000" b="0" dirty="0">
-                <a:solidFill>
-                  <a:srgbClr val="3B3B3B"/>
-                </a:solidFill>
-                <a:effectLst/>
-                <a:latin typeface="Menlo" panose="020B0609030804020204" pitchFamily="49" charset="0"/>
-              </a:rPr>
-              <a:t>(</a:t>
-            </a:r>
-            <a:r>
-              <a:rPr lang="en-GB" sz="1000" b="0" dirty="0">
-                <a:solidFill>
-                  <a:srgbClr val="A31515"/>
-                </a:solidFill>
-                <a:effectLst/>
-                <a:latin typeface="Menlo" panose="020B0609030804020204" pitchFamily="49" charset="0"/>
-              </a:rPr>
-              <a:t>`Hello, my name is </a:t>
-            </a:r>
-            <a:r>
-              <a:rPr lang="en-GB" sz="1000" b="0" dirty="0">
-                <a:solidFill>
-                  <a:srgbClr val="0000FF"/>
-                </a:solidFill>
-                <a:effectLst/>
-                <a:latin typeface="Menlo" panose="020B0609030804020204" pitchFamily="49" charset="0"/>
-              </a:rPr>
-              <a:t>${</a:t>
-            </a:r>
-            <a:r>
-              <a:rPr lang="en-GB" sz="1000" b="0" dirty="0" err="1">
-                <a:solidFill>
-                  <a:srgbClr val="0000FF"/>
-                </a:solidFill>
-                <a:effectLst/>
-                <a:latin typeface="Menlo" panose="020B0609030804020204" pitchFamily="49" charset="0"/>
-              </a:rPr>
-              <a:t>this</a:t>
-            </a:r>
-            <a:r>
-              <a:rPr lang="en-GB" sz="1000" b="0" dirty="0" err="1">
-                <a:solidFill>
-                  <a:srgbClr val="000000"/>
-                </a:solidFill>
-                <a:effectLst/>
-                <a:latin typeface="Menlo" panose="020B0609030804020204" pitchFamily="49" charset="0"/>
-              </a:rPr>
-              <a:t>.</a:t>
-            </a:r>
-            <a:r>
-              <a:rPr lang="en-GB" sz="1000" b="0" dirty="0" err="1">
-                <a:solidFill>
-                  <a:srgbClr val="001080"/>
-                </a:solidFill>
-                <a:effectLst/>
-                <a:latin typeface="Menlo" panose="020B0609030804020204" pitchFamily="49" charset="0"/>
-              </a:rPr>
-              <a:t>name</a:t>
-            </a:r>
-            <a:r>
-              <a:rPr lang="en-GB" sz="1000" b="0" dirty="0">
-                <a:solidFill>
-                  <a:srgbClr val="0000FF"/>
-                </a:solidFill>
-                <a:effectLst/>
-                <a:latin typeface="Menlo" panose="020B0609030804020204" pitchFamily="49" charset="0"/>
-              </a:rPr>
-              <a:t>}</a:t>
-            </a:r>
-            <a:r>
-              <a:rPr lang="en-GB" sz="1000" b="0" dirty="0">
-                <a:solidFill>
-                  <a:srgbClr val="A31515"/>
-                </a:solidFill>
-                <a:effectLst/>
-                <a:latin typeface="Menlo" panose="020B0609030804020204" pitchFamily="49" charset="0"/>
-              </a:rPr>
-              <a:t> and I am </a:t>
-            </a:r>
-            <a:r>
-              <a:rPr lang="en-GB" sz="1000" b="0" dirty="0">
-                <a:solidFill>
-                  <a:srgbClr val="0000FF"/>
-                </a:solidFill>
-                <a:effectLst/>
-                <a:latin typeface="Menlo" panose="020B0609030804020204" pitchFamily="49" charset="0"/>
-              </a:rPr>
-              <a:t>${</a:t>
-            </a:r>
-            <a:r>
-              <a:rPr lang="en-GB" sz="1000" b="0" dirty="0" err="1">
-                <a:solidFill>
-                  <a:srgbClr val="0000FF"/>
-                </a:solidFill>
-                <a:effectLst/>
-                <a:latin typeface="Menlo" panose="020B0609030804020204" pitchFamily="49" charset="0"/>
-              </a:rPr>
-              <a:t>this</a:t>
-            </a:r>
-            <a:r>
-              <a:rPr lang="en-GB" sz="1000" b="0" dirty="0" err="1">
-                <a:solidFill>
-                  <a:srgbClr val="000000"/>
-                </a:solidFill>
-                <a:effectLst/>
-                <a:latin typeface="Menlo" panose="020B0609030804020204" pitchFamily="49" charset="0"/>
-              </a:rPr>
-              <a:t>.</a:t>
-            </a:r>
-            <a:r>
-              <a:rPr lang="en-GB" sz="1000" b="0" dirty="0" err="1">
-                <a:solidFill>
-                  <a:srgbClr val="001080"/>
-                </a:solidFill>
-                <a:effectLst/>
-                <a:latin typeface="Menlo" panose="020B0609030804020204" pitchFamily="49" charset="0"/>
-              </a:rPr>
-              <a:t>age</a:t>
-            </a:r>
-            <a:r>
-              <a:rPr lang="en-GB" sz="1000" b="0" dirty="0">
-                <a:solidFill>
-                  <a:srgbClr val="0000FF"/>
-                </a:solidFill>
-                <a:effectLst/>
-                <a:latin typeface="Menlo" panose="020B0609030804020204" pitchFamily="49" charset="0"/>
-              </a:rPr>
-              <a:t>}</a:t>
-            </a:r>
-            <a:r>
-              <a:rPr lang="en-GB" sz="1000" b="0" dirty="0">
-                <a:solidFill>
-                  <a:srgbClr val="A31515"/>
-                </a:solidFill>
-                <a:effectLst/>
-                <a:latin typeface="Menlo" panose="020B0609030804020204" pitchFamily="49" charset="0"/>
-              </a:rPr>
-              <a:t> years old.`</a:t>
-            </a:r>
-            <a:r>
-              <a:rPr lang="en-GB" sz="1000" b="0" dirty="0">
-                <a:solidFill>
-                  <a:srgbClr val="3B3B3B"/>
-                </a:solidFill>
-                <a:effectLst/>
-                <a:latin typeface="Menlo" panose="020B0609030804020204" pitchFamily="49" charset="0"/>
-              </a:rPr>
-              <a:t>);</a:t>
-            </a:r>
-          </a:p>
-          <a:p>
-            <a:pPr>
-              <a:lnSpc>
-                <a:spcPts val="1350"/>
-              </a:lnSpc>
-              <a:buNone/>
-            </a:pPr>
-            <a:r>
-              <a:rPr lang="en-GB" sz="1000" b="0" dirty="0">
-                <a:solidFill>
-                  <a:srgbClr val="3B3B3B"/>
-                </a:solidFill>
-                <a:effectLst/>
-                <a:latin typeface="Menlo" panose="020B0609030804020204" pitchFamily="49" charset="0"/>
-              </a:rPr>
-              <a:t>		  };</a:t>
-            </a:r>
-          </a:p>
-          <a:p>
-            <a:pPr>
-              <a:lnSpc>
-                <a:spcPts val="1350"/>
-              </a:lnSpc>
-              <a:buNone/>
-            </a:pPr>
-            <a:r>
-              <a:rPr lang="en-GB" sz="1000" dirty="0">
-                <a:solidFill>
-                  <a:srgbClr val="3B3B3B"/>
-                </a:solidFill>
                 <a:latin typeface="Menlo" panose="020B0609030804020204" pitchFamily="49" charset="0"/>
               </a:rPr>
               <a:t>		</a:t>
@@ -26954,36 +25953,6 @@
           </a:p>
         </p:txBody>
       </p:sp>
-      <p:pic>
-        <p:nvPicPr>
-          <p:cNvPr id="173" name="Google Shape;173;p26">
-            <a:hlinkClick r:id="rId3"/>
-          </p:cNvPr>
-          <p:cNvPicPr preferRelativeResize="0"/>
-          <p:nvPr/>
-        </p:nvPicPr>
-        <p:blipFill>
-          <a:blip r:embed="rId4">
-            <a:alphaModFix/>
-          </a:blip>
-          <a:stretch>
-            <a:fillRect/>
-          </a:stretch>
-        </p:blipFill>
-        <p:spPr>
-          <a:xfrm>
-            <a:off x="2906804" y="4730865"/>
-            <a:ext cx="296550" cy="256250"/>
-          </a:xfrm>
-          <a:prstGeom prst="rect">
-            <a:avLst/>
-          </a:prstGeom>
-          <a:noFill/>
-          <a:ln>
-            <a:noFill/>
-          </a:ln>
-        </p:spPr>
-      </p:pic>
     </p:spTree>
   </p:cSld>
   <p:clrMapOvr>
@@ -28651,39 +27620,39 @@
                 <a:effectLst/>
                 <a:latin typeface="Menlo" panose="020B0609030804020204" pitchFamily="49" charset="0"/>
               </a:rPr>
-              <a:t>		class</a:t>
-            </a:r>
-            <a:r>
-              <a:rPr lang="en-GB" sz="1200" b="0" dirty="0">
-                <a:solidFill>
-                  <a:srgbClr val="3B3B3B"/>
-                </a:solidFill>
-                <a:effectLst/>
-                <a:latin typeface="Menlo" panose="020B0609030804020204" pitchFamily="49" charset="0"/>
-              </a:rPr>
-              <a:t> </a:t>
-            </a:r>
-            <a:r>
-              <a:rPr lang="en-GB" sz="1200" b="0" dirty="0">
-                <a:solidFill>
-                  <a:srgbClr val="267F99"/>
-                </a:solidFill>
-                <a:effectLst/>
-                <a:latin typeface="Menlo" panose="020B0609030804020204" pitchFamily="49" charset="0"/>
-              </a:rPr>
-              <a:t>Animal</a:t>
-            </a:r>
-            <a:r>
-              <a:rPr lang="en-GB" sz="1200" b="0" dirty="0">
-                <a:solidFill>
-                  <a:srgbClr val="3B3B3B"/>
-                </a:solidFill>
-                <a:effectLst/>
-                <a:latin typeface="Menlo" panose="020B0609030804020204" pitchFamily="49" charset="0"/>
-              </a:rPr>
-              <a:t> {</a:t>
-            </a:r>
-          </a:p>
+              <a:t>		</a:t>
+            </a:r>
+            <a:endParaRPr dirty="0"/>
+          </a:p>
+        </p:txBody>
+      </p:sp>
+      <p:sp>
+        <p:nvSpPr>
+          <p:cNvPr id="3" name="CasellaDiTesto 2">
+            <a:extLst>
+              <a:ext uri="{FF2B5EF4-FFF2-40B4-BE49-F238E27FC236}">
+                <a16:creationId xmlns:a16="http://schemas.microsoft.com/office/drawing/2014/main" id="{ED1F4048-CBE4-17A9-ECDF-2A16E63ECE27}"/>
+              </a:ext>
+            </a:extLst>
+          </p:cNvPr>
+          <p:cNvSpPr txBox="1"/>
+          <p:nvPr/>
+        </p:nvSpPr>
+        <p:spPr>
+          <a:xfrm>
+            <a:off x="597048" y="2941916"/>
+            <a:ext cx="7783158" cy="3323987"/>
+          </a:xfrm>
+          <a:prstGeom prst="rect">
+            <a:avLst/>
+          </a:prstGeom>
+          <a:noFill/>
+        </p:spPr>
+        <p:txBody>
+          <a:bodyPr wrap="square">
+            <a:spAutoFit/>
+          </a:bodyPr>
+          <a:lstStyle/>
           <a:p>
             <a:pPr>
               <a:lnSpc>
@@ -28692,24 +27661,44 @@
               <a:buNone/>
             </a:pPr>
             <a:r>
-              <a:rPr lang="en-GB" sz="1200" b="0" dirty="0">
-                <a:solidFill>
-                  <a:srgbClr val="795E26"/>
-                </a:solidFill>
-                <a:effectLst/>
-                <a:latin typeface="Menlo" panose="020B0609030804020204" pitchFamily="49" charset="0"/>
-              </a:rPr>
-              <a:t>		  speak</a:t>
-            </a:r>
-            <a:r>
-              <a:rPr lang="en-GB" sz="1200" b="0" dirty="0">
-                <a:solidFill>
-                  <a:srgbClr val="3B3B3B"/>
-                </a:solidFill>
-                <a:effectLst/>
-                <a:latin typeface="Menlo" panose="020B0609030804020204" pitchFamily="49" charset="0"/>
-              </a:rPr>
-              <a:t>() {</a:t>
+              <a:rPr lang="it-IT" b="0" dirty="0" err="1">
+                <a:solidFill>
+                  <a:srgbClr val="0000FF"/>
+                </a:solidFill>
+                <a:effectLst/>
+                <a:latin typeface="Menlo" panose="020B0609030804020204" pitchFamily="49" charset="0"/>
+              </a:rPr>
+              <a:t>const</a:t>
+            </a:r>
+            <a:r>
+              <a:rPr lang="it-IT" b="0" dirty="0">
+                <a:solidFill>
+                  <a:srgbClr val="000000"/>
+                </a:solidFill>
+                <a:effectLst/>
+                <a:latin typeface="Menlo" panose="020B0609030804020204" pitchFamily="49" charset="0"/>
+              </a:rPr>
+              <a:t> </a:t>
+            </a:r>
+            <a:r>
+              <a:rPr lang="it-IT" b="0" dirty="0">
+                <a:solidFill>
+                  <a:srgbClr val="0070C1"/>
+                </a:solidFill>
+                <a:effectLst/>
+                <a:latin typeface="Menlo" panose="020B0609030804020204" pitchFamily="49" charset="0"/>
+              </a:rPr>
+              <a:t>dog</a:t>
+            </a:r>
+            <a:r>
+              <a:rPr lang="it-IT" b="0" dirty="0">
+                <a:solidFill>
+                  <a:srgbClr val="000000"/>
+                </a:solidFill>
+                <a:effectLst/>
+                <a:latin typeface="Menlo" panose="020B0609030804020204" pitchFamily="49" charset="0"/>
+              </a:rPr>
+              <a:t> = {</a:t>
             </a:r>
           </a:p>
           <a:p>
@@ -28720,17 +27709,67 @@
               <a:buNone/>
             </a:pPr>
             <a:r>
-              <a:rPr lang="en-GB" sz="1200" b="0" dirty="0">
+              <a:rPr lang="it-IT" b="0" dirty="0">
+                <a:solidFill>
+                  <a:srgbClr val="795E26"/>
+                </a:solidFill>
+                <a:effectLst/>
+                <a:latin typeface="Menlo" panose="020B0609030804020204" pitchFamily="49" charset="0"/>
+              </a:rPr>
+              <a:t>   </a:t>
+            </a:r>
+            <a:r>
+              <a:rPr lang="it-IT" b="0" dirty="0" err="1">
+                <a:solidFill>
+                  <a:srgbClr val="795E26"/>
+                </a:solidFill>
+                <a:effectLst/>
+                <a:latin typeface="Menlo" panose="020B0609030804020204" pitchFamily="49" charset="0"/>
+              </a:rPr>
+              <a:t>speak</a:t>
+            </a:r>
+            <a:r>
+              <a:rPr lang="it-IT" b="0" dirty="0">
                 <a:solidFill>
                   <a:srgbClr val="001080"/>
                 </a:solidFill>
                 <a:effectLst/>
                 <a:latin typeface="Menlo" panose="020B0609030804020204" pitchFamily="49" charset="0"/>
               </a:rPr>
-              <a:t>		    </a:t>
-            </a:r>
-            <a:r>
-              <a:rPr lang="en-GB" sz="1200" b="0" dirty="0" err="1">
+              <a:t>:</a:t>
+            </a:r>
+            <a:r>
+              <a:rPr lang="it-IT" b="0" dirty="0">
+                <a:solidFill>
+                  <a:srgbClr val="000000"/>
+                </a:solidFill>
+                <a:effectLst/>
+                <a:latin typeface="Menlo" panose="020B0609030804020204" pitchFamily="49" charset="0"/>
+              </a:rPr>
+              <a:t> </a:t>
+            </a:r>
+            <a:r>
+              <a:rPr lang="it-IT" b="0" dirty="0" err="1">
+                <a:solidFill>
+                  <a:srgbClr val="0000FF"/>
+                </a:solidFill>
+                <a:effectLst/>
+                <a:latin typeface="Menlo" panose="020B0609030804020204" pitchFamily="49" charset="0"/>
+              </a:rPr>
+              <a:t>function</a:t>
+            </a:r>
+            <a:r>
+              <a:rPr lang="it-IT" b="0" dirty="0">
+                <a:solidFill>
+                  <a:srgbClr val="000000"/>
+                </a:solidFill>
+                <a:effectLst/>
+                <a:latin typeface="Menlo" panose="020B0609030804020204" pitchFamily="49" charset="0"/>
+              </a:rPr>
+              <a:t>() { </a:t>
+            </a:r>
+            <a:r>
+              <a:rPr lang="it-IT" b="0" dirty="0" err="1">
                 <a:solidFill>
                   <a:srgbClr val="001080"/>
                 </a:solidFill>
@@ -28740,9 +27779,9 @@
               <a:t>console</a:t>
             </a:r>
             <a:r>
-              <a:rPr lang="en-GB" sz="1200" b="0" dirty="0" err="1">
-                <a:solidFill>
-                  <a:srgbClr val="3B3B3B"/>
+              <a:rPr lang="it-IT" b="0" dirty="0" err="1">
+                <a:solidFill>
+                  <a:srgbClr val="000000"/>
                 </a:solidFill>
                 <a:effectLst/>
                 <a:latin typeface="Menlo" panose="020B0609030804020204" pitchFamily="49" charset="0"/>
@@ -28750,7 +27789,7 @@
               <a:t>.</a:t>
             </a:r>
             <a:r>
-              <a:rPr lang="en-GB" sz="1200" b="0" dirty="0" err="1">
+              <a:rPr lang="it-IT" b="0" dirty="0" err="1">
                 <a:solidFill>
                   <a:srgbClr val="795E26"/>
                 </a:solidFill>
@@ -28760,9 +27799,9 @@
               <a:t>log</a:t>
             </a:r>
             <a:r>
-              <a:rPr lang="en-GB" sz="1200" b="0" dirty="0">
-                <a:solidFill>
-                  <a:srgbClr val="3B3B3B"/>
+              <a:rPr lang="it-IT" b="0" dirty="0">
+                <a:solidFill>
+                  <a:srgbClr val="000000"/>
                 </a:solidFill>
                 <a:effectLst/>
                 <a:latin typeface="Menlo" panose="020B0609030804020204" pitchFamily="49" charset="0"/>
@@ -28770,24 +27809,44 @@
               <a:t>(</a:t>
             </a:r>
             <a:r>
-              <a:rPr lang="en-GB" sz="1200" b="0" dirty="0">
+              <a:rPr lang="it-IT" b="0" dirty="0">
                 <a:solidFill>
                   <a:srgbClr val="A31515"/>
                 </a:solidFill>
                 <a:effectLst/>
                 <a:latin typeface="Menlo" panose="020B0609030804020204" pitchFamily="49" charset="0"/>
               </a:rPr>
-              <a:t>"Animal makes a sound"</a:t>
-            </a:r>
-            <a:r>
-              <a:rPr lang="en-GB" sz="1200" b="0" dirty="0">
-                <a:solidFill>
-                  <a:srgbClr val="3B3B3B"/>
-                </a:solidFill>
-                <a:effectLst/>
-                <a:latin typeface="Menlo" panose="020B0609030804020204" pitchFamily="49" charset="0"/>
-              </a:rPr>
-              <a:t>);</a:t>
+              <a:t>"Dog </a:t>
+            </a:r>
+            <a:r>
+              <a:rPr lang="it-IT" b="0" dirty="0" err="1">
+                <a:solidFill>
+                  <a:srgbClr val="A31515"/>
+                </a:solidFill>
+                <a:effectLst/>
+                <a:latin typeface="Menlo" panose="020B0609030804020204" pitchFamily="49" charset="0"/>
+              </a:rPr>
+              <a:t>barks</a:t>
+            </a:r>
+            <a:r>
+              <a:rPr lang="it-IT" b="0" dirty="0">
+                <a:solidFill>
+                  <a:srgbClr val="A31515"/>
+                </a:solidFill>
+                <a:effectLst/>
+                <a:latin typeface="Menlo" panose="020B0609030804020204" pitchFamily="49" charset="0"/>
+              </a:rPr>
+              <a:t>"</a:t>
+            </a:r>
+            <a:r>
+              <a:rPr lang="it-IT" b="0" dirty="0">
+                <a:solidFill>
+                  <a:srgbClr val="000000"/>
+                </a:solidFill>
+                <a:effectLst/>
+                <a:latin typeface="Menlo" panose="020B0609030804020204" pitchFamily="49" charset="0"/>
+              </a:rPr>
+              <a:t>); }</a:t>
             </a:r>
           </a:p>
           <a:p>
@@ -28798,14 +27857,14 @@
               <a:buNone/>
             </a:pPr>
             <a:r>
-              <a:rPr lang="en-GB" sz="1200" b="0" dirty="0">
-                <a:solidFill>
-                  <a:srgbClr val="3B3B3B"/>
-                </a:solidFill>
-                <a:effectLst/>
-                <a:latin typeface="Menlo" panose="020B0609030804020204" pitchFamily="49" charset="0"/>
-              </a:rPr>
-              <a:t>		  }</a:t>
+              <a:rPr lang="it-IT" b="0" dirty="0">
+                <a:solidFill>
+                  <a:srgbClr val="000000"/>
+                </a:solidFill>
+                <a:effectLst/>
+                <a:latin typeface="Menlo" panose="020B0609030804020204" pitchFamily="49" charset="0"/>
+              </a:rPr>
+              <a:t>};</a:t>
             </a:r>
           </a:p>
           <a:p>
@@ -28815,16 +27874,13 @@
               </a:lnSpc>
               <a:buNone/>
             </a:pPr>
-            <a:r>
-              <a:rPr lang="en-GB" sz="1200" b="0" dirty="0">
-                <a:solidFill>
-                  <a:srgbClr val="3B3B3B"/>
-                </a:solidFill>
-                <a:effectLst/>
-                <a:latin typeface="Menlo" panose="020B0609030804020204" pitchFamily="49" charset="0"/>
-              </a:rPr>
-              <a:t>		}</a:t>
-            </a:r>
+            <a:endParaRPr lang="it-IT" b="0" dirty="0">
+              <a:solidFill>
+                <a:srgbClr val="000000"/>
+              </a:solidFill>
+              <a:effectLst/>
+              <a:latin typeface="Menlo" panose="020B0609030804020204" pitchFamily="49" charset="0"/>
+            </a:endParaRPr>
           </a:p>
           <a:p>
             <a:pPr>
@@ -28833,9 +27889,243 @@
               </a:lnSpc>
               <a:buNone/>
             </a:pPr>
-            <a:endParaRPr lang="en-GB" sz="1200" b="0" dirty="0">
+            <a:r>
+              <a:rPr lang="it-IT" b="0" dirty="0" err="1">
+                <a:solidFill>
+                  <a:srgbClr val="0000FF"/>
+                </a:solidFill>
+                <a:effectLst/>
+                <a:latin typeface="Menlo" panose="020B0609030804020204" pitchFamily="49" charset="0"/>
+              </a:rPr>
+              <a:t>const</a:t>
+            </a:r>
+            <a:r>
+              <a:rPr lang="it-IT" b="0" dirty="0">
+                <a:solidFill>
+                  <a:srgbClr val="000000"/>
+                </a:solidFill>
+                <a:effectLst/>
+                <a:latin typeface="Menlo" panose="020B0609030804020204" pitchFamily="49" charset="0"/>
+              </a:rPr>
+              <a:t> </a:t>
+            </a:r>
+            <a:r>
+              <a:rPr lang="it-IT" b="0" dirty="0" err="1">
+                <a:solidFill>
+                  <a:srgbClr val="0070C1"/>
+                </a:solidFill>
+                <a:effectLst/>
+                <a:latin typeface="Menlo" panose="020B0609030804020204" pitchFamily="49" charset="0"/>
+              </a:rPr>
+              <a:t>cat</a:t>
+            </a:r>
+            <a:r>
+              <a:rPr lang="it-IT" b="0" dirty="0">
+                <a:solidFill>
+                  <a:srgbClr val="000000"/>
+                </a:solidFill>
+                <a:effectLst/>
+                <a:latin typeface="Menlo" panose="020B0609030804020204" pitchFamily="49" charset="0"/>
+              </a:rPr>
+              <a:t> = {</a:t>
+            </a:r>
+          </a:p>
+          <a:p>
+            <a:pPr>
+              <a:lnSpc>
+                <a:spcPts val="1350"/>
+              </a:lnSpc>
+              <a:buNone/>
+            </a:pPr>
+            <a:r>
+              <a:rPr lang="it-IT" b="0" dirty="0">
+                <a:solidFill>
+                  <a:srgbClr val="795E26"/>
+                </a:solidFill>
+                <a:effectLst/>
+                <a:latin typeface="Menlo" panose="020B0609030804020204" pitchFamily="49" charset="0"/>
+              </a:rPr>
+              <a:t>   </a:t>
+            </a:r>
+            <a:r>
+              <a:rPr lang="it-IT" b="0" dirty="0" err="1">
+                <a:solidFill>
+                  <a:srgbClr val="795E26"/>
+                </a:solidFill>
+                <a:effectLst/>
+                <a:latin typeface="Menlo" panose="020B0609030804020204" pitchFamily="49" charset="0"/>
+              </a:rPr>
+              <a:t>speak</a:t>
+            </a:r>
+            <a:r>
+              <a:rPr lang="it-IT" b="0" dirty="0">
+                <a:solidFill>
+                  <a:srgbClr val="001080"/>
+                </a:solidFill>
+                <a:effectLst/>
+                <a:latin typeface="Menlo" panose="020B0609030804020204" pitchFamily="49" charset="0"/>
+              </a:rPr>
+              <a:t>:</a:t>
+            </a:r>
+            <a:r>
+              <a:rPr lang="it-IT" b="0" dirty="0">
+                <a:solidFill>
+                  <a:srgbClr val="000000"/>
+                </a:solidFill>
+                <a:effectLst/>
+                <a:latin typeface="Menlo" panose="020B0609030804020204" pitchFamily="49" charset="0"/>
+              </a:rPr>
+              <a:t> </a:t>
+            </a:r>
+            <a:r>
+              <a:rPr lang="it-IT" b="0" dirty="0" err="1">
+                <a:solidFill>
+                  <a:srgbClr val="0000FF"/>
+                </a:solidFill>
+                <a:effectLst/>
+                <a:latin typeface="Menlo" panose="020B0609030804020204" pitchFamily="49" charset="0"/>
+              </a:rPr>
+              <a:t>function</a:t>
+            </a:r>
+            <a:r>
+              <a:rPr lang="it-IT" b="0" dirty="0">
+                <a:solidFill>
+                  <a:srgbClr val="000000"/>
+                </a:solidFill>
+                <a:effectLst/>
+                <a:latin typeface="Menlo" panose="020B0609030804020204" pitchFamily="49" charset="0"/>
+              </a:rPr>
+              <a:t>() { </a:t>
+            </a:r>
+            <a:r>
+              <a:rPr lang="it-IT" b="0" dirty="0" err="1">
+                <a:solidFill>
+                  <a:srgbClr val="001080"/>
+                </a:solidFill>
+                <a:effectLst/>
+                <a:latin typeface="Menlo" panose="020B0609030804020204" pitchFamily="49" charset="0"/>
+              </a:rPr>
+              <a:t>console</a:t>
+            </a:r>
+            <a:r>
+              <a:rPr lang="it-IT" b="0" dirty="0" err="1">
+                <a:solidFill>
+                  <a:srgbClr val="000000"/>
+                </a:solidFill>
+                <a:effectLst/>
+                <a:latin typeface="Menlo" panose="020B0609030804020204" pitchFamily="49" charset="0"/>
+              </a:rPr>
+              <a:t>.</a:t>
+            </a:r>
+            <a:r>
+              <a:rPr lang="it-IT" b="0" dirty="0" err="1">
+                <a:solidFill>
+                  <a:srgbClr val="795E26"/>
+                </a:solidFill>
+                <a:effectLst/>
+                <a:latin typeface="Menlo" panose="020B0609030804020204" pitchFamily="49" charset="0"/>
+              </a:rPr>
+              <a:t>log</a:t>
+            </a:r>
+            <a:r>
+              <a:rPr lang="it-IT" b="0" dirty="0">
+                <a:solidFill>
+                  <a:srgbClr val="000000"/>
+                </a:solidFill>
+                <a:effectLst/>
+                <a:latin typeface="Menlo" panose="020B0609030804020204" pitchFamily="49" charset="0"/>
+              </a:rPr>
+              <a:t>(</a:t>
+            </a:r>
+            <a:r>
+              <a:rPr lang="it-IT" b="0" dirty="0">
+                <a:solidFill>
+                  <a:srgbClr val="A31515"/>
+                </a:solidFill>
+                <a:effectLst/>
+                <a:latin typeface="Menlo" panose="020B0609030804020204" pitchFamily="49" charset="0"/>
+              </a:rPr>
+              <a:t>"</a:t>
+            </a:r>
+            <a:r>
+              <a:rPr lang="it-IT" b="0" dirty="0" err="1">
+                <a:solidFill>
+                  <a:srgbClr val="A31515"/>
+                </a:solidFill>
+                <a:effectLst/>
+                <a:latin typeface="Menlo" panose="020B0609030804020204" pitchFamily="49" charset="0"/>
+              </a:rPr>
+              <a:t>Cat</a:t>
+            </a:r>
+            <a:r>
+              <a:rPr lang="it-IT" b="0" dirty="0">
+                <a:solidFill>
+                  <a:srgbClr val="A31515"/>
+                </a:solidFill>
+                <a:effectLst/>
+                <a:latin typeface="Menlo" panose="020B0609030804020204" pitchFamily="49" charset="0"/>
+              </a:rPr>
+              <a:t> </a:t>
+            </a:r>
+            <a:r>
+              <a:rPr lang="it-IT" b="0" dirty="0" err="1">
+                <a:solidFill>
+                  <a:srgbClr val="A31515"/>
+                </a:solidFill>
+                <a:effectLst/>
+                <a:latin typeface="Menlo" panose="020B0609030804020204" pitchFamily="49" charset="0"/>
+              </a:rPr>
+              <a:t>meows</a:t>
+            </a:r>
+            <a:r>
+              <a:rPr lang="it-IT" b="0" dirty="0">
+                <a:solidFill>
+                  <a:srgbClr val="A31515"/>
+                </a:solidFill>
+                <a:effectLst/>
+                <a:latin typeface="Menlo" panose="020B0609030804020204" pitchFamily="49" charset="0"/>
+              </a:rPr>
+              <a:t>"</a:t>
+            </a:r>
+            <a:r>
+              <a:rPr lang="it-IT" b="0" dirty="0">
+                <a:solidFill>
+                  <a:srgbClr val="000000"/>
+                </a:solidFill>
+                <a:effectLst/>
+                <a:latin typeface="Menlo" panose="020B0609030804020204" pitchFamily="49" charset="0"/>
+              </a:rPr>
+              <a:t>); }</a:t>
+            </a:r>
+          </a:p>
+          <a:p>
+            <a:pPr>
+              <a:lnSpc>
+                <a:spcPts val="1350"/>
+              </a:lnSpc>
+              <a:buNone/>
+            </a:pPr>
+            <a:r>
+              <a:rPr lang="it-IT" b="0" dirty="0">
+                <a:solidFill>
+                  <a:srgbClr val="000000"/>
+                </a:solidFill>
+                <a:effectLst/>
+                <a:latin typeface="Menlo" panose="020B0609030804020204" pitchFamily="49" charset="0"/>
+              </a:rPr>
+              <a:t>};</a:t>
+            </a:r>
+          </a:p>
+          <a:p>
+            <a:pPr>
+              <a:lnSpc>
+                <a:spcPts val="1350"/>
+              </a:lnSpc>
+              <a:buNone/>
+            </a:pPr>
+            <a:endParaRPr lang="it-IT" b="0" dirty="0">
               <a:solidFill>
-                <a:srgbClr val="0000FF"/>
+                <a:srgbClr val="000000"/>
               </a:solidFill>
               <a:effectLst/>
               <a:latin typeface="Menlo" panose="020B0609030804020204" pitchFamily="49" charset="0"/>
@@ -28849,93 +28139,154 @@
               <a:buNone/>
             </a:pPr>
             <a:r>
-              <a:rPr lang="en-GB" sz="1200" dirty="0">
+              <a:rPr lang="it-IT" b="0" dirty="0" err="1">
                 <a:solidFill>
                   <a:srgbClr val="0000FF"/>
                 </a:solidFill>
-                <a:latin typeface="Menlo" panose="020B0609030804020204" pitchFamily="49" charset="0"/>
-              </a:rPr>
-              <a:t>		</a:t>
-            </a:r>
-            <a:r>
-              <a:rPr lang="en-GB" sz="1200" b="0" dirty="0">
+                <a:effectLst/>
+                <a:latin typeface="Menlo" panose="020B0609030804020204" pitchFamily="49" charset="0"/>
+              </a:rPr>
+              <a:t>const</a:t>
+            </a:r>
+            <a:r>
+              <a:rPr lang="it-IT" b="0" dirty="0">
+                <a:solidFill>
+                  <a:srgbClr val="000000"/>
+                </a:solidFill>
+                <a:effectLst/>
+                <a:latin typeface="Menlo" panose="020B0609030804020204" pitchFamily="49" charset="0"/>
+              </a:rPr>
+              <a:t> </a:t>
+            </a:r>
+            <a:r>
+              <a:rPr lang="it-IT" b="0" dirty="0" err="1">
+                <a:solidFill>
+                  <a:srgbClr val="0070C1"/>
+                </a:solidFill>
+                <a:effectLst/>
+                <a:latin typeface="Menlo" panose="020B0609030804020204" pitchFamily="49" charset="0"/>
+              </a:rPr>
+              <a:t>bird</a:t>
+            </a:r>
+            <a:r>
+              <a:rPr lang="it-IT" b="0" dirty="0">
+                <a:solidFill>
+                  <a:srgbClr val="000000"/>
+                </a:solidFill>
+                <a:effectLst/>
+                <a:latin typeface="Menlo" panose="020B0609030804020204" pitchFamily="49" charset="0"/>
+              </a:rPr>
+              <a:t> = { </a:t>
+            </a:r>
+            <a:r>
+              <a:rPr lang="it-IT" b="0" dirty="0" err="1">
+                <a:solidFill>
+                  <a:srgbClr val="795E26"/>
+                </a:solidFill>
+                <a:effectLst/>
+                <a:latin typeface="Menlo" panose="020B0609030804020204" pitchFamily="49" charset="0"/>
+              </a:rPr>
+              <a:t>speak</a:t>
+            </a:r>
+            <a:r>
+              <a:rPr lang="it-IT" b="0" dirty="0">
+                <a:solidFill>
+                  <a:srgbClr val="001080"/>
+                </a:solidFill>
+                <a:effectLst/>
+                <a:latin typeface="Menlo" panose="020B0609030804020204" pitchFamily="49" charset="0"/>
+              </a:rPr>
+              <a:t>:</a:t>
+            </a:r>
+            <a:r>
+              <a:rPr lang="it-IT" b="0" dirty="0">
+                <a:solidFill>
+                  <a:srgbClr val="000000"/>
+                </a:solidFill>
+                <a:effectLst/>
+                <a:latin typeface="Menlo" panose="020B0609030804020204" pitchFamily="49" charset="0"/>
+              </a:rPr>
+              <a:t> </a:t>
+            </a:r>
+            <a:r>
+              <a:rPr lang="it-IT" b="0" dirty="0" err="1">
                 <a:solidFill>
                   <a:srgbClr val="0000FF"/>
                 </a:solidFill>
                 <a:effectLst/>
                 <a:latin typeface="Menlo" panose="020B0609030804020204" pitchFamily="49" charset="0"/>
               </a:rPr>
-              <a:t>class</a:t>
-            </a:r>
-            <a:r>
-              <a:rPr lang="en-GB" sz="1200" b="0" dirty="0">
-                <a:solidFill>
-                  <a:srgbClr val="3B3B3B"/>
-                </a:solidFill>
-                <a:effectLst/>
-                <a:latin typeface="Menlo" panose="020B0609030804020204" pitchFamily="49" charset="0"/>
-              </a:rPr>
-              <a:t> </a:t>
-            </a:r>
-            <a:r>
-              <a:rPr lang="en-GB" sz="1200" b="0" dirty="0">
-                <a:solidFill>
-                  <a:srgbClr val="267F99"/>
-                </a:solidFill>
-                <a:effectLst/>
-                <a:latin typeface="Menlo" panose="020B0609030804020204" pitchFamily="49" charset="0"/>
-              </a:rPr>
-              <a:t>Dog</a:t>
-            </a:r>
-            <a:r>
-              <a:rPr lang="en-GB" sz="1200" b="0" dirty="0">
-                <a:solidFill>
-                  <a:srgbClr val="3B3B3B"/>
-                </a:solidFill>
-                <a:effectLst/>
-                <a:latin typeface="Menlo" panose="020B0609030804020204" pitchFamily="49" charset="0"/>
-              </a:rPr>
-              <a:t> </a:t>
-            </a:r>
-            <a:r>
-              <a:rPr lang="en-GB" sz="1200" b="0" dirty="0">
-                <a:solidFill>
-                  <a:srgbClr val="0000FF"/>
-                </a:solidFill>
-                <a:effectLst/>
-                <a:latin typeface="Menlo" panose="020B0609030804020204" pitchFamily="49" charset="0"/>
-              </a:rPr>
-              <a:t>extends</a:t>
-            </a:r>
-            <a:r>
-              <a:rPr lang="en-GB" sz="1200" b="0" dirty="0">
-                <a:solidFill>
-                  <a:srgbClr val="3B3B3B"/>
-                </a:solidFill>
-                <a:effectLst/>
-                <a:latin typeface="Menlo" panose="020B0609030804020204" pitchFamily="49" charset="0"/>
-              </a:rPr>
-              <a:t> </a:t>
-            </a:r>
-            <a:r>
-              <a:rPr lang="en-GB" sz="1200" b="0" dirty="0">
-                <a:solidFill>
-                  <a:srgbClr val="267F99"/>
-                </a:solidFill>
-                <a:effectLst/>
-                <a:latin typeface="Menlo" panose="020B0609030804020204" pitchFamily="49" charset="0"/>
-              </a:rPr>
-              <a:t>Animal</a:t>
-            </a:r>
-            <a:r>
-              <a:rPr lang="en-GB" sz="1200" b="0" dirty="0">
-                <a:solidFill>
-                  <a:srgbClr val="3B3B3B"/>
-                </a:solidFill>
-                <a:effectLst/>
-                <a:latin typeface="Menlo" panose="020B0609030804020204" pitchFamily="49" charset="0"/>
-              </a:rPr>
-              <a:t> {</a:t>
+              <a:t>function</a:t>
+            </a:r>
+            <a:r>
+              <a:rPr lang="it-IT" b="0" dirty="0">
+                <a:solidFill>
+                  <a:srgbClr val="000000"/>
+                </a:solidFill>
+                <a:effectLst/>
+                <a:latin typeface="Menlo" panose="020B0609030804020204" pitchFamily="49" charset="0"/>
+              </a:rPr>
+              <a:t>() { </a:t>
+            </a:r>
+            <a:r>
+              <a:rPr lang="it-IT" b="0" dirty="0" err="1">
+                <a:solidFill>
+                  <a:srgbClr val="001080"/>
+                </a:solidFill>
+                <a:effectLst/>
+                <a:latin typeface="Menlo" panose="020B0609030804020204" pitchFamily="49" charset="0"/>
+              </a:rPr>
+              <a:t>console</a:t>
+            </a:r>
+            <a:r>
+              <a:rPr lang="it-IT" b="0" dirty="0" err="1">
+                <a:solidFill>
+                  <a:srgbClr val="000000"/>
+                </a:solidFill>
+                <a:effectLst/>
+                <a:latin typeface="Menlo" panose="020B0609030804020204" pitchFamily="49" charset="0"/>
+              </a:rPr>
+              <a:t>.</a:t>
+            </a:r>
+            <a:r>
+              <a:rPr lang="it-IT" b="0" dirty="0" err="1">
+                <a:solidFill>
+                  <a:srgbClr val="795E26"/>
+                </a:solidFill>
+                <a:effectLst/>
+                <a:latin typeface="Menlo" panose="020B0609030804020204" pitchFamily="49" charset="0"/>
+              </a:rPr>
+              <a:t>log</a:t>
+            </a:r>
+            <a:r>
+              <a:rPr lang="it-IT" b="0" dirty="0">
+                <a:solidFill>
+                  <a:srgbClr val="000000"/>
+                </a:solidFill>
+                <a:effectLst/>
+                <a:latin typeface="Menlo" panose="020B0609030804020204" pitchFamily="49" charset="0"/>
+              </a:rPr>
+              <a:t>(</a:t>
+            </a:r>
+            <a:r>
+              <a:rPr lang="it-IT" b="0" dirty="0">
+                <a:solidFill>
+                  <a:srgbClr val="A31515"/>
+                </a:solidFill>
+                <a:effectLst/>
+                <a:latin typeface="Menlo" panose="020B0609030804020204" pitchFamily="49" charset="0"/>
+              </a:rPr>
+              <a:t>"Bird chirps"</a:t>
+            </a:r>
+            <a:r>
+              <a:rPr lang="it-IT" b="0" dirty="0">
+                <a:solidFill>
+                  <a:srgbClr val="000000"/>
+                </a:solidFill>
+                <a:effectLst/>
+                <a:latin typeface="Menlo" panose="020B0609030804020204" pitchFamily="49" charset="0"/>
+              </a:rPr>
+              <a:t>); } </a:t>
             </a:r>
           </a:p>
           <a:p>
@@ -28946,24 +28297,14 @@
               <a:buNone/>
             </a:pPr>
             <a:r>
-              <a:rPr lang="en-GB" sz="1200" b="0" dirty="0">
-                <a:solidFill>
-                  <a:srgbClr val="795E26"/>
-                </a:solidFill>
-                <a:effectLst/>
-                <a:latin typeface="Menlo" panose="020B0609030804020204" pitchFamily="49" charset="0"/>
-              </a:rPr>
-              <a:t>		  speak</a:t>
-            </a:r>
-            <a:r>
-              <a:rPr lang="en-GB" sz="1200" b="0" dirty="0">
-                <a:solidFill>
-                  <a:srgbClr val="3B3B3B"/>
-                </a:solidFill>
-                <a:effectLst/>
-                <a:latin typeface="Menlo" panose="020B0609030804020204" pitchFamily="49" charset="0"/>
-              </a:rPr>
-              <a:t>() {</a:t>
+              <a:rPr lang="it-IT" b="0" dirty="0">
+                <a:solidFill>
+                  <a:srgbClr val="000000"/>
+                </a:solidFill>
+                <a:effectLst/>
+                <a:latin typeface="Menlo" panose="020B0609030804020204" pitchFamily="49" charset="0"/>
+              </a:rPr>
+              <a:t>};</a:t>
             </a:r>
           </a:p>
           <a:p>
@@ -28973,76 +28314,13 @@
               </a:lnSpc>
               <a:buNone/>
             </a:pPr>
-            <a:r>
-              <a:rPr lang="en-GB" sz="1200" b="0" dirty="0">
-                <a:solidFill>
-                  <a:srgbClr val="001080"/>
-                </a:solidFill>
-                <a:effectLst/>
-                <a:latin typeface="Menlo" panose="020B0609030804020204" pitchFamily="49" charset="0"/>
-              </a:rPr>
-              <a:t>		    </a:t>
-            </a:r>
-            <a:r>
-              <a:rPr lang="en-GB" sz="1200" b="0" dirty="0" err="1">
-                <a:solidFill>
-                  <a:srgbClr val="001080"/>
-                </a:solidFill>
-                <a:effectLst/>
-                <a:latin typeface="Menlo" panose="020B0609030804020204" pitchFamily="49" charset="0"/>
-              </a:rPr>
-              <a:t>console</a:t>
-            </a:r>
-            <a:r>
-              <a:rPr lang="en-GB" sz="1200" b="0" dirty="0" err="1">
-                <a:solidFill>
-                  <a:srgbClr val="3B3B3B"/>
-                </a:solidFill>
-                <a:effectLst/>
-                <a:latin typeface="Menlo" panose="020B0609030804020204" pitchFamily="49" charset="0"/>
-              </a:rPr>
-              <a:t>.</a:t>
-            </a:r>
-            <a:r>
-              <a:rPr lang="en-GB" sz="1200" b="0" dirty="0" err="1">
-                <a:solidFill>
-                  <a:srgbClr val="795E26"/>
-                </a:solidFill>
-                <a:effectLst/>
-                <a:latin typeface="Menlo" panose="020B0609030804020204" pitchFamily="49" charset="0"/>
-              </a:rPr>
-              <a:t>log</a:t>
-            </a:r>
-            <a:r>
-              <a:rPr lang="en-GB" sz="1200" b="0" dirty="0">
-                <a:solidFill>
-                  <a:srgbClr val="3B3B3B"/>
-                </a:solidFill>
-                <a:effectLst/>
-                <a:latin typeface="Menlo" panose="020B0609030804020204" pitchFamily="49" charset="0"/>
-              </a:rPr>
-              <a:t>(</a:t>
-            </a:r>
-            <a:r>
-              <a:rPr lang="en-GB" sz="1200" b="0" dirty="0">
-                <a:solidFill>
-                  <a:srgbClr val="A31515"/>
-                </a:solidFill>
-                <a:effectLst/>
-                <a:latin typeface="Menlo" panose="020B0609030804020204" pitchFamily="49" charset="0"/>
-              </a:rPr>
-              <a:t>"Dog barks"</a:t>
-            </a:r>
-            <a:r>
-              <a:rPr lang="en-GB" sz="1200" b="0" dirty="0">
-                <a:solidFill>
-                  <a:srgbClr val="3B3B3B"/>
-                </a:solidFill>
-                <a:effectLst/>
-                <a:latin typeface="Menlo" panose="020B0609030804020204" pitchFamily="49" charset="0"/>
-              </a:rPr>
-              <a:t>);</a:t>
-            </a:r>
+            <a:endParaRPr lang="it-IT" b="0" dirty="0">
+              <a:solidFill>
+                <a:srgbClr val="000000"/>
+              </a:solidFill>
+              <a:effectLst/>
+              <a:latin typeface="Menlo" panose="020B0609030804020204" pitchFamily="49" charset="0"/>
+            </a:endParaRPr>
           </a:p>
           <a:p>
             <a:pPr>
@@ -29051,16 +28329,13 @@
               </a:lnSpc>
               <a:buNone/>
             </a:pPr>
-            <a:r>
-              <a:rPr lang="en-GB" sz="1200" b="0" dirty="0">
-                <a:solidFill>
-                  <a:srgbClr val="3B3B3B"/>
-                </a:solidFill>
-                <a:effectLst/>
-                <a:latin typeface="Menlo" panose="020B0609030804020204" pitchFamily="49" charset="0"/>
-              </a:rPr>
-              <a:t>		  }</a:t>
-            </a:r>
+            <a:endParaRPr lang="it-IT" b="0" dirty="0">
+              <a:solidFill>
+                <a:srgbClr val="000000"/>
+              </a:solidFill>
+              <a:effectLst/>
+              <a:latin typeface="Menlo" panose="020B0609030804020204" pitchFamily="49" charset="0"/>
+            </a:endParaRPr>
           </a:p>
           <a:p>
             <a:pPr>
@@ -29070,14 +28345,104 @@
               <a:buNone/>
             </a:pPr>
             <a:r>
-              <a:rPr lang="en-GB" sz="1200" b="0" dirty="0">
-                <a:solidFill>
-                  <a:srgbClr val="3B3B3B"/>
-                </a:solidFill>
-                <a:effectLst/>
-                <a:latin typeface="Menlo" panose="020B0609030804020204" pitchFamily="49" charset="0"/>
-              </a:rPr>
-              <a:t>		}</a:t>
+              <a:rPr lang="it-IT" b="0" dirty="0" err="1">
+                <a:solidFill>
+                  <a:srgbClr val="0000FF"/>
+                </a:solidFill>
+                <a:effectLst/>
+                <a:latin typeface="Menlo" panose="020B0609030804020204" pitchFamily="49" charset="0"/>
+              </a:rPr>
+              <a:t>function</a:t>
+            </a:r>
+            <a:r>
+              <a:rPr lang="it-IT" b="0" dirty="0">
+                <a:solidFill>
+                  <a:srgbClr val="000000"/>
+                </a:solidFill>
+                <a:effectLst/>
+                <a:latin typeface="Menlo" panose="020B0609030804020204" pitchFamily="49" charset="0"/>
+              </a:rPr>
+              <a:t> </a:t>
+            </a:r>
+            <a:r>
+              <a:rPr lang="it-IT" b="0" dirty="0" err="1">
+                <a:solidFill>
+                  <a:srgbClr val="795E26"/>
+                </a:solidFill>
+                <a:effectLst/>
+                <a:latin typeface="Menlo" panose="020B0609030804020204" pitchFamily="49" charset="0"/>
+              </a:rPr>
+              <a:t>makeAnimalSpeak</a:t>
+            </a:r>
+            <a:r>
+              <a:rPr lang="it-IT" b="0" dirty="0">
+                <a:solidFill>
+                  <a:srgbClr val="000000"/>
+                </a:solidFill>
+                <a:effectLst/>
+                <a:latin typeface="Menlo" panose="020B0609030804020204" pitchFamily="49" charset="0"/>
+              </a:rPr>
+              <a:t>(</a:t>
+            </a:r>
+            <a:r>
+              <a:rPr lang="it-IT" b="0" dirty="0" err="1">
+                <a:solidFill>
+                  <a:srgbClr val="001080"/>
+                </a:solidFill>
+                <a:effectLst/>
+                <a:latin typeface="Menlo" panose="020B0609030804020204" pitchFamily="49" charset="0"/>
+              </a:rPr>
+              <a:t>animal</a:t>
+            </a:r>
+            <a:r>
+              <a:rPr lang="it-IT" b="0" dirty="0">
+                <a:solidFill>
+                  <a:srgbClr val="000000"/>
+                </a:solidFill>
+                <a:effectLst/>
+                <a:latin typeface="Menlo" panose="020B0609030804020204" pitchFamily="49" charset="0"/>
+              </a:rPr>
+              <a:t>) { </a:t>
+            </a:r>
+            <a:r>
+              <a:rPr lang="it-IT" b="0" dirty="0" err="1">
+                <a:solidFill>
+                  <a:srgbClr val="001080"/>
+                </a:solidFill>
+                <a:effectLst/>
+                <a:latin typeface="Menlo" panose="020B0609030804020204" pitchFamily="49" charset="0"/>
+              </a:rPr>
+              <a:t>animal</a:t>
+            </a:r>
+            <a:r>
+              <a:rPr lang="it-IT" b="0" dirty="0" err="1">
+                <a:solidFill>
+                  <a:srgbClr val="000000"/>
+                </a:solidFill>
+                <a:effectLst/>
+                <a:latin typeface="Menlo" panose="020B0609030804020204" pitchFamily="49" charset="0"/>
+              </a:rPr>
+              <a:t>.</a:t>
+            </a:r>
+            <a:r>
+              <a:rPr lang="it-IT" b="0" dirty="0" err="1">
+                <a:solidFill>
+                  <a:srgbClr val="795E26"/>
+                </a:solidFill>
+                <a:effectLst/>
+                <a:latin typeface="Menlo" panose="020B0609030804020204" pitchFamily="49" charset="0"/>
+              </a:rPr>
+              <a:t>speak</a:t>
+            </a:r>
+            <a:r>
+              <a:rPr lang="it-IT" b="0" dirty="0">
+                <a:solidFill>
+                  <a:srgbClr val="000000"/>
+                </a:solidFill>
+                <a:effectLst/>
+                <a:latin typeface="Menlo" panose="020B0609030804020204" pitchFamily="49" charset="0"/>
+              </a:rPr>
+              <a:t>(); }</a:t>
             </a:r>
           </a:p>
           <a:p>
@@ -29087,16 +28452,9 @@
               </a:lnSpc>
               <a:buNone/>
             </a:pPr>
-            <a:r>
-              <a:rPr lang="en-GB" sz="1200" b="0" dirty="0">
-                <a:solidFill>
-                  <a:srgbClr val="0000FF"/>
-                </a:solidFill>
-                <a:effectLst/>
-                <a:latin typeface="Menlo" panose="020B0609030804020204" pitchFamily="49" charset="0"/>
-              </a:rPr>
-              <a:t>		</a:t>
-            </a:r>
+            <a:endParaRPr lang="it-IT" dirty="0">
+              <a:latin typeface="Menlo" panose="020B0609030804020204" pitchFamily="49" charset="0"/>
+            </a:endParaRPr>
           </a:p>
           <a:p>
             <a:pPr>
@@ -29106,113 +28464,14 @@
               <a:buNone/>
             </a:pPr>
             <a:r>
-              <a:rPr lang="en-GB" sz="1200" dirty="0">
-                <a:solidFill>
-                  <a:srgbClr val="0000FF"/>
-                </a:solidFill>
-                <a:latin typeface="Menlo" panose="020B0609030804020204" pitchFamily="49" charset="0"/>
-              </a:rPr>
-              <a:t>		</a:t>
-            </a:r>
-            <a:r>
-              <a:rPr lang="en-GB" sz="1200" b="0" dirty="0" err="1">
-                <a:solidFill>
-                  <a:srgbClr val="0000FF"/>
-                </a:solidFill>
-                <a:effectLst/>
-                <a:latin typeface="Menlo" panose="020B0609030804020204" pitchFamily="49" charset="0"/>
-              </a:rPr>
-              <a:t>const</a:t>
-            </a:r>
-            <a:r>
-              <a:rPr lang="en-GB" sz="1200" b="0" dirty="0">
-                <a:solidFill>
-                  <a:srgbClr val="3B3B3B"/>
+              <a:rPr lang="it-IT" b="0" dirty="0">
+                <a:solidFill>
+                  <a:srgbClr val="000000"/>
                 </a:solidFill>
                 <a:effectLst/>
                 <a:latin typeface="Menlo" panose="020B0609030804020204" pitchFamily="49" charset="0"/>
               </a:rPr>
               <a:t> </a:t>
-            </a:r>
-            <a:r>
-              <a:rPr lang="en-GB" sz="1200" b="0" dirty="0" err="1">
-                <a:solidFill>
-                  <a:srgbClr val="0070C1"/>
-                </a:solidFill>
-                <a:effectLst/>
-                <a:latin typeface="Menlo" panose="020B0609030804020204" pitchFamily="49" charset="0"/>
-              </a:rPr>
-              <a:t>myAnimal</a:t>
-            </a:r>
-            <a:r>
-              <a:rPr lang="en-GB" sz="1200" b="0" dirty="0">
-                <a:solidFill>
-                  <a:srgbClr val="3B3B3B"/>
-                </a:solidFill>
-                <a:effectLst/>
-                <a:latin typeface="Menlo" panose="020B0609030804020204" pitchFamily="49" charset="0"/>
-              </a:rPr>
-              <a:t> </a:t>
-            </a:r>
-            <a:r>
-              <a:rPr lang="en-GB" sz="1200" b="0" dirty="0">
-                <a:solidFill>
-                  <a:srgbClr val="000000"/>
-                </a:solidFill>
-                <a:effectLst/>
-                <a:latin typeface="Menlo" panose="020B0609030804020204" pitchFamily="49" charset="0"/>
-              </a:rPr>
-              <a:t>=</a:t>
-            </a:r>
-            <a:r>
-              <a:rPr lang="en-GB" sz="1200" b="0" dirty="0">
-                <a:solidFill>
-                  <a:srgbClr val="3B3B3B"/>
-                </a:solidFill>
-                <a:effectLst/>
-                <a:latin typeface="Menlo" panose="020B0609030804020204" pitchFamily="49" charset="0"/>
-              </a:rPr>
-              <a:t> </a:t>
-            </a:r>
-            <a:r>
-              <a:rPr lang="en-GB" sz="1200" b="0" dirty="0">
-                <a:solidFill>
-                  <a:srgbClr val="0000FF"/>
-                </a:solidFill>
-                <a:effectLst/>
-                <a:latin typeface="Menlo" panose="020B0609030804020204" pitchFamily="49" charset="0"/>
-              </a:rPr>
-              <a:t>new</a:t>
-            </a:r>
-            <a:r>
-              <a:rPr lang="en-GB" sz="1200" b="0" dirty="0">
-                <a:solidFill>
-                  <a:srgbClr val="3B3B3B"/>
-                </a:solidFill>
-                <a:effectLst/>
-                <a:latin typeface="Menlo" panose="020B0609030804020204" pitchFamily="49" charset="0"/>
-              </a:rPr>
-              <a:t> </a:t>
-            </a:r>
-            <a:r>
-              <a:rPr lang="en-GB" sz="1200" b="0" dirty="0">
-                <a:solidFill>
-                  <a:srgbClr val="267F99"/>
-                </a:solidFill>
-                <a:effectLst/>
-                <a:latin typeface="Menlo" panose="020B0609030804020204" pitchFamily="49" charset="0"/>
-              </a:rPr>
-              <a:t>Animal</a:t>
-            </a:r>
-            <a:r>
-              <a:rPr lang="en-GB" sz="1200" b="0" dirty="0">
-                <a:solidFill>
-                  <a:srgbClr val="3B3B3B"/>
-                </a:solidFill>
-                <a:effectLst/>
-                <a:latin typeface="Menlo" panose="020B0609030804020204" pitchFamily="49" charset="0"/>
-              </a:rPr>
-              <a:t>();</a:t>
             </a:r>
           </a:p>
           <a:p>
@@ -29223,115 +28482,82 @@
               <a:buNone/>
             </a:pPr>
             <a:r>
-              <a:rPr lang="en-GB" sz="1200" b="0" dirty="0">
-                <a:solidFill>
-                  <a:srgbClr val="0000FF"/>
-                </a:solidFill>
-                <a:effectLst/>
-                <a:latin typeface="Menlo" panose="020B0609030804020204" pitchFamily="49" charset="0"/>
-              </a:rPr>
-              <a:t>		</a:t>
-            </a:r>
-            <a:r>
-              <a:rPr lang="en-GB" sz="1200" b="0" dirty="0" err="1">
-                <a:solidFill>
-                  <a:srgbClr val="0000FF"/>
-                </a:solidFill>
-                <a:effectLst/>
-                <a:latin typeface="Menlo" panose="020B0609030804020204" pitchFamily="49" charset="0"/>
-              </a:rPr>
-              <a:t>const</a:t>
-            </a:r>
-            <a:r>
-              <a:rPr lang="en-GB" sz="1200" b="0" dirty="0">
-                <a:solidFill>
-                  <a:srgbClr val="3B3B3B"/>
-                </a:solidFill>
-                <a:effectLst/>
-                <a:latin typeface="Menlo" panose="020B0609030804020204" pitchFamily="49" charset="0"/>
-              </a:rPr>
-              <a:t> </a:t>
-            </a:r>
-            <a:r>
-              <a:rPr lang="en-GB" sz="1200" b="0" dirty="0" err="1">
+              <a:rPr lang="it-IT" b="0" dirty="0" err="1">
+                <a:solidFill>
+                  <a:srgbClr val="795E26"/>
+                </a:solidFill>
+                <a:effectLst/>
+                <a:latin typeface="Menlo" panose="020B0609030804020204" pitchFamily="49" charset="0"/>
+              </a:rPr>
+              <a:t>makeAnimalSpeak</a:t>
+            </a:r>
+            <a:r>
+              <a:rPr lang="it-IT" b="0" dirty="0">
+                <a:solidFill>
+                  <a:srgbClr val="000000"/>
+                </a:solidFill>
+                <a:effectLst/>
+                <a:latin typeface="Menlo" panose="020B0609030804020204" pitchFamily="49" charset="0"/>
+              </a:rPr>
+              <a:t>(</a:t>
+            </a:r>
+            <a:r>
+              <a:rPr lang="it-IT" b="0" dirty="0">
                 <a:solidFill>
                   <a:srgbClr val="0070C1"/>
                 </a:solidFill>
                 <a:effectLst/>
                 <a:latin typeface="Menlo" panose="020B0609030804020204" pitchFamily="49" charset="0"/>
               </a:rPr>
-              <a:t>myDog</a:t>
-            </a:r>
-            <a:r>
-              <a:rPr lang="en-GB" sz="1200" b="0" dirty="0">
-                <a:solidFill>
-                  <a:srgbClr val="3B3B3B"/>
-                </a:solidFill>
-                <a:effectLst/>
-                <a:latin typeface="Menlo" panose="020B0609030804020204" pitchFamily="49" charset="0"/>
-              </a:rPr>
-              <a:t> </a:t>
-            </a:r>
-            <a:r>
-              <a:rPr lang="en-GB" sz="1200" b="0" dirty="0">
-                <a:solidFill>
-                  <a:srgbClr val="000000"/>
-                </a:solidFill>
-                <a:effectLst/>
-                <a:latin typeface="Menlo" panose="020B0609030804020204" pitchFamily="49" charset="0"/>
-              </a:rPr>
-              <a:t>=</a:t>
-            </a:r>
-            <a:r>
-              <a:rPr lang="en-GB" sz="1200" b="0" dirty="0">
-                <a:solidFill>
-                  <a:srgbClr val="3B3B3B"/>
-                </a:solidFill>
-                <a:effectLst/>
-                <a:latin typeface="Menlo" panose="020B0609030804020204" pitchFamily="49" charset="0"/>
-              </a:rPr>
-              <a:t> </a:t>
-            </a:r>
-            <a:r>
-              <a:rPr lang="en-GB" sz="1200" b="0" dirty="0">
-                <a:solidFill>
-                  <a:srgbClr val="0000FF"/>
-                </a:solidFill>
-                <a:effectLst/>
-                <a:latin typeface="Menlo" panose="020B0609030804020204" pitchFamily="49" charset="0"/>
-              </a:rPr>
-              <a:t>new</a:t>
-            </a:r>
-            <a:r>
-              <a:rPr lang="en-GB" sz="1200" b="0" dirty="0">
-                <a:solidFill>
-                  <a:srgbClr val="3B3B3B"/>
-                </a:solidFill>
-                <a:effectLst/>
-                <a:latin typeface="Menlo" panose="020B0609030804020204" pitchFamily="49" charset="0"/>
-              </a:rPr>
-              <a:t> </a:t>
-            </a:r>
-            <a:r>
-              <a:rPr lang="en-GB" sz="1200" b="0" dirty="0">
-                <a:solidFill>
-                  <a:srgbClr val="267F99"/>
-                </a:solidFill>
-                <a:effectLst/>
-                <a:latin typeface="Menlo" panose="020B0609030804020204" pitchFamily="49" charset="0"/>
-              </a:rPr>
-              <a:t>Dog</a:t>
-            </a:r>
-            <a:r>
-              <a:rPr lang="en-GB" sz="1200" b="0" dirty="0">
-                <a:solidFill>
-                  <a:srgbClr val="3B3B3B"/>
-                </a:solidFill>
-                <a:effectLst/>
-                <a:latin typeface="Menlo" panose="020B0609030804020204" pitchFamily="49" charset="0"/>
-              </a:rPr>
-              <a:t>();</a:t>
-            </a:r>
+              <a:t>dog</a:t>
+            </a:r>
+            <a:r>
+              <a:rPr lang="it-IT" b="0" dirty="0">
+                <a:solidFill>
+                  <a:srgbClr val="000000"/>
+                </a:solidFill>
+                <a:effectLst/>
+                <a:latin typeface="Menlo" panose="020B0609030804020204" pitchFamily="49" charset="0"/>
+              </a:rPr>
+              <a:t>); </a:t>
+            </a:r>
+            <a:r>
+              <a:rPr lang="it-IT" b="0" dirty="0">
+                <a:solidFill>
+                  <a:srgbClr val="008000"/>
+                </a:solidFill>
+                <a:effectLst/>
+                <a:latin typeface="Menlo" panose="020B0609030804020204" pitchFamily="49" charset="0"/>
+              </a:rPr>
+              <a:t>// "Dog </a:t>
+            </a:r>
+            <a:r>
+              <a:rPr lang="it-IT" b="0" dirty="0" err="1">
+                <a:solidFill>
+                  <a:srgbClr val="008000"/>
+                </a:solidFill>
+                <a:effectLst/>
+                <a:latin typeface="Menlo" panose="020B0609030804020204" pitchFamily="49" charset="0"/>
+              </a:rPr>
+              <a:t>barks</a:t>
+            </a:r>
+            <a:r>
+              <a:rPr lang="it-IT" b="0" dirty="0">
+                <a:solidFill>
+                  <a:srgbClr val="008000"/>
+                </a:solidFill>
+                <a:effectLst/>
+                <a:latin typeface="Menlo" panose="020B0609030804020204" pitchFamily="49" charset="0"/>
+              </a:rPr>
+              <a:t>"</a:t>
+            </a:r>
+            <a:endParaRPr lang="it-IT" b="0" dirty="0">
+              <a:solidFill>
+                <a:srgbClr val="000000"/>
+              </a:solidFill>
+              <a:effectLst/>
+              <a:latin typeface="Menlo" panose="020B0609030804020204" pitchFamily="49" charset="0"/>
+            </a:endParaRPr>
           </a:p>
           <a:p>
             <a:pPr>
@@ -29341,15 +28567,102 @@
               <a:buNone/>
             </a:pPr>
             <a:r>
-              <a:rPr lang="en-GB" sz="1200" b="0" dirty="0">
+              <a:rPr lang="it-IT" b="0" dirty="0" err="1">
+                <a:solidFill>
+                  <a:srgbClr val="795E26"/>
+                </a:solidFill>
+                <a:effectLst/>
+                <a:latin typeface="Menlo" panose="020B0609030804020204" pitchFamily="49" charset="0"/>
+              </a:rPr>
+              <a:t>makeAnimalSpeak</a:t>
+            </a:r>
+            <a:r>
+              <a:rPr lang="it-IT" b="0" dirty="0">
+                <a:solidFill>
+                  <a:srgbClr val="000000"/>
+                </a:solidFill>
+                <a:effectLst/>
+                <a:latin typeface="Menlo" panose="020B0609030804020204" pitchFamily="49" charset="0"/>
+              </a:rPr>
+              <a:t>(</a:t>
+            </a:r>
+            <a:r>
+              <a:rPr lang="it-IT" b="0" dirty="0" err="1">
                 <a:solidFill>
                   <a:srgbClr val="0070C1"/>
                 </a:solidFill>
                 <a:effectLst/>
                 <a:latin typeface="Menlo" panose="020B0609030804020204" pitchFamily="49" charset="0"/>
               </a:rPr>
-              <a:t>		</a:t>
-            </a:r>
+              <a:t>cat</a:t>
+            </a:r>
+            <a:r>
+              <a:rPr lang="it-IT" b="0" dirty="0">
+                <a:solidFill>
+                  <a:srgbClr val="000000"/>
+                </a:solidFill>
+                <a:effectLst/>
+                <a:latin typeface="Menlo" panose="020B0609030804020204" pitchFamily="49" charset="0"/>
+              </a:rPr>
+              <a:t>); </a:t>
+            </a:r>
+            <a:r>
+              <a:rPr lang="it-IT" b="0" dirty="0">
+                <a:solidFill>
+                  <a:srgbClr val="008000"/>
+                </a:solidFill>
+                <a:effectLst/>
+                <a:latin typeface="Menlo" panose="020B0609030804020204" pitchFamily="49" charset="0"/>
+              </a:rPr>
+              <a:t>// "</a:t>
+            </a:r>
+            <a:r>
+              <a:rPr lang="it-IT" b="0" dirty="0" err="1">
+                <a:solidFill>
+                  <a:srgbClr val="008000"/>
+                </a:solidFill>
+                <a:effectLst/>
+                <a:latin typeface="Menlo" panose="020B0609030804020204" pitchFamily="49" charset="0"/>
+              </a:rPr>
+              <a:t>Cat</a:t>
+            </a:r>
+            <a:r>
+              <a:rPr lang="it-IT" b="0" dirty="0">
+                <a:solidFill>
+                  <a:srgbClr val="008000"/>
+                </a:solidFill>
+                <a:effectLst/>
+                <a:latin typeface="Menlo" panose="020B0609030804020204" pitchFamily="49" charset="0"/>
+              </a:rPr>
+              <a:t> </a:t>
+            </a:r>
+            <a:r>
+              <a:rPr lang="it-IT" b="0" dirty="0" err="1">
+                <a:solidFill>
+                  <a:srgbClr val="008000"/>
+                </a:solidFill>
+                <a:effectLst/>
+                <a:latin typeface="Menlo" panose="020B0609030804020204" pitchFamily="49" charset="0"/>
+              </a:rPr>
+              <a:t>meows</a:t>
+            </a:r>
+            <a:r>
+              <a:rPr lang="it-IT" b="0" dirty="0">
+                <a:solidFill>
+                  <a:srgbClr val="008000"/>
+                </a:solidFill>
+                <a:effectLst/>
+                <a:latin typeface="Menlo" panose="020B0609030804020204" pitchFamily="49" charset="0"/>
+              </a:rPr>
+              <a:t>"</a:t>
+            </a:r>
+            <a:endParaRPr lang="it-IT" b="0" dirty="0">
+              <a:solidFill>
+                <a:srgbClr val="000000"/>
+              </a:solidFill>
+              <a:effectLst/>
+              <a:latin typeface="Menlo" panose="020B0609030804020204" pitchFamily="49" charset="0"/>
+            </a:endParaRPr>
           </a:p>
           <a:p>
             <a:pPr>
@@ -29359,161 +28672,62 @@
               <a:buNone/>
             </a:pPr>
             <a:r>
-              <a:rPr lang="en-GB" sz="1200" dirty="0">
+              <a:rPr lang="it-IT" b="0" dirty="0" err="1">
+                <a:solidFill>
+                  <a:srgbClr val="795E26"/>
+                </a:solidFill>
+                <a:effectLst/>
+                <a:latin typeface="Menlo" panose="020B0609030804020204" pitchFamily="49" charset="0"/>
+              </a:rPr>
+              <a:t>makeAnimalSpeak</a:t>
+            </a:r>
+            <a:r>
+              <a:rPr lang="it-IT" b="0" dirty="0">
+                <a:solidFill>
+                  <a:srgbClr val="000000"/>
+                </a:solidFill>
+                <a:effectLst/>
+                <a:latin typeface="Menlo" panose="020B0609030804020204" pitchFamily="49" charset="0"/>
+              </a:rPr>
+              <a:t>(</a:t>
+            </a:r>
+            <a:r>
+              <a:rPr lang="it-IT" b="0" dirty="0" err="1">
                 <a:solidFill>
                   <a:srgbClr val="0070C1"/>
                 </a:solidFill>
-                <a:latin typeface="Menlo" panose="020B0609030804020204" pitchFamily="49" charset="0"/>
-              </a:rPr>
-              <a:t>		</a:t>
-            </a:r>
-            <a:r>
-              <a:rPr lang="en-GB" sz="1200" b="0" dirty="0" err="1">
-                <a:solidFill>
-                  <a:srgbClr val="0070C1"/>
-                </a:solidFill>
-                <a:effectLst/>
-                <a:latin typeface="Menlo" panose="020B0609030804020204" pitchFamily="49" charset="0"/>
-              </a:rPr>
-              <a:t>myAnimal</a:t>
-            </a:r>
-            <a:r>
-              <a:rPr lang="en-GB" sz="1200" b="0" dirty="0" err="1">
-                <a:solidFill>
-                  <a:srgbClr val="3B3B3B"/>
-                </a:solidFill>
-                <a:effectLst/>
-                <a:latin typeface="Menlo" panose="020B0609030804020204" pitchFamily="49" charset="0"/>
-              </a:rPr>
-              <a:t>.</a:t>
-            </a:r>
-            <a:r>
-              <a:rPr lang="en-GB" sz="1200" b="0" dirty="0" err="1">
-                <a:solidFill>
-                  <a:srgbClr val="795E26"/>
-                </a:solidFill>
-                <a:effectLst/>
-                <a:latin typeface="Menlo" panose="020B0609030804020204" pitchFamily="49" charset="0"/>
-              </a:rPr>
-              <a:t>speak</a:t>
-            </a:r>
-            <a:r>
-              <a:rPr lang="en-GB" sz="1200" b="0" dirty="0">
-                <a:solidFill>
-                  <a:srgbClr val="3B3B3B"/>
-                </a:solidFill>
-                <a:effectLst/>
-                <a:latin typeface="Menlo" panose="020B0609030804020204" pitchFamily="49" charset="0"/>
-              </a:rPr>
-              <a:t>(); </a:t>
-            </a:r>
-            <a:r>
-              <a:rPr lang="en-GB" sz="1200" b="0" dirty="0">
+                <a:effectLst/>
+                <a:latin typeface="Menlo" panose="020B0609030804020204" pitchFamily="49" charset="0"/>
+              </a:rPr>
+              <a:t>bird</a:t>
+            </a:r>
+            <a:r>
+              <a:rPr lang="it-IT" b="0" dirty="0">
+                <a:solidFill>
+                  <a:srgbClr val="000000"/>
+                </a:solidFill>
+                <a:effectLst/>
+                <a:latin typeface="Menlo" panose="020B0609030804020204" pitchFamily="49" charset="0"/>
+              </a:rPr>
+              <a:t>); </a:t>
+            </a:r>
+            <a:r>
+              <a:rPr lang="it-IT" b="0" dirty="0">
                 <a:solidFill>
                   <a:srgbClr val="008000"/>
                 </a:solidFill>
                 <a:effectLst/>
                 <a:latin typeface="Menlo" panose="020B0609030804020204" pitchFamily="49" charset="0"/>
               </a:rPr>
-              <a:t>// "Animal makes a sound"</a:t>
-            </a:r>
-            <a:endParaRPr lang="en-GB" sz="1200" b="0" dirty="0">
+              <a:t>// "Bird chirps" </a:t>
+            </a:r>
+            <a:endParaRPr lang="it-IT" b="0" dirty="0">
               <a:solidFill>
-                <a:srgbClr val="3B3B3B"/>
+                <a:srgbClr val="000000"/>
               </a:solidFill>
               <a:effectLst/>
               <a:latin typeface="Menlo" panose="020B0609030804020204" pitchFamily="49" charset="0"/>
             </a:endParaRPr>
-          </a:p>
-          <a:p>
-            <a:pPr marL="120650" indent="0">
-              <a:lnSpc>
-                <a:spcPts val="1350"/>
-              </a:lnSpc>
-              <a:buNone/>
-            </a:pPr>
-            <a:r>
-              <a:rPr lang="en-GB" sz="1200" b="0" dirty="0">
-                <a:solidFill>
-                  <a:srgbClr val="0070C1"/>
-                </a:solidFill>
-                <a:effectLst/>
-                <a:latin typeface="Menlo" panose="020B0609030804020204" pitchFamily="49" charset="0"/>
-              </a:rPr>
-              <a:t>	</a:t>
-            </a:r>
-            <a:r>
-              <a:rPr lang="en-GB" sz="1200" b="0" dirty="0" err="1">
-                <a:solidFill>
-                  <a:srgbClr val="0070C1"/>
-                </a:solidFill>
-                <a:effectLst/>
-                <a:latin typeface="Menlo" panose="020B0609030804020204" pitchFamily="49" charset="0"/>
-              </a:rPr>
-              <a:t>myDog</a:t>
-            </a:r>
-            <a:r>
-              <a:rPr lang="en-GB" sz="1200" b="0" dirty="0" err="1">
-                <a:solidFill>
-                  <a:srgbClr val="3B3B3B"/>
-                </a:solidFill>
-                <a:effectLst/>
-                <a:latin typeface="Menlo" panose="020B0609030804020204" pitchFamily="49" charset="0"/>
-              </a:rPr>
-              <a:t>.</a:t>
-            </a:r>
-            <a:r>
-              <a:rPr lang="en-GB" sz="1200" b="0" dirty="0" err="1">
-                <a:solidFill>
-                  <a:srgbClr val="795E26"/>
-                </a:solidFill>
-                <a:effectLst/>
-                <a:latin typeface="Menlo" panose="020B0609030804020204" pitchFamily="49" charset="0"/>
-              </a:rPr>
-              <a:t>speak</a:t>
-            </a:r>
-            <a:r>
-              <a:rPr lang="en-GB" sz="1200" b="0" dirty="0">
-                <a:solidFill>
-                  <a:srgbClr val="3B3B3B"/>
-                </a:solidFill>
-                <a:effectLst/>
-                <a:latin typeface="Menlo" panose="020B0609030804020204" pitchFamily="49" charset="0"/>
-              </a:rPr>
-              <a:t>(); </a:t>
-            </a:r>
-            <a:r>
-              <a:rPr lang="en-GB" sz="1200" b="0" dirty="0">
-                <a:solidFill>
-                  <a:srgbClr val="008000"/>
-                </a:solidFill>
-                <a:effectLst/>
-                <a:latin typeface="Menlo" panose="020B0609030804020204" pitchFamily="49" charset="0"/>
-              </a:rPr>
-              <a:t>// "Dog barks"</a:t>
-            </a:r>
-            <a:endParaRPr lang="en-GB" sz="1200" b="0" dirty="0">
-              <a:solidFill>
-                <a:srgbClr val="3B3B3B"/>
-              </a:solidFill>
-              <a:effectLst/>
-              <a:latin typeface="Menlo" panose="020B0609030804020204" pitchFamily="49" charset="0"/>
-            </a:endParaRPr>
-          </a:p>
-          <a:p>
-            <a:pPr marL="457200" marR="0" lvl="0" indent="0" algn="l" rtl="0">
-              <a:lnSpc>
-                <a:spcPct val="115000"/>
-              </a:lnSpc>
-              <a:spcBef>
-                <a:spcPts val="0"/>
-              </a:spcBef>
-              <a:spcAft>
-                <a:spcPts val="1600"/>
-              </a:spcAft>
-              <a:buNone/>
-            </a:pPr>
-            <a:endParaRPr dirty="0"/>
           </a:p>
         </p:txBody>
       </p:sp>
@@ -33726,7 +32940,7 @@
             </a:pPr>
             <a:r>
               <a:rPr lang="en-GB" dirty="0"/>
-              <a:t>Procedural approach is useful for small scripts where we just need to process data in a linear fashion.</a:t>
+              <a:t>Procedural approach is useful for small scripts where we just need to process data in a linear fashion</a:t>
             </a:r>
           </a:p>
           <a:p>
@@ -36034,15 +35248,7 @@
             </a:r>
             <a:r>
               <a:rPr lang="en-GB" dirty="0"/>
-              <a:t> an example to </a:t>
-            </a:r>
-            <a:r>
-              <a:rPr lang="en-GB" dirty="0" err="1"/>
-              <a:t>compera</a:t>
-            </a:r>
-            <a:r>
-              <a:rPr lang="en-GB" dirty="0"/>
-              <a:t> the two styles (see 02.declatative_imperative.js</a:t>
+              <a:t> an example to compere the two styles (see 02.declatative_imperative.js)</a:t>
             </a:r>
           </a:p>
         </p:txBody>
@@ -37235,7 +36441,7 @@
             </a:pPr>
             <a:r>
               <a:rPr lang="en-GB" dirty="0"/>
-              <a:t>Functions without a name)</a:t>
+              <a:t>Functions without a name</a:t>
             </a:r>
             <a:endParaRPr lang="en-GB" sz="1700" dirty="0"/>
           </a:p>
@@ -40239,12 +39445,15 @@
             </a:r>
           </a:p>
           <a:p>
-            <a:pPr lvl="1" indent="-336550">
-              <a:spcBef>
-                <a:spcPts val="0"/>
-              </a:spcBef>
-              <a:buSzPts val="1700"/>
-              <a:buChar char="●"/>
+            <a:pPr marL="914400" lvl="1" indent="-323850" algn="l" rtl="0">
+              <a:spcBef>
+                <a:spcPts val="0"/>
+              </a:spcBef>
+              <a:spcAft>
+                <a:spcPts val="0"/>
+              </a:spcAft>
+              <a:buSzPts val="1500"/>
+              <a:buChar char="○"/>
             </a:pPr>
             <a:r>
               <a:rPr lang="en-GB" dirty="0"/>
@@ -41615,6 +40824,26 @@
 </file>
 
 <file path=customXml/item1.xml><?xml version="1.0" encoding="utf-8"?>
+<p:properties xmlns:p="http://schemas.microsoft.com/office/2006/metadata/properties" xmlns:xsi="http://www.w3.org/2001/XMLSchema-instance" xmlns:pc="http://schemas.microsoft.com/office/infopath/2007/PartnerControls">
+  <documentManagement>
+    <TaxCatchAll xmlns="e9b5433c-2372-4cb7-8bab-09518096b29b" xsi:nil="true"/>
+    <lcf76f155ced4ddcb4097134ff3c332f xmlns="3bd0d43f-5e5b-43cd-b6fc-691bd77672c6">
+      <Terms xmlns="http://schemas.microsoft.com/office/infopath/2007/PartnerControls"/>
+    </lcf76f155ced4ddcb4097134ff3c332f>
+  </documentManagement>
+</p:properties>
+</file>
+
+<file path=customXml/item2.xml><?xml version="1.0" encoding="utf-8"?>
+<?mso-contentType ?>
+<FormTemplates xmlns="http://schemas.microsoft.com/sharepoint/v3/contenttype/forms">
+  <Display>DocumentLibraryForm</Display>
+  <Edit>DocumentLibraryForm</Edit>
+  <New>DocumentLibraryForm</New>
+</FormTemplates>
+</file>
+
+<file path=customXml/item3.xml><?xml version="1.0" encoding="utf-8"?>
 <ct:contentTypeSchema xmlns:ct="http://schemas.microsoft.com/office/2006/metadata/contentType" xmlns:ma="http://schemas.microsoft.com/office/2006/metadata/properties/metaAttributes" ct:_="" ma:_="" ma:contentTypeName="Documento" ma:contentTypeID="0x010100B8FA822B18A0634FB7342CF29752587A" ma:contentTypeVersion="13" ma:contentTypeDescription="Creare un nuovo documento." ma:contentTypeScope="" ma:versionID="5c5a1a1f66437ceed8e2102d49525b77">
   <xsd:schema xmlns:xsd="http://www.w3.org/2001/XMLSchema" xmlns:xs="http://www.w3.org/2001/XMLSchema" xmlns:p="http://schemas.microsoft.com/office/2006/metadata/properties" xmlns:ns2="3bd0d43f-5e5b-43cd-b6fc-691bd77672c6" xmlns:ns3="e9b5433c-2372-4cb7-8bab-09518096b29b" targetNamespace="http://schemas.microsoft.com/office/2006/metadata/properties" ma:root="true" ma:fieldsID="79bbaae61552c66980d55f32a6cab4b6" ns2:_="" ns3:_="">
     <xsd:import namespace="3bd0d43f-5e5b-43cd-b6fc-691bd77672c6"/>
@@ -41821,34 +41050,46 @@
 </ct:contentTypeSchema>
 </file>
 
-<file path=customXml/item2.xml><?xml version="1.0" encoding="utf-8"?>
-<?mso-contentType ?>
-<FormTemplates xmlns="http://schemas.microsoft.com/sharepoint/v3/contenttype/forms">
-  <Display>DocumentLibraryForm</Display>
-  <Edit>DocumentLibraryForm</Edit>
-  <New>DocumentLibraryForm</New>
-</FormTemplates>
-</file>
-
-<file path=customXml/item3.xml><?xml version="1.0" encoding="utf-8"?>
-<p:properties xmlns:p="http://schemas.microsoft.com/office/2006/metadata/properties" xmlns:xsi="http://www.w3.org/2001/XMLSchema-instance" xmlns:pc="http://schemas.microsoft.com/office/infopath/2007/PartnerControls">
-  <documentManagement>
-    <TaxCatchAll xmlns="e9b5433c-2372-4cb7-8bab-09518096b29b" xsi:nil="true"/>
-    <lcf76f155ced4ddcb4097134ff3c332f xmlns="3bd0d43f-5e5b-43cd-b6fc-691bd77672c6">
-      <Terms xmlns="http://schemas.microsoft.com/office/infopath/2007/PartnerControls"/>
-    </lcf76f155ced4ddcb4097134ff3c332f>
-  </documentManagement>
-</p:properties>
-</file>
-
 <file path=customXml/itemProps1.xml><?xml version="1.0" encoding="utf-8"?>
-<ds:datastoreItem xmlns:ds="http://schemas.openxmlformats.org/officeDocument/2006/customXml" ds:itemID="{7CBAEB8B-257A-4542-BBC4-7AEAAEEB667B}"/>
+<ds:datastoreItem xmlns:ds="http://schemas.openxmlformats.org/officeDocument/2006/customXml" ds:itemID="{93D79986-1EC9-4377-8170-A0618606B19E}">
+  <ds:schemaRefs>
+    <ds:schemaRef ds:uri="http://www.w3.org/XML/1998/namespace"/>
+    <ds:schemaRef ds:uri="http://schemas.openxmlformats.org/package/2006/metadata/core-properties"/>
+    <ds:schemaRef ds:uri="e9b5433c-2372-4cb7-8bab-09518096b29b"/>
+    <ds:schemaRef ds:uri="http://purl.org/dc/terms/"/>
+    <ds:schemaRef ds:uri="http://purl.org/dc/dcmitype/"/>
+    <ds:schemaRef ds:uri="http://schemas.microsoft.com/office/2006/metadata/properties"/>
+    <ds:schemaRef ds:uri="http://purl.org/dc/elements/1.1/"/>
+    <ds:schemaRef ds:uri="http://schemas.microsoft.com/office/2006/documentManagement/types"/>
+    <ds:schemaRef ds:uri="http://schemas.microsoft.com/office/infopath/2007/PartnerControls"/>
+    <ds:schemaRef ds:uri="3bd0d43f-5e5b-43cd-b6fc-691bd77672c6"/>
+  </ds:schemaRefs>
+</ds:datastoreItem>
 </file>
 
 <file path=customXml/itemProps2.xml><?xml version="1.0" encoding="utf-8"?>
-<ds:datastoreItem xmlns:ds="http://schemas.openxmlformats.org/officeDocument/2006/customXml" ds:itemID="{8B33E020-D3E2-4BE8-A440-834CD22BCCC2}"/>
+<ds:datastoreItem xmlns:ds="http://schemas.openxmlformats.org/officeDocument/2006/customXml" ds:itemID="{8B33E020-D3E2-4BE8-A440-834CD22BCCC2}">
+  <ds:schemaRefs>
+    <ds:schemaRef ds:uri="http://schemas.microsoft.com/sharepoint/v3/contenttype/forms"/>
+  </ds:schemaRefs>
+</ds:datastoreItem>
 </file>
 
 <file path=customXml/itemProps3.xml><?xml version="1.0" encoding="utf-8"?>
-<ds:datastoreItem xmlns:ds="http://schemas.openxmlformats.org/officeDocument/2006/customXml" ds:itemID="{93D79986-1EC9-4377-8170-A0618606B19E}"/>
+<ds:datastoreItem xmlns:ds="http://schemas.openxmlformats.org/officeDocument/2006/customXml" ds:itemID="{7CBAEB8B-257A-4542-BBC4-7AEAAEEB667B}">
+  <ds:schemaRefs>
+    <ds:schemaRef ds:uri="http://schemas.microsoft.com/office/2006/metadata/contentType"/>
+    <ds:schemaRef ds:uri="http://schemas.microsoft.com/office/2006/metadata/properties/metaAttributes"/>
+    <ds:schemaRef ds:uri="http://www.w3.org/2001/XMLSchema"/>
+    <ds:schemaRef ds:uri="http://schemas.microsoft.com/office/2006/metadata/properties"/>
+    <ds:schemaRef ds:uri="3bd0d43f-5e5b-43cd-b6fc-691bd77672c6"/>
+    <ds:schemaRef ds:uri="e9b5433c-2372-4cb7-8bab-09518096b29b"/>
+    <ds:schemaRef ds:uri="http://schemas.microsoft.com/office/2006/documentManagement/types"/>
+    <ds:schemaRef ds:uri="http://schemas.microsoft.com/office/infopath/2007/PartnerControls"/>
+    <ds:schemaRef ds:uri="http://schemas.openxmlformats.org/package/2006/metadata/core-properties"/>
+    <ds:schemaRef ds:uri="http://purl.org/dc/elements/1.1/"/>
+    <ds:schemaRef ds:uri="http://purl.org/dc/terms/"/>
+    <ds:schemaRef ds:uri="http://schemas.microsoft.com/internal/obd"/>
+  </ds:schemaRefs>
+</ds:datastoreItem>
 </file>
</xml_diff>